<commit_message>
working with nlp section, first part of the course
</commit_message>
<xml_diff>
--- a/20242-NLP-LLM/lecture notes/Part 3 - Introduction to Large Lanuage Models/Part 2 Introduction to Large Langauge Models.pptx
+++ b/20242-NLP-LLM/lecture notes/Part 3 - Introduction to Large Lanuage Models/Part 2 Introduction to Large Langauge Models.pptx
@@ -5,26 +5,28 @@
     <p:sldMasterId id="2147483648" r:id="rId1"/>
   </p:sldMasterIdLst>
   <p:notesMasterIdLst>
-    <p:notesMasterId r:id="rId19"/>
+    <p:notesMasterId r:id="rId21"/>
   </p:notesMasterIdLst>
   <p:sldIdLst>
     <p:sldId id="455" r:id="rId2"/>
-    <p:sldId id="456" r:id="rId3"/>
-    <p:sldId id="457" r:id="rId4"/>
-    <p:sldId id="458" r:id="rId5"/>
-    <p:sldId id="459" r:id="rId6"/>
-    <p:sldId id="460" r:id="rId7"/>
-    <p:sldId id="462" r:id="rId8"/>
-    <p:sldId id="463" r:id="rId9"/>
-    <p:sldId id="464" r:id="rId10"/>
-    <p:sldId id="465" r:id="rId11"/>
-    <p:sldId id="466" r:id="rId12"/>
-    <p:sldId id="467" r:id="rId13"/>
-    <p:sldId id="468" r:id="rId14"/>
-    <p:sldId id="469" r:id="rId15"/>
-    <p:sldId id="470" r:id="rId16"/>
-    <p:sldId id="471" r:id="rId17"/>
-    <p:sldId id="461" r:id="rId18"/>
+    <p:sldId id="474" r:id="rId3"/>
+    <p:sldId id="473" r:id="rId4"/>
+    <p:sldId id="456" r:id="rId5"/>
+    <p:sldId id="457" r:id="rId6"/>
+    <p:sldId id="458" r:id="rId7"/>
+    <p:sldId id="459" r:id="rId8"/>
+    <p:sldId id="460" r:id="rId9"/>
+    <p:sldId id="462" r:id="rId10"/>
+    <p:sldId id="463" r:id="rId11"/>
+    <p:sldId id="464" r:id="rId12"/>
+    <p:sldId id="465" r:id="rId13"/>
+    <p:sldId id="466" r:id="rId14"/>
+    <p:sldId id="467" r:id="rId15"/>
+    <p:sldId id="468" r:id="rId16"/>
+    <p:sldId id="469" r:id="rId17"/>
+    <p:sldId id="470" r:id="rId18"/>
+    <p:sldId id="471" r:id="rId19"/>
+    <p:sldId id="461" r:id="rId20"/>
   </p:sldIdLst>
   <p:sldSz cx="12192000" cy="6858000"/>
   <p:notesSz cx="6858000" cy="9144000"/>
@@ -140,7 +142,7 @@
 <file path=ppt/revisionInfo.xml><?xml version="1.0" encoding="utf-8"?>
 <p1510:revInfo xmlns:a="http://schemas.openxmlformats.org/drawingml/2006/main" xmlns:r="http://schemas.openxmlformats.org/officeDocument/2006/relationships" xmlns:p1510="http://schemas.microsoft.com/office/powerpoint/2015/10/main">
   <p1510:revLst>
-    <p1510:client id="{66E75AB1-FCE8-0FCD-8995-E220AF9681CC}" v="351" dt="2025-03-15T07:27:28.249"/>
+    <p1510:client id="{4B0C216D-0431-4C08-83EB-B615D906D932}" v="16" dt="2025-03-18T02:16:29.343"/>
   </p1510:revLst>
 </p1510:revInfo>
 </file>
@@ -148,844 +150,157 @@
 <file path=ppt/changesInfos/changesInfo1.xml><?xml version="1.0" encoding="utf-8"?>
 <pc:chgInfo xmlns:a="http://schemas.openxmlformats.org/drawingml/2006/main" xmlns:r="http://schemas.openxmlformats.org/officeDocument/2006/relationships" xmlns:ac="http://schemas.microsoft.com/office/drawing/2013/main/command" xmlns:pc="http://schemas.microsoft.com/office/powerpoint/2013/main/command">
   <pc:docChgLst>
-    <pc:chgData name="Mohammed Fasha" userId="cc64f42d-a1a6-4f08-b97b-0c37f877119f" providerId="ADAL" clId="{BECD4A7F-C1AF-4585-8C31-FE7D4FE3ED16}"/>
-    <pc:docChg chg="undo redo custSel addSld delSld modSld sldOrd">
-      <pc:chgData name="Mohammed Fasha" userId="cc64f42d-a1a6-4f08-b97b-0c37f877119f" providerId="ADAL" clId="{BECD4A7F-C1AF-4585-8C31-FE7D4FE3ED16}" dt="2025-01-05T16:36:16.605" v="1945" actId="1076"/>
+    <pc:chgData name="Mohammed Fasha" userId="cc64f42d-a1a6-4f08-b97b-0c37f877119f" providerId="ADAL" clId="{5980B3BB-4EB6-4E37-92BF-3A2A8F4B2C7A}"/>
+    <pc:docChg chg="custSel modSld">
+      <pc:chgData name="Mohammed Fasha" userId="cc64f42d-a1a6-4f08-b97b-0c37f877119f" providerId="ADAL" clId="{5980B3BB-4EB6-4E37-92BF-3A2A8F4B2C7A}" dt="2024-10-15T02:28:13.535" v="0" actId="478"/>
       <pc:docMkLst>
         <pc:docMk/>
       </pc:docMkLst>
-      <pc:sldChg chg="modSp mod">
-        <pc:chgData name="Mohammed Fasha" userId="cc64f42d-a1a6-4f08-b97b-0c37f877119f" providerId="ADAL" clId="{BECD4A7F-C1AF-4585-8C31-FE7D4FE3ED16}" dt="2024-12-30T18:47:27.683" v="988" actId="20577"/>
-        <pc:sldMkLst>
-          <pc:docMk/>
-          <pc:sldMk cId="2281221656" sldId="527"/>
-        </pc:sldMkLst>
-        <pc:spChg chg="mod">
-          <ac:chgData name="Mohammed Fasha" userId="cc64f42d-a1a6-4f08-b97b-0c37f877119f" providerId="ADAL" clId="{BECD4A7F-C1AF-4585-8C31-FE7D4FE3ED16}" dt="2024-12-30T18:47:27.683" v="988" actId="20577"/>
+      <pc:sldChg chg="delSp mod">
+        <pc:chgData name="Mohammed Fasha" userId="cc64f42d-a1a6-4f08-b97b-0c37f877119f" providerId="ADAL" clId="{5980B3BB-4EB6-4E37-92BF-3A2A8F4B2C7A}" dt="2024-10-15T02:28:13.535" v="0" actId="478"/>
+        <pc:sldMkLst>
+          <pc:docMk/>
+          <pc:sldMk cId="2297456757" sldId="483"/>
+        </pc:sldMkLst>
+      </pc:sldChg>
+    </pc:docChg>
+  </pc:docChgLst>
+  <pc:docChgLst>
+    <pc:chgData name="Mohammed Fasha" userId="cc64f42d-a1a6-4f08-b97b-0c37f877119f" providerId="ADAL" clId="{4B0C216D-0431-4C08-83EB-B615D906D932}"/>
+    <pc:docChg chg="custSel addSld delSld modSld sldOrd">
+      <pc:chgData name="Mohammed Fasha" userId="cc64f42d-a1a6-4f08-b97b-0c37f877119f" providerId="ADAL" clId="{4B0C216D-0431-4C08-83EB-B615D906D932}" dt="2025-03-18T02:16:41.167" v="152" actId="20577"/>
+      <pc:docMkLst>
+        <pc:docMk/>
+      </pc:docMkLst>
+      <pc:sldChg chg="ord">
+        <pc:chgData name="Mohammed Fasha" userId="cc64f42d-a1a6-4f08-b97b-0c37f877119f" providerId="ADAL" clId="{4B0C216D-0431-4C08-83EB-B615D906D932}" dt="2025-03-18T02:15:01.379" v="67"/>
+        <pc:sldMkLst>
+          <pc:docMk/>
+          <pc:sldMk cId="2282942957" sldId="456"/>
+        </pc:sldMkLst>
+      </pc:sldChg>
+      <pc:sldChg chg="addSp delSp modSp new del mod modClrScheme chgLayout">
+        <pc:chgData name="Mohammed Fasha" userId="cc64f42d-a1a6-4f08-b97b-0c37f877119f" providerId="ADAL" clId="{4B0C216D-0431-4C08-83EB-B615D906D932}" dt="2025-03-18T02:14:19.984" v="50" actId="2696"/>
+        <pc:sldMkLst>
+          <pc:docMk/>
+          <pc:sldMk cId="3499033775" sldId="472"/>
+        </pc:sldMkLst>
+        <pc:spChg chg="del">
+          <ac:chgData name="Mohammed Fasha" userId="cc64f42d-a1a6-4f08-b97b-0c37f877119f" providerId="ADAL" clId="{4B0C216D-0431-4C08-83EB-B615D906D932}" dt="2025-03-18T02:10:37.371" v="17" actId="700"/>
           <ac:spMkLst>
             <pc:docMk/>
-            <pc:sldMk cId="2281221656" sldId="527"/>
-            <ac:spMk id="3" creationId="{36C8F9DB-7550-D96E-B8E4-26F0B46EDE0D}"/>
+            <pc:sldMk cId="3499033775" sldId="472"/>
+            <ac:spMk id="2" creationId="{AB7BAFA6-DB51-46E2-3B2C-880150CF6E9E}"/>
           </ac:spMkLst>
         </pc:spChg>
-      </pc:sldChg>
-      <pc:sldChg chg="modSp mod">
-        <pc:chgData name="Mohammed Fasha" userId="cc64f42d-a1a6-4f08-b97b-0c37f877119f" providerId="ADAL" clId="{BECD4A7F-C1AF-4585-8C31-FE7D4FE3ED16}" dt="2024-12-27T13:59:26.893" v="366" actId="20577"/>
-        <pc:sldMkLst>
-          <pc:docMk/>
-          <pc:sldMk cId="3474268344" sldId="596"/>
-        </pc:sldMkLst>
-        <pc:spChg chg="mod">
-          <ac:chgData name="Mohammed Fasha" userId="cc64f42d-a1a6-4f08-b97b-0c37f877119f" providerId="ADAL" clId="{BECD4A7F-C1AF-4585-8C31-FE7D4FE3ED16}" dt="2024-12-27T13:59:26.893" v="366" actId="20577"/>
+        <pc:spChg chg="del">
+          <ac:chgData name="Mohammed Fasha" userId="cc64f42d-a1a6-4f08-b97b-0c37f877119f" providerId="ADAL" clId="{4B0C216D-0431-4C08-83EB-B615D906D932}" dt="2025-03-18T02:09:22.665" v="1"/>
           <ac:spMkLst>
             <pc:docMk/>
-            <pc:sldMk cId="3474268344" sldId="596"/>
-            <ac:spMk id="3" creationId="{835E72A7-391A-F018-EF29-2D19FF7F7EA9}"/>
+            <pc:sldMk cId="3499033775" sldId="472"/>
+            <ac:spMk id="3" creationId="{DD372FA3-C25C-CAD2-0432-3181C995C6E8}"/>
           </ac:spMkLst>
         </pc:spChg>
-      </pc:sldChg>
-      <pc:sldChg chg="modSp mod">
-        <pc:chgData name="Mohammed Fasha" userId="cc64f42d-a1a6-4f08-b97b-0c37f877119f" providerId="ADAL" clId="{BECD4A7F-C1AF-4585-8C31-FE7D4FE3ED16}" dt="2024-12-30T18:44:34.649" v="884" actId="20577"/>
-        <pc:sldMkLst>
-          <pc:docMk/>
-          <pc:sldMk cId="916802035" sldId="651"/>
-        </pc:sldMkLst>
-        <pc:spChg chg="mod">
-          <ac:chgData name="Mohammed Fasha" userId="cc64f42d-a1a6-4f08-b97b-0c37f877119f" providerId="ADAL" clId="{BECD4A7F-C1AF-4585-8C31-FE7D4FE3ED16}" dt="2024-12-30T18:44:10.836" v="878" actId="14100"/>
+        <pc:spChg chg="add mod">
+          <ac:chgData name="Mohammed Fasha" userId="cc64f42d-a1a6-4f08-b97b-0c37f877119f" providerId="ADAL" clId="{4B0C216D-0431-4C08-83EB-B615D906D932}" dt="2025-03-18T02:10:48.549" v="21" actId="1076"/>
           <ac:spMkLst>
             <pc:docMk/>
-            <pc:sldMk cId="916802035" sldId="651"/>
-            <ac:spMk id="2" creationId="{20E23A9E-CFA6-8DB8-8A86-326FDC984276}"/>
+            <pc:sldMk cId="3499033775" sldId="472"/>
+            <ac:spMk id="5" creationId="{C0CCA68B-FBDC-D4D4-D7A8-6F0C17215B1C}"/>
+          </ac:spMkLst>
+        </pc:spChg>
+        <pc:spChg chg="add">
+          <ac:chgData name="Mohammed Fasha" userId="cc64f42d-a1a6-4f08-b97b-0c37f877119f" providerId="ADAL" clId="{4B0C216D-0431-4C08-83EB-B615D906D932}" dt="2025-03-18T02:12:39.523" v="22"/>
+          <ac:spMkLst>
+            <pc:docMk/>
+            <pc:sldMk cId="3499033775" sldId="472"/>
+            <ac:spMk id="6" creationId="{F5E73FDA-2144-84F7-2ACD-C11FA3ED9FE4}"/>
+          </ac:spMkLst>
+        </pc:spChg>
+        <pc:spChg chg="add mod">
+          <ac:chgData name="Mohammed Fasha" userId="cc64f42d-a1a6-4f08-b97b-0c37f877119f" providerId="ADAL" clId="{4B0C216D-0431-4C08-83EB-B615D906D932}" dt="2025-03-18T02:13:33.095" v="32" actId="1076"/>
+          <ac:spMkLst>
+            <pc:docMk/>
+            <pc:sldMk cId="3499033775" sldId="472"/>
+            <ac:spMk id="8" creationId="{40366A84-7CB3-FF9E-E536-9EDD1F635741}"/>
+          </ac:spMkLst>
+        </pc:spChg>
+        <pc:spChg chg="add">
+          <ac:chgData name="Mohammed Fasha" userId="cc64f42d-a1a6-4f08-b97b-0c37f877119f" providerId="ADAL" clId="{4B0C216D-0431-4C08-83EB-B615D906D932}" dt="2025-03-18T02:12:56.180" v="26"/>
+          <ac:spMkLst>
+            <pc:docMk/>
+            <pc:sldMk cId="3499033775" sldId="472"/>
+            <ac:spMk id="9" creationId="{5C21B3EC-1E90-8F97-CC61-EE703464D5FF}"/>
+          </ac:spMkLst>
+        </pc:spChg>
+        <pc:picChg chg="add del mod ord">
+          <ac:chgData name="Mohammed Fasha" userId="cc64f42d-a1a6-4f08-b97b-0c37f877119f" providerId="ADAL" clId="{4B0C216D-0431-4C08-83EB-B615D906D932}" dt="2025-03-18T02:14:09.652" v="47" actId="21"/>
+          <ac:picMkLst>
+            <pc:docMk/>
+            <pc:sldMk cId="3499033775" sldId="472"/>
+            <ac:picMk id="2050" creationId="{804C5AFC-2370-82B7-38A0-7C05C6C3769B}"/>
+          </ac:picMkLst>
+        </pc:picChg>
+      </pc:sldChg>
+      <pc:sldChg chg="addSp delSp modSp new mod ord modClrScheme chgLayout">
+        <pc:chgData name="Mohammed Fasha" userId="cc64f42d-a1a6-4f08-b97b-0c37f877119f" providerId="ADAL" clId="{4B0C216D-0431-4C08-83EB-B615D906D932}" dt="2025-03-18T02:16:41.167" v="152" actId="20577"/>
+        <pc:sldMkLst>
+          <pc:docMk/>
+          <pc:sldMk cId="3385747305" sldId="473"/>
+        </pc:sldMkLst>
+        <pc:spChg chg="add del mod">
+          <ac:chgData name="Mohammed Fasha" userId="cc64f42d-a1a6-4f08-b97b-0c37f877119f" providerId="ADAL" clId="{4B0C216D-0431-4C08-83EB-B615D906D932}" dt="2025-03-18T02:14:15.631" v="49" actId="700"/>
+          <ac:spMkLst>
+            <pc:docMk/>
+            <pc:sldMk cId="3385747305" sldId="473"/>
+            <ac:spMk id="2" creationId="{BF2B1AA0-2F67-FD33-DF5C-FACDA7455A75}"/>
+          </ac:spMkLst>
+        </pc:spChg>
+        <pc:spChg chg="add mod ord">
+          <ac:chgData name="Mohammed Fasha" userId="cc64f42d-a1a6-4f08-b97b-0c37f877119f" providerId="ADAL" clId="{4B0C216D-0431-4C08-83EB-B615D906D932}" dt="2025-03-18T02:16:23.541" v="106" actId="27636"/>
+          <ac:spMkLst>
+            <pc:docMk/>
+            <pc:sldMk cId="3385747305" sldId="473"/>
+            <ac:spMk id="3" creationId="{A41D86F4-2CDE-CB20-3664-2556C0F84D47}"/>
+          </ac:spMkLst>
+        </pc:spChg>
+        <pc:spChg chg="add mod ord">
+          <ac:chgData name="Mohammed Fasha" userId="cc64f42d-a1a6-4f08-b97b-0c37f877119f" providerId="ADAL" clId="{4B0C216D-0431-4C08-83EB-B615D906D932}" dt="2025-03-18T02:16:41.167" v="152" actId="20577"/>
+          <ac:spMkLst>
+            <pc:docMk/>
+            <pc:sldMk cId="3385747305" sldId="473"/>
+            <ac:spMk id="4" creationId="{0B0DDC81-A74C-861A-3FF8-DEFF3BE23C27}"/>
+          </ac:spMkLst>
+        </pc:spChg>
+        <pc:picChg chg="add mod">
+          <ac:chgData name="Mohammed Fasha" userId="cc64f42d-a1a6-4f08-b97b-0c37f877119f" providerId="ADAL" clId="{4B0C216D-0431-4C08-83EB-B615D906D932}" dt="2025-03-18T02:16:29.343" v="108" actId="1076"/>
+          <ac:picMkLst>
+            <pc:docMk/>
+            <pc:sldMk cId="3385747305" sldId="473"/>
+            <ac:picMk id="2050" creationId="{804C5AFC-2370-82B7-38A0-7C05C6C3769B}"/>
+          </ac:picMkLst>
+        </pc:picChg>
+      </pc:sldChg>
+      <pc:sldChg chg="modSp new mod">
+        <pc:chgData name="Mohammed Fasha" userId="cc64f42d-a1a6-4f08-b97b-0c37f877119f" providerId="ADAL" clId="{4B0C216D-0431-4C08-83EB-B615D906D932}" dt="2025-03-18T02:15:56.699" v="100"/>
+        <pc:sldMkLst>
+          <pc:docMk/>
+          <pc:sldMk cId="1939766790" sldId="474"/>
+        </pc:sldMkLst>
+        <pc:spChg chg="mod">
+          <ac:chgData name="Mohammed Fasha" userId="cc64f42d-a1a6-4f08-b97b-0c37f877119f" providerId="ADAL" clId="{4B0C216D-0431-4C08-83EB-B615D906D932}" dt="2025-03-18T02:15:19.652" v="99" actId="20577"/>
+          <ac:spMkLst>
+            <pc:docMk/>
+            <pc:sldMk cId="1939766790" sldId="474"/>
+            <ac:spMk id="2" creationId="{43A12493-75ED-FFA9-A1BD-A09AEC623815}"/>
           </ac:spMkLst>
         </pc:spChg>
         <pc:spChg chg="mod">
-          <ac:chgData name="Mohammed Fasha" userId="cc64f42d-a1a6-4f08-b97b-0c37f877119f" providerId="ADAL" clId="{BECD4A7F-C1AF-4585-8C31-FE7D4FE3ED16}" dt="2024-12-30T18:44:34.649" v="884" actId="20577"/>
+          <ac:chgData name="Mohammed Fasha" userId="cc64f42d-a1a6-4f08-b97b-0c37f877119f" providerId="ADAL" clId="{4B0C216D-0431-4C08-83EB-B615D906D932}" dt="2025-03-18T02:15:56.699" v="100"/>
           <ac:spMkLst>
             <pc:docMk/>
-            <pc:sldMk cId="916802035" sldId="651"/>
-            <ac:spMk id="3" creationId="{4A45A649-6990-06EF-697E-90241C4765BF}"/>
-          </ac:spMkLst>
-        </pc:spChg>
-        <pc:picChg chg="mod">
-          <ac:chgData name="Mohammed Fasha" userId="cc64f42d-a1a6-4f08-b97b-0c37f877119f" providerId="ADAL" clId="{BECD4A7F-C1AF-4585-8C31-FE7D4FE3ED16}" dt="2024-12-30T18:43:43.192" v="874" actId="1076"/>
-          <ac:picMkLst>
-            <pc:docMk/>
-            <pc:sldMk cId="916802035" sldId="651"/>
-            <ac:picMk id="5" creationId="{067BF3A6-7F1B-A426-CBBE-B3026AD3604D}"/>
-          </ac:picMkLst>
-        </pc:picChg>
-      </pc:sldChg>
-      <pc:sldChg chg="del">
-        <pc:chgData name="Mohammed Fasha" userId="cc64f42d-a1a6-4f08-b97b-0c37f877119f" providerId="ADAL" clId="{BECD4A7F-C1AF-4585-8C31-FE7D4FE3ED16}" dt="2025-01-05T14:42:38.675" v="989" actId="2696"/>
-        <pc:sldMkLst>
-          <pc:docMk/>
-          <pc:sldMk cId="426516858" sldId="662"/>
-        </pc:sldMkLst>
-      </pc:sldChg>
-      <pc:sldChg chg="modSp add del mod">
-        <pc:chgData name="Mohammed Fasha" userId="cc64f42d-a1a6-4f08-b97b-0c37f877119f" providerId="ADAL" clId="{BECD4A7F-C1AF-4585-8C31-FE7D4FE3ED16}" dt="2025-01-05T16:34:59.233" v="1926" actId="20577"/>
-        <pc:sldMkLst>
-          <pc:docMk/>
-          <pc:sldMk cId="691538069" sldId="662"/>
-        </pc:sldMkLst>
-        <pc:spChg chg="mod">
-          <ac:chgData name="Mohammed Fasha" userId="cc64f42d-a1a6-4f08-b97b-0c37f877119f" providerId="ADAL" clId="{BECD4A7F-C1AF-4585-8C31-FE7D4FE3ED16}" dt="2025-01-05T16:34:51.876" v="1919" actId="20577"/>
-          <ac:spMkLst>
-            <pc:docMk/>
-            <pc:sldMk cId="691538069" sldId="662"/>
-            <ac:spMk id="4" creationId="{614D3388-9637-C201-21C4-6668D7194B7A}"/>
-          </ac:spMkLst>
-        </pc:spChg>
-        <pc:spChg chg="mod">
-          <ac:chgData name="Mohammed Fasha" userId="cc64f42d-a1a6-4f08-b97b-0c37f877119f" providerId="ADAL" clId="{BECD4A7F-C1AF-4585-8C31-FE7D4FE3ED16}" dt="2025-01-05T16:34:59.233" v="1926" actId="20577"/>
-          <ac:spMkLst>
-            <pc:docMk/>
-            <pc:sldMk cId="691538069" sldId="662"/>
-            <ac:spMk id="5" creationId="{9B787316-1F56-3550-8870-1878E64917AD}"/>
-          </ac:spMkLst>
-        </pc:spChg>
-      </pc:sldChg>
-      <pc:sldChg chg="del">
-        <pc:chgData name="Mohammed Fasha" userId="cc64f42d-a1a6-4f08-b97b-0c37f877119f" providerId="ADAL" clId="{BECD4A7F-C1AF-4585-8C31-FE7D4FE3ED16}" dt="2025-01-05T14:42:38.675" v="989" actId="2696"/>
-        <pc:sldMkLst>
-          <pc:docMk/>
-          <pc:sldMk cId="895445062" sldId="663"/>
-        </pc:sldMkLst>
-      </pc:sldChg>
-      <pc:sldChg chg="add del">
-        <pc:chgData name="Mohammed Fasha" userId="cc64f42d-a1a6-4f08-b97b-0c37f877119f" providerId="ADAL" clId="{BECD4A7F-C1AF-4585-8C31-FE7D4FE3ED16}" dt="2025-01-05T14:43:16.100" v="993" actId="2696"/>
-        <pc:sldMkLst>
-          <pc:docMk/>
-          <pc:sldMk cId="3980180774" sldId="663"/>
-        </pc:sldMkLst>
-      </pc:sldChg>
-      <pc:sldChg chg="add del">
-        <pc:chgData name="Mohammed Fasha" userId="cc64f42d-a1a6-4f08-b97b-0c37f877119f" providerId="ADAL" clId="{BECD4A7F-C1AF-4585-8C31-FE7D4FE3ED16}" dt="2025-01-05T14:43:16.100" v="993" actId="2696"/>
-        <pc:sldMkLst>
-          <pc:docMk/>
-          <pc:sldMk cId="1728680596" sldId="664"/>
-        </pc:sldMkLst>
-      </pc:sldChg>
-      <pc:sldChg chg="del">
-        <pc:chgData name="Mohammed Fasha" userId="cc64f42d-a1a6-4f08-b97b-0c37f877119f" providerId="ADAL" clId="{BECD4A7F-C1AF-4585-8C31-FE7D4FE3ED16}" dt="2025-01-05T14:42:38.675" v="989" actId="2696"/>
-        <pc:sldMkLst>
-          <pc:docMk/>
-          <pc:sldMk cId="3900588277" sldId="664"/>
-        </pc:sldMkLst>
-      </pc:sldChg>
-      <pc:sldChg chg="del">
-        <pc:chgData name="Mohammed Fasha" userId="cc64f42d-a1a6-4f08-b97b-0c37f877119f" providerId="ADAL" clId="{BECD4A7F-C1AF-4585-8C31-FE7D4FE3ED16}" dt="2025-01-05T14:42:38.675" v="989" actId="2696"/>
-        <pc:sldMkLst>
-          <pc:docMk/>
-          <pc:sldMk cId="123002105" sldId="665"/>
-        </pc:sldMkLst>
-      </pc:sldChg>
-      <pc:sldChg chg="modSp add del mod">
-        <pc:chgData name="Mohammed Fasha" userId="cc64f42d-a1a6-4f08-b97b-0c37f877119f" providerId="ADAL" clId="{BECD4A7F-C1AF-4585-8C31-FE7D4FE3ED16}" dt="2025-01-05T15:05:12.729" v="1226" actId="21"/>
-        <pc:sldMkLst>
-          <pc:docMk/>
-          <pc:sldMk cId="148099094" sldId="665"/>
-        </pc:sldMkLst>
-        <pc:spChg chg="mod">
-          <ac:chgData name="Mohammed Fasha" userId="cc64f42d-a1a6-4f08-b97b-0c37f877119f" providerId="ADAL" clId="{BECD4A7F-C1AF-4585-8C31-FE7D4FE3ED16}" dt="2025-01-05T15:05:12.729" v="1226" actId="21"/>
-          <ac:spMkLst>
-            <pc:docMk/>
-            <pc:sldMk cId="148099094" sldId="665"/>
-            <ac:spMk id="3" creationId="{DDB8F6FE-FF12-0BA5-D224-71F068E4DF88}"/>
-          </ac:spMkLst>
-        </pc:spChg>
-      </pc:sldChg>
-      <pc:sldChg chg="del">
-        <pc:chgData name="Mohammed Fasha" userId="cc64f42d-a1a6-4f08-b97b-0c37f877119f" providerId="ADAL" clId="{BECD4A7F-C1AF-4585-8C31-FE7D4FE3ED16}" dt="2025-01-05T14:42:38.675" v="989" actId="2696"/>
-        <pc:sldMkLst>
-          <pc:docMk/>
-          <pc:sldMk cId="659863378" sldId="676"/>
-        </pc:sldMkLst>
-      </pc:sldChg>
-      <pc:sldChg chg="modSp add del mod">
-        <pc:chgData name="Mohammed Fasha" userId="cc64f42d-a1a6-4f08-b97b-0c37f877119f" providerId="ADAL" clId="{BECD4A7F-C1AF-4585-8C31-FE7D4FE3ED16}" dt="2025-01-05T14:55:27.595" v="1130" actId="255"/>
-        <pc:sldMkLst>
-          <pc:docMk/>
-          <pc:sldMk cId="1577854815" sldId="676"/>
-        </pc:sldMkLst>
-        <pc:spChg chg="mod">
-          <ac:chgData name="Mohammed Fasha" userId="cc64f42d-a1a6-4f08-b97b-0c37f877119f" providerId="ADAL" clId="{BECD4A7F-C1AF-4585-8C31-FE7D4FE3ED16}" dt="2025-01-05T14:55:27.595" v="1130" actId="255"/>
-          <ac:spMkLst>
-            <pc:docMk/>
-            <pc:sldMk cId="1577854815" sldId="676"/>
-            <ac:spMk id="3" creationId="{E88ABCC0-74F9-FC39-07D3-08B330832EDD}"/>
-          </ac:spMkLst>
-        </pc:spChg>
-      </pc:sldChg>
-      <pc:sldChg chg="modSp add del mod">
-        <pc:chgData name="Mohammed Fasha" userId="cc64f42d-a1a6-4f08-b97b-0c37f877119f" providerId="ADAL" clId="{BECD4A7F-C1AF-4585-8C31-FE7D4FE3ED16}" dt="2025-01-05T14:55:43.754" v="1132" actId="1076"/>
-        <pc:sldMkLst>
-          <pc:docMk/>
-          <pc:sldMk cId="139882925" sldId="677"/>
-        </pc:sldMkLst>
-        <pc:picChg chg="mod">
-          <ac:chgData name="Mohammed Fasha" userId="cc64f42d-a1a6-4f08-b97b-0c37f877119f" providerId="ADAL" clId="{BECD4A7F-C1AF-4585-8C31-FE7D4FE3ED16}" dt="2025-01-05T14:55:43.754" v="1132" actId="1076"/>
-          <ac:picMkLst>
-            <pc:docMk/>
-            <pc:sldMk cId="139882925" sldId="677"/>
-            <ac:picMk id="7" creationId="{98586F92-0EDA-112D-2826-05772E5428E5}"/>
-          </ac:picMkLst>
-        </pc:picChg>
-      </pc:sldChg>
-      <pc:sldChg chg="del">
-        <pc:chgData name="Mohammed Fasha" userId="cc64f42d-a1a6-4f08-b97b-0c37f877119f" providerId="ADAL" clId="{BECD4A7F-C1AF-4585-8C31-FE7D4FE3ED16}" dt="2025-01-05T14:42:38.675" v="989" actId="2696"/>
-        <pc:sldMkLst>
-          <pc:docMk/>
-          <pc:sldMk cId="2736863534" sldId="677"/>
-        </pc:sldMkLst>
-      </pc:sldChg>
-      <pc:sldChg chg="add del">
-        <pc:chgData name="Mohammed Fasha" userId="cc64f42d-a1a6-4f08-b97b-0c37f877119f" providerId="ADAL" clId="{BECD4A7F-C1AF-4585-8C31-FE7D4FE3ED16}" dt="2025-01-05T14:43:16.100" v="993" actId="2696"/>
-        <pc:sldMkLst>
-          <pc:docMk/>
-          <pc:sldMk cId="4146654093" sldId="678"/>
-        </pc:sldMkLst>
-      </pc:sldChg>
-      <pc:sldChg chg="del">
-        <pc:chgData name="Mohammed Fasha" userId="cc64f42d-a1a6-4f08-b97b-0c37f877119f" providerId="ADAL" clId="{BECD4A7F-C1AF-4585-8C31-FE7D4FE3ED16}" dt="2025-01-05T14:42:38.675" v="989" actId="2696"/>
-        <pc:sldMkLst>
-          <pc:docMk/>
-          <pc:sldMk cId="4228312762" sldId="678"/>
-        </pc:sldMkLst>
-      </pc:sldChg>
-      <pc:sldChg chg="del">
-        <pc:chgData name="Mohammed Fasha" userId="cc64f42d-a1a6-4f08-b97b-0c37f877119f" providerId="ADAL" clId="{BECD4A7F-C1AF-4585-8C31-FE7D4FE3ED16}" dt="2025-01-05T14:42:38.675" v="989" actId="2696"/>
-        <pc:sldMkLst>
-          <pc:docMk/>
-          <pc:sldMk cId="581717462" sldId="679"/>
-        </pc:sldMkLst>
-      </pc:sldChg>
-      <pc:sldChg chg="addSp delSp modSp add del mod chgLayout">
-        <pc:chgData name="Mohammed Fasha" userId="cc64f42d-a1a6-4f08-b97b-0c37f877119f" providerId="ADAL" clId="{BECD4A7F-C1AF-4585-8C31-FE7D4FE3ED16}" dt="2025-01-05T16:36:16.605" v="1945" actId="1076"/>
-        <pc:sldMkLst>
-          <pc:docMk/>
-          <pc:sldMk cId="3454522070" sldId="679"/>
-        </pc:sldMkLst>
-        <pc:spChg chg="add del mod ord">
-          <ac:chgData name="Mohammed Fasha" userId="cc64f42d-a1a6-4f08-b97b-0c37f877119f" providerId="ADAL" clId="{BECD4A7F-C1AF-4585-8C31-FE7D4FE3ED16}" dt="2025-01-05T16:36:10.278" v="1943" actId="313"/>
-          <ac:spMkLst>
-            <pc:docMk/>
-            <pc:sldMk cId="3454522070" sldId="679"/>
-            <ac:spMk id="2" creationId="{DC1FA89A-FF01-0D0D-2715-B8513C3632F7}"/>
-          </ac:spMkLst>
-        </pc:spChg>
-        <pc:spChg chg="add del mod">
-          <ac:chgData name="Mohammed Fasha" userId="cc64f42d-a1a6-4f08-b97b-0c37f877119f" providerId="ADAL" clId="{BECD4A7F-C1AF-4585-8C31-FE7D4FE3ED16}" dt="2025-01-05T14:45:37.640" v="999"/>
-          <ac:spMkLst>
-            <pc:docMk/>
-            <pc:sldMk cId="3454522070" sldId="679"/>
-            <ac:spMk id="6" creationId="{6C11E174-5A48-F505-7932-CB179EEF47E7}"/>
-          </ac:spMkLst>
-        </pc:spChg>
-        <pc:spChg chg="add del mod">
-          <ac:chgData name="Mohammed Fasha" userId="cc64f42d-a1a6-4f08-b97b-0c37f877119f" providerId="ADAL" clId="{BECD4A7F-C1AF-4585-8C31-FE7D4FE3ED16}" dt="2025-01-05T16:36:07.200" v="1942" actId="478"/>
-          <ac:spMkLst>
-            <pc:docMk/>
-            <pc:sldMk cId="3454522070" sldId="679"/>
-            <ac:spMk id="13" creationId="{2F90C3D9-EAFA-9309-673F-F9FCF86FAD56}"/>
-          </ac:spMkLst>
-        </pc:spChg>
-        <pc:spChg chg="add mod">
-          <ac:chgData name="Mohammed Fasha" userId="cc64f42d-a1a6-4f08-b97b-0c37f877119f" providerId="ADAL" clId="{BECD4A7F-C1AF-4585-8C31-FE7D4FE3ED16}" dt="2025-01-05T16:36:06.153" v="1940" actId="1076"/>
-          <ac:spMkLst>
-            <pc:docMk/>
-            <pc:sldMk cId="3454522070" sldId="679"/>
-            <ac:spMk id="14" creationId="{67F0B3DB-A8D4-D592-3C0B-129549E92C71}"/>
-          </ac:spMkLst>
-        </pc:spChg>
-        <pc:picChg chg="add del mod">
-          <ac:chgData name="Mohammed Fasha" userId="cc64f42d-a1a6-4f08-b97b-0c37f877119f" providerId="ADAL" clId="{BECD4A7F-C1AF-4585-8C31-FE7D4FE3ED16}" dt="2025-01-05T14:47:38.324" v="1021" actId="21"/>
-          <ac:picMkLst>
-            <pc:docMk/>
-            <pc:sldMk cId="3454522070" sldId="679"/>
-            <ac:picMk id="3" creationId="{73F62A98-46BE-B548-A7C6-11FC6C2FEEDD}"/>
-          </ac:picMkLst>
-        </pc:picChg>
-        <pc:picChg chg="del mod">
-          <ac:chgData name="Mohammed Fasha" userId="cc64f42d-a1a6-4f08-b97b-0c37f877119f" providerId="ADAL" clId="{BECD4A7F-C1AF-4585-8C31-FE7D4FE3ED16}" dt="2025-01-05T14:45:34.723" v="998" actId="478"/>
-          <ac:picMkLst>
-            <pc:docMk/>
-            <pc:sldMk cId="3454522070" sldId="679"/>
-            <ac:picMk id="5" creationId="{9053084C-4E1D-96B1-C446-5149D46AE2C8}"/>
-          </ac:picMkLst>
-        </pc:picChg>
-        <pc:picChg chg="add del mod">
-          <ac:chgData name="Mohammed Fasha" userId="cc64f42d-a1a6-4f08-b97b-0c37f877119f" providerId="ADAL" clId="{BECD4A7F-C1AF-4585-8C31-FE7D4FE3ED16}" dt="2025-01-05T14:46:33.011" v="1012" actId="22"/>
-          <ac:picMkLst>
-            <pc:docMk/>
-            <pc:sldMk cId="3454522070" sldId="679"/>
-            <ac:picMk id="8" creationId="{863B68B7-310F-AA51-0405-5B687241430B}"/>
-          </ac:picMkLst>
-        </pc:picChg>
-        <pc:picChg chg="add del mod ord">
-          <ac:chgData name="Mohammed Fasha" userId="cc64f42d-a1a6-4f08-b97b-0c37f877119f" providerId="ADAL" clId="{BECD4A7F-C1AF-4585-8C31-FE7D4FE3ED16}" dt="2025-01-05T14:48:34.871" v="1032" actId="478"/>
-          <ac:picMkLst>
-            <pc:docMk/>
-            <pc:sldMk cId="3454522070" sldId="679"/>
-            <ac:picMk id="9" creationId="{73F62A98-46BE-B548-A7C6-11FC6C2FEEDD}"/>
-          </ac:picMkLst>
-        </pc:picChg>
-        <pc:picChg chg="add mod ord">
-          <ac:chgData name="Mohammed Fasha" userId="cc64f42d-a1a6-4f08-b97b-0c37f877119f" providerId="ADAL" clId="{BECD4A7F-C1AF-4585-8C31-FE7D4FE3ED16}" dt="2025-01-05T16:36:14.089" v="1944" actId="1076"/>
-          <ac:picMkLst>
-            <pc:docMk/>
-            <pc:sldMk cId="3454522070" sldId="679"/>
-            <ac:picMk id="11" creationId="{62538CCE-0EC2-E549-8085-A8A2AD747E71}"/>
-          </ac:picMkLst>
-        </pc:picChg>
-        <pc:picChg chg="add mod ord">
-          <ac:chgData name="Mohammed Fasha" userId="cc64f42d-a1a6-4f08-b97b-0c37f877119f" providerId="ADAL" clId="{BECD4A7F-C1AF-4585-8C31-FE7D4FE3ED16}" dt="2025-01-05T16:36:16.605" v="1945" actId="1076"/>
-          <ac:picMkLst>
-            <pc:docMk/>
-            <pc:sldMk cId="3454522070" sldId="679"/>
-            <ac:picMk id="1026" creationId="{E5FCBA12-B813-E4BA-B5B4-D671EFBBC8DF}"/>
-          </ac:picMkLst>
-        </pc:picChg>
-      </pc:sldChg>
-      <pc:sldChg chg="add del">
-        <pc:chgData name="Mohammed Fasha" userId="cc64f42d-a1a6-4f08-b97b-0c37f877119f" providerId="ADAL" clId="{BECD4A7F-C1AF-4585-8C31-FE7D4FE3ED16}" dt="2025-01-05T14:43:16.100" v="993" actId="2696"/>
-        <pc:sldMkLst>
-          <pc:docMk/>
-          <pc:sldMk cId="2856814121" sldId="681"/>
-        </pc:sldMkLst>
-      </pc:sldChg>
-      <pc:sldChg chg="del">
-        <pc:chgData name="Mohammed Fasha" userId="cc64f42d-a1a6-4f08-b97b-0c37f877119f" providerId="ADAL" clId="{BECD4A7F-C1AF-4585-8C31-FE7D4FE3ED16}" dt="2025-01-05T14:42:38.675" v="989" actId="2696"/>
-        <pc:sldMkLst>
-          <pc:docMk/>
-          <pc:sldMk cId="3083966018" sldId="681"/>
-        </pc:sldMkLst>
-      </pc:sldChg>
-      <pc:sldChg chg="modSp mod">
-        <pc:chgData name="Mohammed Fasha" userId="cc64f42d-a1a6-4f08-b97b-0c37f877119f" providerId="ADAL" clId="{BECD4A7F-C1AF-4585-8C31-FE7D4FE3ED16}" dt="2025-01-05T14:42:50.596" v="990" actId="14100"/>
-        <pc:sldMkLst>
-          <pc:docMk/>
-          <pc:sldMk cId="1697141369" sldId="695"/>
-        </pc:sldMkLst>
-        <pc:picChg chg="mod">
-          <ac:chgData name="Mohammed Fasha" userId="cc64f42d-a1a6-4f08-b97b-0c37f877119f" providerId="ADAL" clId="{BECD4A7F-C1AF-4585-8C31-FE7D4FE3ED16}" dt="2025-01-05T14:42:50.596" v="990" actId="14100"/>
-          <ac:picMkLst>
-            <pc:docMk/>
-            <pc:sldMk cId="1697141369" sldId="695"/>
-            <ac:picMk id="4" creationId="{74D2163C-9B06-605A-CBD7-17ACC1C06142}"/>
-          </ac:picMkLst>
-        </pc:picChg>
-      </pc:sldChg>
-      <pc:sldChg chg="addSp delSp modSp add del mod">
-        <pc:chgData name="Mohammed Fasha" userId="cc64f42d-a1a6-4f08-b97b-0c37f877119f" providerId="ADAL" clId="{BECD4A7F-C1AF-4585-8C31-FE7D4FE3ED16}" dt="2025-01-05T14:54:31.375" v="1125" actId="14100"/>
-        <pc:sldMkLst>
-          <pc:docMk/>
-          <pc:sldMk cId="265576630" sldId="698"/>
-        </pc:sldMkLst>
-        <pc:spChg chg="mod">
-          <ac:chgData name="Mohammed Fasha" userId="cc64f42d-a1a6-4f08-b97b-0c37f877119f" providerId="ADAL" clId="{BECD4A7F-C1AF-4585-8C31-FE7D4FE3ED16}" dt="2025-01-05T14:54:28.875" v="1124" actId="14100"/>
-          <ac:spMkLst>
-            <pc:docMk/>
-            <pc:sldMk cId="265576630" sldId="698"/>
-            <ac:spMk id="3" creationId="{5D33FC49-A3F8-3127-1AE9-16D35E013844}"/>
-          </ac:spMkLst>
-        </pc:spChg>
-        <pc:spChg chg="add mod">
-          <ac:chgData name="Mohammed Fasha" userId="cc64f42d-a1a6-4f08-b97b-0c37f877119f" providerId="ADAL" clId="{BECD4A7F-C1AF-4585-8C31-FE7D4FE3ED16}" dt="2025-01-05T14:54:31.375" v="1125" actId="14100"/>
-          <ac:spMkLst>
-            <pc:docMk/>
-            <pc:sldMk cId="265576630" sldId="698"/>
-            <ac:spMk id="7" creationId="{1B5443AD-BA71-B7BC-EEF2-04F1040B5C15}"/>
-          </ac:spMkLst>
-        </pc:spChg>
-        <pc:picChg chg="del">
-          <ac:chgData name="Mohammed Fasha" userId="cc64f42d-a1a6-4f08-b97b-0c37f877119f" providerId="ADAL" clId="{BECD4A7F-C1AF-4585-8C31-FE7D4FE3ED16}" dt="2025-01-05T14:49:12.023" v="1040" actId="21"/>
-          <ac:picMkLst>
-            <pc:docMk/>
-            <pc:sldMk cId="265576630" sldId="698"/>
-            <ac:picMk id="4" creationId="{6EF9C390-99A6-D5D7-8326-0D1C3413C862}"/>
-          </ac:picMkLst>
-        </pc:picChg>
-        <pc:picChg chg="add mod">
-          <ac:chgData name="Mohammed Fasha" userId="cc64f42d-a1a6-4f08-b97b-0c37f877119f" providerId="ADAL" clId="{BECD4A7F-C1AF-4585-8C31-FE7D4FE3ED16}" dt="2025-01-05T14:54:16.911" v="1123" actId="14100"/>
-          <ac:picMkLst>
-            <pc:docMk/>
-            <pc:sldMk cId="265576630" sldId="698"/>
-            <ac:picMk id="5" creationId="{C2587C9A-CF04-6159-EE69-CB2CD60250FA}"/>
-          </ac:picMkLst>
-        </pc:picChg>
-        <pc:picChg chg="del">
-          <ac:chgData name="Mohammed Fasha" userId="cc64f42d-a1a6-4f08-b97b-0c37f877119f" providerId="ADAL" clId="{BECD4A7F-C1AF-4585-8C31-FE7D4FE3ED16}" dt="2025-01-05T14:49:11.320" v="1039" actId="21"/>
-          <ac:picMkLst>
-            <pc:docMk/>
-            <pc:sldMk cId="265576630" sldId="698"/>
-            <ac:picMk id="6" creationId="{4D94753D-D34E-E836-87D8-F675A954E2D6}"/>
-          </ac:picMkLst>
-        </pc:picChg>
-      </pc:sldChg>
-      <pc:sldChg chg="del">
-        <pc:chgData name="Mohammed Fasha" userId="cc64f42d-a1a6-4f08-b97b-0c37f877119f" providerId="ADAL" clId="{BECD4A7F-C1AF-4585-8C31-FE7D4FE3ED16}" dt="2025-01-05T14:42:38.675" v="989" actId="2696"/>
-        <pc:sldMkLst>
-          <pc:docMk/>
-          <pc:sldMk cId="991725834" sldId="698"/>
-        </pc:sldMkLst>
-      </pc:sldChg>
-      <pc:sldChg chg="del">
-        <pc:chgData name="Mohammed Fasha" userId="cc64f42d-a1a6-4f08-b97b-0c37f877119f" providerId="ADAL" clId="{BECD4A7F-C1AF-4585-8C31-FE7D4FE3ED16}" dt="2025-01-05T14:42:38.675" v="989" actId="2696"/>
-        <pc:sldMkLst>
-          <pc:docMk/>
-          <pc:sldMk cId="3109561867" sldId="700"/>
-        </pc:sldMkLst>
-      </pc:sldChg>
-      <pc:sldChg chg="addSp delSp modSp add del mod">
-        <pc:chgData name="Mohammed Fasha" userId="cc64f42d-a1a6-4f08-b97b-0c37f877119f" providerId="ADAL" clId="{BECD4A7F-C1AF-4585-8C31-FE7D4FE3ED16}" dt="2025-01-05T16:00:05.564" v="1529" actId="20577"/>
-        <pc:sldMkLst>
-          <pc:docMk/>
-          <pc:sldMk cId="4247717824" sldId="700"/>
-        </pc:sldMkLst>
-        <pc:spChg chg="mod">
-          <ac:chgData name="Mohammed Fasha" userId="cc64f42d-a1a6-4f08-b97b-0c37f877119f" providerId="ADAL" clId="{BECD4A7F-C1AF-4585-8C31-FE7D4FE3ED16}" dt="2025-01-05T15:56:23.869" v="1473" actId="14100"/>
-          <ac:spMkLst>
-            <pc:docMk/>
-            <pc:sldMk cId="4247717824" sldId="700"/>
-            <ac:spMk id="3" creationId="{A65C5F38-2118-DD61-42D4-371CCEDADFFD}"/>
-          </ac:spMkLst>
-        </pc:spChg>
-        <pc:spChg chg="add">
-          <ac:chgData name="Mohammed Fasha" userId="cc64f42d-a1a6-4f08-b97b-0c37f877119f" providerId="ADAL" clId="{BECD4A7F-C1AF-4585-8C31-FE7D4FE3ED16}" dt="2025-01-05T15:00:04.891" v="1193"/>
-          <ac:spMkLst>
-            <pc:docMk/>
-            <pc:sldMk cId="4247717824" sldId="700"/>
-            <ac:spMk id="4" creationId="{6BB10121-B684-A350-F210-A254A83EEB13}"/>
-          </ac:spMkLst>
-        </pc:spChg>
-        <pc:graphicFrameChg chg="add del mod">
-          <ac:chgData name="Mohammed Fasha" userId="cc64f42d-a1a6-4f08-b97b-0c37f877119f" providerId="ADAL" clId="{BECD4A7F-C1AF-4585-8C31-FE7D4FE3ED16}" dt="2025-01-05T15:58:46.412" v="1482" actId="21"/>
-          <ac:graphicFrameMkLst>
-            <pc:docMk/>
-            <pc:sldMk cId="4247717824" sldId="700"/>
-            <ac:graphicFrameMk id="5" creationId="{93428C5A-F7AD-A5A5-36DD-A42B79A28E6B}"/>
-          </ac:graphicFrameMkLst>
-        </pc:graphicFrameChg>
-        <pc:graphicFrameChg chg="add mod modGraphic">
-          <ac:chgData name="Mohammed Fasha" userId="cc64f42d-a1a6-4f08-b97b-0c37f877119f" providerId="ADAL" clId="{BECD4A7F-C1AF-4585-8C31-FE7D4FE3ED16}" dt="2025-01-05T15:56:21.666" v="1469" actId="1076"/>
-          <ac:graphicFrameMkLst>
-            <pc:docMk/>
-            <pc:sldMk cId="4247717824" sldId="700"/>
-            <ac:graphicFrameMk id="6" creationId="{7A5CBBCD-7FBD-096A-406F-800D810B0392}"/>
-          </ac:graphicFrameMkLst>
-        </pc:graphicFrameChg>
-        <pc:graphicFrameChg chg="add mod">
-          <ac:chgData name="Mohammed Fasha" userId="cc64f42d-a1a6-4f08-b97b-0c37f877119f" providerId="ADAL" clId="{BECD4A7F-C1AF-4585-8C31-FE7D4FE3ED16}" dt="2025-01-05T15:58:33.106" v="1479"/>
-          <ac:graphicFrameMkLst>
-            <pc:docMk/>
-            <pc:sldMk cId="4247717824" sldId="700"/>
-            <ac:graphicFrameMk id="7" creationId="{14464770-762C-E4E4-BDD4-F4E24BE459E2}"/>
-          </ac:graphicFrameMkLst>
-        </pc:graphicFrameChg>
-        <pc:graphicFrameChg chg="add mod modGraphic">
-          <ac:chgData name="Mohammed Fasha" userId="cc64f42d-a1a6-4f08-b97b-0c37f877119f" providerId="ADAL" clId="{BECD4A7F-C1AF-4585-8C31-FE7D4FE3ED16}" dt="2025-01-05T15:59:00.638" v="1487" actId="14100"/>
-          <ac:graphicFrameMkLst>
-            <pc:docMk/>
-            <pc:sldMk cId="4247717824" sldId="700"/>
-            <ac:graphicFrameMk id="8" creationId="{CC8499AA-D51B-F138-9281-A3831B8EEE55}"/>
-          </ac:graphicFrameMkLst>
-        </pc:graphicFrameChg>
-        <pc:graphicFrameChg chg="add mod">
-          <ac:chgData name="Mohammed Fasha" userId="cc64f42d-a1a6-4f08-b97b-0c37f877119f" providerId="ADAL" clId="{BECD4A7F-C1AF-4585-8C31-FE7D4FE3ED16}" dt="2025-01-05T16:00:05.564" v="1529" actId="20577"/>
-          <ac:graphicFrameMkLst>
-            <pc:docMk/>
-            <pc:sldMk cId="4247717824" sldId="700"/>
-            <ac:graphicFrameMk id="9" creationId="{93428C5A-F7AD-A5A5-36DD-A42B79A28E6B}"/>
-          </ac:graphicFrameMkLst>
-        </pc:graphicFrameChg>
-      </pc:sldChg>
-      <pc:sldChg chg="addSp delSp modSp add mod">
-        <pc:chgData name="Mohammed Fasha" userId="cc64f42d-a1a6-4f08-b97b-0c37f877119f" providerId="ADAL" clId="{BECD4A7F-C1AF-4585-8C31-FE7D4FE3ED16}" dt="2025-01-05T14:53:29.185" v="1101" actId="21"/>
-        <pc:sldMkLst>
-          <pc:docMk/>
-          <pc:sldMk cId="67871309" sldId="709"/>
-        </pc:sldMkLst>
-        <pc:spChg chg="del">
-          <ac:chgData name="Mohammed Fasha" userId="cc64f42d-a1a6-4f08-b97b-0c37f877119f" providerId="ADAL" clId="{BECD4A7F-C1AF-4585-8C31-FE7D4FE3ED16}" dt="2025-01-05T14:49:24.636" v="1045" actId="21"/>
-          <ac:spMkLst>
-            <pc:docMk/>
-            <pc:sldMk cId="67871309" sldId="709"/>
-            <ac:spMk id="3" creationId="{0015CF61-9BD6-8201-BBB4-6F77436BA77B}"/>
-          </ac:spMkLst>
-        </pc:spChg>
-        <pc:spChg chg="add del mod">
-          <ac:chgData name="Mohammed Fasha" userId="cc64f42d-a1a6-4f08-b97b-0c37f877119f" providerId="ADAL" clId="{BECD4A7F-C1AF-4585-8C31-FE7D4FE3ED16}" dt="2025-01-05T14:49:28.264" v="1046" actId="21"/>
-          <ac:spMkLst>
-            <pc:docMk/>
-            <pc:sldMk cId="67871309" sldId="709"/>
-            <ac:spMk id="7" creationId="{ECA43FAD-DEA7-B526-932A-A50D5B778B12}"/>
-          </ac:spMkLst>
-        </pc:spChg>
-        <pc:picChg chg="add del mod">
-          <ac:chgData name="Mohammed Fasha" userId="cc64f42d-a1a6-4f08-b97b-0c37f877119f" providerId="ADAL" clId="{BECD4A7F-C1AF-4585-8C31-FE7D4FE3ED16}" dt="2025-01-05T14:53:29.185" v="1101" actId="21"/>
-          <ac:picMkLst>
-            <pc:docMk/>
-            <pc:sldMk cId="67871309" sldId="709"/>
-            <ac:picMk id="4" creationId="{C2587C9A-CF04-6159-EE69-CB2CD60250FA}"/>
-          </ac:picMkLst>
-        </pc:picChg>
-        <pc:picChg chg="del mod ord">
-          <ac:chgData name="Mohammed Fasha" userId="cc64f42d-a1a6-4f08-b97b-0c37f877119f" providerId="ADAL" clId="{BECD4A7F-C1AF-4585-8C31-FE7D4FE3ED16}" dt="2025-01-05T14:52:21.384" v="1084" actId="478"/>
-          <ac:picMkLst>
-            <pc:docMk/>
-            <pc:sldMk cId="67871309" sldId="709"/>
-            <ac:picMk id="6" creationId="{BB02C29B-037E-B325-1E1D-CECD23E4F994}"/>
-          </ac:picMkLst>
-        </pc:picChg>
-        <pc:picChg chg="add mod">
-          <ac:chgData name="Mohammed Fasha" userId="cc64f42d-a1a6-4f08-b97b-0c37f877119f" providerId="ADAL" clId="{BECD4A7F-C1AF-4585-8C31-FE7D4FE3ED16}" dt="2025-01-05T14:53:25.955" v="1099" actId="14100"/>
-          <ac:picMkLst>
-            <pc:docMk/>
-            <pc:sldMk cId="67871309" sldId="709"/>
-            <ac:picMk id="9" creationId="{8A693C11-304C-13A7-D332-654612E36CB7}"/>
-          </ac:picMkLst>
-        </pc:picChg>
-        <pc:picChg chg="add mod">
-          <ac:chgData name="Mohammed Fasha" userId="cc64f42d-a1a6-4f08-b97b-0c37f877119f" providerId="ADAL" clId="{BECD4A7F-C1AF-4585-8C31-FE7D4FE3ED16}" dt="2025-01-05T14:53:28.513" v="1100" actId="1076"/>
-          <ac:picMkLst>
-            <pc:docMk/>
-            <pc:sldMk cId="67871309" sldId="709"/>
-            <ac:picMk id="2050" creationId="{084A30D3-2CDA-6011-243C-60D829890086}"/>
-          </ac:picMkLst>
-        </pc:picChg>
-      </pc:sldChg>
-      <pc:sldChg chg="modSp add mod">
-        <pc:chgData name="Mohammed Fasha" userId="cc64f42d-a1a6-4f08-b97b-0c37f877119f" providerId="ADAL" clId="{BECD4A7F-C1AF-4585-8C31-FE7D4FE3ED16}" dt="2025-01-05T15:31:09.113" v="1385" actId="6549"/>
-        <pc:sldMkLst>
-          <pc:docMk/>
-          <pc:sldMk cId="4114896152" sldId="710"/>
-        </pc:sldMkLst>
-        <pc:spChg chg="mod">
-          <ac:chgData name="Mohammed Fasha" userId="cc64f42d-a1a6-4f08-b97b-0c37f877119f" providerId="ADAL" clId="{BECD4A7F-C1AF-4585-8C31-FE7D4FE3ED16}" dt="2025-01-05T15:31:09.113" v="1385" actId="6549"/>
-          <ac:spMkLst>
-            <pc:docMk/>
-            <pc:sldMk cId="4114896152" sldId="710"/>
-            <ac:spMk id="3" creationId="{D33E66F3-8397-4994-28A4-1DCE141C618C}"/>
-          </ac:spMkLst>
-        </pc:spChg>
-      </pc:sldChg>
-      <pc:sldChg chg="addSp modSp add mod">
-        <pc:chgData name="Mohammed Fasha" userId="cc64f42d-a1a6-4f08-b97b-0c37f877119f" providerId="ADAL" clId="{BECD4A7F-C1AF-4585-8C31-FE7D4FE3ED16}" dt="2025-01-05T15:27:36.027" v="1348" actId="20577"/>
-        <pc:sldMkLst>
-          <pc:docMk/>
-          <pc:sldMk cId="3794385322" sldId="711"/>
-        </pc:sldMkLst>
-        <pc:spChg chg="mod">
-          <ac:chgData name="Mohammed Fasha" userId="cc64f42d-a1a6-4f08-b97b-0c37f877119f" providerId="ADAL" clId="{BECD4A7F-C1AF-4585-8C31-FE7D4FE3ED16}" dt="2025-01-05T15:27:36.027" v="1348" actId="20577"/>
-          <ac:spMkLst>
-            <pc:docMk/>
-            <pc:sldMk cId="3794385322" sldId="711"/>
-            <ac:spMk id="3" creationId="{978883A7-D876-AEF2-76C8-90BFC8E97077}"/>
-          </ac:spMkLst>
-        </pc:spChg>
-        <pc:spChg chg="add">
-          <ac:chgData name="Mohammed Fasha" userId="cc64f42d-a1a6-4f08-b97b-0c37f877119f" providerId="ADAL" clId="{BECD4A7F-C1AF-4585-8C31-FE7D4FE3ED16}" dt="2025-01-05T14:59:16.910" v="1179"/>
-          <ac:spMkLst>
-            <pc:docMk/>
-            <pc:sldMk cId="3794385322" sldId="711"/>
-            <ac:spMk id="4" creationId="{0EBA0640-41A1-5E21-F108-02E5B6FEE7A7}"/>
-          </ac:spMkLst>
-        </pc:spChg>
-        <pc:spChg chg="add">
-          <ac:chgData name="Mohammed Fasha" userId="cc64f42d-a1a6-4f08-b97b-0c37f877119f" providerId="ADAL" clId="{BECD4A7F-C1AF-4585-8C31-FE7D4FE3ED16}" dt="2025-01-05T14:59:20.488" v="1181"/>
-          <ac:spMkLst>
-            <pc:docMk/>
-            <pc:sldMk cId="3794385322" sldId="711"/>
-            <ac:spMk id="5" creationId="{B6223C37-AFD7-5C7E-30AE-53F0F5E51AF1}"/>
-          </ac:spMkLst>
-        </pc:spChg>
-        <pc:picChg chg="add mod">
-          <ac:chgData name="Mohammed Fasha" userId="cc64f42d-a1a6-4f08-b97b-0c37f877119f" providerId="ADAL" clId="{BECD4A7F-C1AF-4585-8C31-FE7D4FE3ED16}" dt="2025-01-05T15:03:13.408" v="1217" actId="1076"/>
-          <ac:picMkLst>
-            <pc:docMk/>
-            <pc:sldMk cId="3794385322" sldId="711"/>
-            <ac:picMk id="3076" creationId="{67BB95F7-FCED-74F1-D09F-61ED49C7CCD3}"/>
-          </ac:picMkLst>
-        </pc:picChg>
-      </pc:sldChg>
-      <pc:sldChg chg="add del">
-        <pc:chgData name="Mohammed Fasha" userId="cc64f42d-a1a6-4f08-b97b-0c37f877119f" providerId="ADAL" clId="{BECD4A7F-C1AF-4585-8C31-FE7D4FE3ED16}" dt="2025-01-05T14:57:43.613" v="1146" actId="2696"/>
-        <pc:sldMkLst>
-          <pc:docMk/>
-          <pc:sldMk cId="501127302" sldId="712"/>
-        </pc:sldMkLst>
-      </pc:sldChg>
-      <pc:sldChg chg="modSp add mod">
-        <pc:chgData name="Mohammed Fasha" userId="cc64f42d-a1a6-4f08-b97b-0c37f877119f" providerId="ADAL" clId="{BECD4A7F-C1AF-4585-8C31-FE7D4FE3ED16}" dt="2025-01-05T15:32:23.870" v="1388"/>
-        <pc:sldMkLst>
-          <pc:docMk/>
-          <pc:sldMk cId="3701206727" sldId="712"/>
-        </pc:sldMkLst>
-        <pc:spChg chg="mod">
-          <ac:chgData name="Mohammed Fasha" userId="cc64f42d-a1a6-4f08-b97b-0c37f877119f" providerId="ADAL" clId="{BECD4A7F-C1AF-4585-8C31-FE7D4FE3ED16}" dt="2025-01-05T15:32:23.870" v="1388"/>
-          <ac:spMkLst>
-            <pc:docMk/>
-            <pc:sldMk cId="3701206727" sldId="712"/>
-            <ac:spMk id="3" creationId="{B5EBE5AB-A5B7-7A93-34E6-EA5080D2C2C8}"/>
-          </ac:spMkLst>
-        </pc:spChg>
-      </pc:sldChg>
-      <pc:sldChg chg="addSp modSp add mod">
-        <pc:chgData name="Mohammed Fasha" userId="cc64f42d-a1a6-4f08-b97b-0c37f877119f" providerId="ADAL" clId="{BECD4A7F-C1AF-4585-8C31-FE7D4FE3ED16}" dt="2025-01-05T16:06:36.028" v="1538" actId="1076"/>
-        <pc:sldMkLst>
-          <pc:docMk/>
-          <pc:sldMk cId="1499972066" sldId="713"/>
-        </pc:sldMkLst>
-        <pc:spChg chg="mod">
-          <ac:chgData name="Mohammed Fasha" userId="cc64f42d-a1a6-4f08-b97b-0c37f877119f" providerId="ADAL" clId="{BECD4A7F-C1AF-4585-8C31-FE7D4FE3ED16}" dt="2025-01-05T15:28:24.065" v="1358" actId="20577"/>
-          <ac:spMkLst>
-            <pc:docMk/>
-            <pc:sldMk cId="1499972066" sldId="713"/>
-            <ac:spMk id="3" creationId="{6719E367-A4FE-AE2B-34B1-1DA0024C6A20}"/>
-          </ac:spMkLst>
-        </pc:spChg>
-        <pc:picChg chg="add mod">
-          <ac:chgData name="Mohammed Fasha" userId="cc64f42d-a1a6-4f08-b97b-0c37f877119f" providerId="ADAL" clId="{BECD4A7F-C1AF-4585-8C31-FE7D4FE3ED16}" dt="2025-01-05T16:06:36.028" v="1538" actId="1076"/>
-          <ac:picMkLst>
-            <pc:docMk/>
-            <pc:sldMk cId="1499972066" sldId="713"/>
-            <ac:picMk id="6146" creationId="{F4194E29-81D9-5FD3-B646-EAFBE7BE7254}"/>
-          </ac:picMkLst>
-        </pc:picChg>
-      </pc:sldChg>
-      <pc:sldChg chg="addSp delSp modSp add mod">
-        <pc:chgData name="Mohammed Fasha" userId="cc64f42d-a1a6-4f08-b97b-0c37f877119f" providerId="ADAL" clId="{BECD4A7F-C1AF-4585-8C31-FE7D4FE3ED16}" dt="2025-01-05T16:19:08.436" v="1705" actId="1036"/>
-        <pc:sldMkLst>
-          <pc:docMk/>
-          <pc:sldMk cId="1270641495" sldId="714"/>
-        </pc:sldMkLst>
-        <pc:spChg chg="mod">
-          <ac:chgData name="Mohammed Fasha" userId="cc64f42d-a1a6-4f08-b97b-0c37f877119f" providerId="ADAL" clId="{BECD4A7F-C1AF-4585-8C31-FE7D4FE3ED16}" dt="2025-01-05T16:18:59.577" v="1697" actId="20577"/>
-          <ac:spMkLst>
-            <pc:docMk/>
-            <pc:sldMk cId="1270641495" sldId="714"/>
-            <ac:spMk id="3" creationId="{83ED29CA-FE26-6777-1F1A-6F46BCEEB9BB}"/>
-          </ac:spMkLst>
-        </pc:spChg>
-        <pc:spChg chg="add">
-          <ac:chgData name="Mohammed Fasha" userId="cc64f42d-a1a6-4f08-b97b-0c37f877119f" providerId="ADAL" clId="{BECD4A7F-C1AF-4585-8C31-FE7D4FE3ED16}" dt="2025-01-05T16:16:48.111" v="1542"/>
-          <ac:spMkLst>
-            <pc:docMk/>
-            <pc:sldMk cId="1270641495" sldId="714"/>
-            <ac:spMk id="5" creationId="{AB4345C3-D7BD-99C3-CA10-3EE9E7FEBF80}"/>
-          </ac:spMkLst>
-        </pc:spChg>
-        <pc:spChg chg="add mod">
-          <ac:chgData name="Mohammed Fasha" userId="cc64f42d-a1a6-4f08-b97b-0c37f877119f" providerId="ADAL" clId="{BECD4A7F-C1AF-4585-8C31-FE7D4FE3ED16}" dt="2025-01-05T16:18:14.908" v="1617" actId="1076"/>
-          <ac:spMkLst>
-            <pc:docMk/>
-            <pc:sldMk cId="1270641495" sldId="714"/>
-            <ac:spMk id="7" creationId="{0550F4B6-EF46-BA8E-B021-A9DD446047EA}"/>
-          </ac:spMkLst>
-        </pc:spChg>
-        <pc:graphicFrameChg chg="add del mod">
-          <ac:chgData name="Mohammed Fasha" userId="cc64f42d-a1a6-4f08-b97b-0c37f877119f" providerId="ADAL" clId="{BECD4A7F-C1AF-4585-8C31-FE7D4FE3ED16}" dt="2025-01-05T16:06:08.308" v="1530" actId="478"/>
-          <ac:graphicFrameMkLst>
-            <pc:docMk/>
-            <pc:sldMk cId="1270641495" sldId="714"/>
-            <ac:graphicFrameMk id="4" creationId="{80C2BEB0-99A2-2D57-E597-EDFE0AB3AA92}"/>
-          </ac:graphicFrameMkLst>
-        </pc:graphicFrameChg>
-        <pc:picChg chg="add mod">
-          <ac:chgData name="Mohammed Fasha" userId="cc64f42d-a1a6-4f08-b97b-0c37f877119f" providerId="ADAL" clId="{BECD4A7F-C1AF-4585-8C31-FE7D4FE3ED16}" dt="2025-01-05T16:18:20.673" v="1618" actId="14100"/>
-          <ac:picMkLst>
-            <pc:docMk/>
-            <pc:sldMk cId="1270641495" sldId="714"/>
-            <ac:picMk id="7170" creationId="{AF89B1EB-4AD3-6E64-5A9B-9A00BD5EF2DB}"/>
-          </ac:picMkLst>
-        </pc:picChg>
-        <pc:picChg chg="add mod">
-          <ac:chgData name="Mohammed Fasha" userId="cc64f42d-a1a6-4f08-b97b-0c37f877119f" providerId="ADAL" clId="{BECD4A7F-C1AF-4585-8C31-FE7D4FE3ED16}" dt="2025-01-05T16:19:08.436" v="1705" actId="1036"/>
-          <ac:picMkLst>
-            <pc:docMk/>
-            <pc:sldMk cId="1270641495" sldId="714"/>
-            <ac:picMk id="7172" creationId="{B620BAD4-C68B-A239-E964-52B8908CD0E4}"/>
-          </ac:picMkLst>
-        </pc:picChg>
-      </pc:sldChg>
-      <pc:sldChg chg="addSp modSp new mod">
-        <pc:chgData name="Mohammed Fasha" userId="cc64f42d-a1a6-4f08-b97b-0c37f877119f" providerId="ADAL" clId="{BECD4A7F-C1AF-4585-8C31-FE7D4FE3ED16}" dt="2025-01-05T16:23:44.632" v="1736" actId="12"/>
-        <pc:sldMkLst>
-          <pc:docMk/>
-          <pc:sldMk cId="1096386322" sldId="715"/>
-        </pc:sldMkLst>
-        <pc:spChg chg="mod">
-          <ac:chgData name="Mohammed Fasha" userId="cc64f42d-a1a6-4f08-b97b-0c37f877119f" providerId="ADAL" clId="{BECD4A7F-C1AF-4585-8C31-FE7D4FE3ED16}" dt="2025-01-05T16:22:50.331" v="1729" actId="27636"/>
-          <ac:spMkLst>
-            <pc:docMk/>
-            <pc:sldMk cId="1096386322" sldId="715"/>
-            <ac:spMk id="2" creationId="{E0FA676E-AB7F-658B-0B80-69D7FC0870BD}"/>
-          </ac:spMkLst>
-        </pc:spChg>
-        <pc:spChg chg="mod">
-          <ac:chgData name="Mohammed Fasha" userId="cc64f42d-a1a6-4f08-b97b-0c37f877119f" providerId="ADAL" clId="{BECD4A7F-C1AF-4585-8C31-FE7D4FE3ED16}" dt="2025-01-05T16:23:44.632" v="1736" actId="12"/>
-          <ac:spMkLst>
-            <pc:docMk/>
-            <pc:sldMk cId="1096386322" sldId="715"/>
-            <ac:spMk id="3" creationId="{45AB6FB8-BB05-D23A-0B53-873D2E6C00ED}"/>
-          </ac:spMkLst>
-        </pc:spChg>
-        <pc:spChg chg="add">
-          <ac:chgData name="Mohammed Fasha" userId="cc64f42d-a1a6-4f08-b97b-0c37f877119f" providerId="ADAL" clId="{BECD4A7F-C1AF-4585-8C31-FE7D4FE3ED16}" dt="2025-01-05T16:22:07.171" v="1707"/>
-          <ac:spMkLst>
-            <pc:docMk/>
-            <pc:sldMk cId="1096386322" sldId="715"/>
-            <ac:spMk id="4" creationId="{71DD10F4-7171-6A1D-C235-670BB52B8E14}"/>
-          </ac:spMkLst>
-        </pc:spChg>
-        <pc:spChg chg="add">
-          <ac:chgData name="Mohammed Fasha" userId="cc64f42d-a1a6-4f08-b97b-0c37f877119f" providerId="ADAL" clId="{BECD4A7F-C1AF-4585-8C31-FE7D4FE3ED16}" dt="2025-01-05T16:22:07.171" v="1707"/>
-          <ac:spMkLst>
-            <pc:docMk/>
-            <pc:sldMk cId="1096386322" sldId="715"/>
-            <ac:spMk id="5" creationId="{167E6EFE-6AC2-E3C0-91F8-EF90A8B79A8F}"/>
-          </ac:spMkLst>
-        </pc:spChg>
-        <pc:spChg chg="add">
-          <ac:chgData name="Mohammed Fasha" userId="cc64f42d-a1a6-4f08-b97b-0c37f877119f" providerId="ADAL" clId="{BECD4A7F-C1AF-4585-8C31-FE7D4FE3ED16}" dt="2025-01-05T16:22:07.171" v="1707"/>
-          <ac:spMkLst>
-            <pc:docMk/>
-            <pc:sldMk cId="1096386322" sldId="715"/>
-            <ac:spMk id="6" creationId="{B7F93336-D140-9B42-DB5E-6E84E2F993F0}"/>
-          </ac:spMkLst>
-        </pc:spChg>
-        <pc:spChg chg="add">
-          <ac:chgData name="Mohammed Fasha" userId="cc64f42d-a1a6-4f08-b97b-0c37f877119f" providerId="ADAL" clId="{BECD4A7F-C1AF-4585-8C31-FE7D4FE3ED16}" dt="2025-01-05T16:22:07.171" v="1707"/>
-          <ac:spMkLst>
-            <pc:docMk/>
-            <pc:sldMk cId="1096386322" sldId="715"/>
-            <ac:spMk id="7" creationId="{715F4345-60CB-07E6-2468-D84AACB6C84E}"/>
-          </ac:spMkLst>
-        </pc:spChg>
-        <pc:spChg chg="add">
-          <ac:chgData name="Mohammed Fasha" userId="cc64f42d-a1a6-4f08-b97b-0c37f877119f" providerId="ADAL" clId="{BECD4A7F-C1AF-4585-8C31-FE7D4FE3ED16}" dt="2025-01-05T16:22:07.171" v="1707"/>
-          <ac:spMkLst>
-            <pc:docMk/>
-            <pc:sldMk cId="1096386322" sldId="715"/>
-            <ac:spMk id="8" creationId="{6E05A7CE-60FB-696C-CE39-C1F2774F8199}"/>
-          </ac:spMkLst>
-        </pc:spChg>
-        <pc:spChg chg="add">
-          <ac:chgData name="Mohammed Fasha" userId="cc64f42d-a1a6-4f08-b97b-0c37f877119f" providerId="ADAL" clId="{BECD4A7F-C1AF-4585-8C31-FE7D4FE3ED16}" dt="2025-01-05T16:22:07.171" v="1707"/>
-          <ac:spMkLst>
-            <pc:docMk/>
-            <pc:sldMk cId="1096386322" sldId="715"/>
-            <ac:spMk id="9" creationId="{C1C1CF98-4DAC-F85F-6D77-3570AC5C0A80}"/>
-          </ac:spMkLst>
-        </pc:spChg>
-        <pc:spChg chg="add">
-          <ac:chgData name="Mohammed Fasha" userId="cc64f42d-a1a6-4f08-b97b-0c37f877119f" providerId="ADAL" clId="{BECD4A7F-C1AF-4585-8C31-FE7D4FE3ED16}" dt="2025-01-05T16:22:07.171" v="1707"/>
-          <ac:spMkLst>
-            <pc:docMk/>
-            <pc:sldMk cId="1096386322" sldId="715"/>
-            <ac:spMk id="10" creationId="{1240D613-7E7C-45AD-7065-ABC2DF7BFE44}"/>
-          </ac:spMkLst>
-        </pc:spChg>
-        <pc:spChg chg="add">
-          <ac:chgData name="Mohammed Fasha" userId="cc64f42d-a1a6-4f08-b97b-0c37f877119f" providerId="ADAL" clId="{BECD4A7F-C1AF-4585-8C31-FE7D4FE3ED16}" dt="2025-01-05T16:22:07.171" v="1707"/>
-          <ac:spMkLst>
-            <pc:docMk/>
-            <pc:sldMk cId="1096386322" sldId="715"/>
-            <ac:spMk id="11" creationId="{E3757EDF-D707-27FF-E3A8-106D2ECC9C72}"/>
-          </ac:spMkLst>
-        </pc:spChg>
-        <pc:spChg chg="add">
-          <ac:chgData name="Mohammed Fasha" userId="cc64f42d-a1a6-4f08-b97b-0c37f877119f" providerId="ADAL" clId="{BECD4A7F-C1AF-4585-8C31-FE7D4FE3ED16}" dt="2025-01-05T16:22:07.171" v="1707"/>
-          <ac:spMkLst>
-            <pc:docMk/>
-            <pc:sldMk cId="1096386322" sldId="715"/>
-            <ac:spMk id="12" creationId="{9CB87924-8ACA-36F3-17D6-9D0E54C18E94}"/>
-          </ac:spMkLst>
-        </pc:spChg>
-      </pc:sldChg>
-      <pc:sldChg chg="modSp new mod">
-        <pc:chgData name="Mohammed Fasha" userId="cc64f42d-a1a6-4f08-b97b-0c37f877119f" providerId="ADAL" clId="{BECD4A7F-C1AF-4585-8C31-FE7D4FE3ED16}" dt="2025-01-05T16:34:02.360" v="1902" actId="27636"/>
-        <pc:sldMkLst>
-          <pc:docMk/>
-          <pc:sldMk cId="1784058309" sldId="716"/>
-        </pc:sldMkLst>
-        <pc:spChg chg="mod">
-          <ac:chgData name="Mohammed Fasha" userId="cc64f42d-a1a6-4f08-b97b-0c37f877119f" providerId="ADAL" clId="{BECD4A7F-C1AF-4585-8C31-FE7D4FE3ED16}" dt="2025-01-05T16:27:44.855" v="1812" actId="27636"/>
-          <ac:spMkLst>
-            <pc:docMk/>
-            <pc:sldMk cId="1784058309" sldId="716"/>
-            <ac:spMk id="2" creationId="{7F17E170-927D-7ABF-8B46-A9506CFC1D2E}"/>
-          </ac:spMkLst>
-        </pc:spChg>
-        <pc:spChg chg="mod">
-          <ac:chgData name="Mohammed Fasha" userId="cc64f42d-a1a6-4f08-b97b-0c37f877119f" providerId="ADAL" clId="{BECD4A7F-C1AF-4585-8C31-FE7D4FE3ED16}" dt="2025-01-05T16:34:02.360" v="1902" actId="27636"/>
-          <ac:spMkLst>
-            <pc:docMk/>
-            <pc:sldMk cId="1784058309" sldId="716"/>
-            <ac:spMk id="3" creationId="{B36514A8-EBE6-D8AF-FF1F-BD24FB37FC59}"/>
-          </ac:spMkLst>
-        </pc:spChg>
-      </pc:sldChg>
-      <pc:sldChg chg="modSp add mod ord">
-        <pc:chgData name="Mohammed Fasha" userId="cc64f42d-a1a6-4f08-b97b-0c37f877119f" providerId="ADAL" clId="{BECD4A7F-C1AF-4585-8C31-FE7D4FE3ED16}" dt="2025-01-05T16:27:20.520" v="1803"/>
-        <pc:sldMkLst>
-          <pc:docMk/>
-          <pc:sldMk cId="3139017106" sldId="717"/>
-        </pc:sldMkLst>
-        <pc:spChg chg="mod">
-          <ac:chgData name="Mohammed Fasha" userId="cc64f42d-a1a6-4f08-b97b-0c37f877119f" providerId="ADAL" clId="{BECD4A7F-C1AF-4585-8C31-FE7D4FE3ED16}" dt="2025-01-05T16:24:23.538" v="1746" actId="27636"/>
-          <ac:spMkLst>
-            <pc:docMk/>
-            <pc:sldMk cId="3139017106" sldId="717"/>
-            <ac:spMk id="2" creationId="{676E8EB1-B8AF-38C9-45A2-E884124D2358}"/>
-          </ac:spMkLst>
-        </pc:spChg>
-        <pc:spChg chg="mod">
-          <ac:chgData name="Mohammed Fasha" userId="cc64f42d-a1a6-4f08-b97b-0c37f877119f" providerId="ADAL" clId="{BECD4A7F-C1AF-4585-8C31-FE7D4FE3ED16}" dt="2025-01-05T16:27:02.817" v="1801"/>
-          <ac:spMkLst>
-            <pc:docMk/>
-            <pc:sldMk cId="3139017106" sldId="717"/>
-            <ac:spMk id="3" creationId="{DC3791AF-CCDA-A622-4609-138A92B217B4}"/>
-          </ac:spMkLst>
-        </pc:spChg>
-      </pc:sldChg>
-      <pc:sldChg chg="addSp delSp modSp new mod">
-        <pc:chgData name="Mohammed Fasha" userId="cc64f42d-a1a6-4f08-b97b-0c37f877119f" providerId="ADAL" clId="{BECD4A7F-C1AF-4585-8C31-FE7D4FE3ED16}" dt="2025-01-05T16:32:45.446" v="1897" actId="20577"/>
-        <pc:sldMkLst>
-          <pc:docMk/>
-          <pc:sldMk cId="3043812923" sldId="718"/>
-        </pc:sldMkLst>
-        <pc:spChg chg="mod">
-          <ac:chgData name="Mohammed Fasha" userId="cc64f42d-a1a6-4f08-b97b-0c37f877119f" providerId="ADAL" clId="{BECD4A7F-C1AF-4585-8C31-FE7D4FE3ED16}" dt="2025-01-05T16:28:21.066" v="1830" actId="20577"/>
-          <ac:spMkLst>
-            <pc:docMk/>
-            <pc:sldMk cId="3043812923" sldId="718"/>
-            <ac:spMk id="2" creationId="{A31FB935-1934-5D5A-7731-43E1686EE5AE}"/>
-          </ac:spMkLst>
-        </pc:spChg>
-        <pc:spChg chg="add del mod">
-          <ac:chgData name="Mohammed Fasha" userId="cc64f42d-a1a6-4f08-b97b-0c37f877119f" providerId="ADAL" clId="{BECD4A7F-C1AF-4585-8C31-FE7D4FE3ED16}" dt="2025-01-05T16:32:45.446" v="1897" actId="20577"/>
-          <ac:spMkLst>
-            <pc:docMk/>
-            <pc:sldMk cId="3043812923" sldId="718"/>
-            <ac:spMk id="3" creationId="{7E85BC0E-FC03-93B4-4532-87B2D4670422}"/>
-          </ac:spMkLst>
-        </pc:spChg>
-        <pc:spChg chg="add mod">
-          <ac:chgData name="Mohammed Fasha" userId="cc64f42d-a1a6-4f08-b97b-0c37f877119f" providerId="ADAL" clId="{BECD4A7F-C1AF-4585-8C31-FE7D4FE3ED16}" dt="2025-01-05T16:28:00.821" v="1815"/>
-          <ac:spMkLst>
-            <pc:docMk/>
-            <pc:sldMk cId="3043812923" sldId="718"/>
-            <ac:spMk id="4" creationId="{E7853568-FC98-329D-D683-8D4955460246}"/>
-          </ac:spMkLst>
-        </pc:spChg>
-        <pc:spChg chg="add">
-          <ac:chgData name="Mohammed Fasha" userId="cc64f42d-a1a6-4f08-b97b-0c37f877119f" providerId="ADAL" clId="{BECD4A7F-C1AF-4585-8C31-FE7D4FE3ED16}" dt="2025-01-05T16:31:57.708" v="1837"/>
-          <ac:spMkLst>
-            <pc:docMk/>
-            <pc:sldMk cId="3043812923" sldId="718"/>
-            <ac:spMk id="5" creationId="{E385683B-4735-F77C-4B9C-26ECC1E3E890}"/>
+            <pc:sldMk cId="1939766790" sldId="474"/>
+            <ac:spMk id="3" creationId="{4C7102F1-33CC-09ED-19D1-63AD5315FDDF}"/>
           </ac:spMkLst>
         </pc:spChg>
       </pc:sldChg>
@@ -1022,17 +337,269 @@
     </pc:docChg>
   </pc:docChgLst>
   <pc:docChgLst>
-    <pc:chgData name="Mohammed Fasha" userId="cc64f42d-a1a6-4f08-b97b-0c37f877119f" providerId="ADAL" clId="{5980B3BB-4EB6-4E37-92BF-3A2A8F4B2C7A}"/>
-    <pc:docChg chg="custSel modSld">
-      <pc:chgData name="Mohammed Fasha" userId="cc64f42d-a1a6-4f08-b97b-0c37f877119f" providerId="ADAL" clId="{5980B3BB-4EB6-4E37-92BF-3A2A8F4B2C7A}" dt="2024-10-15T02:28:13.535" v="0" actId="478"/>
+    <pc:chgData name="Mohammed Fasha" userId="cc64f42d-a1a6-4f08-b97b-0c37f877119f" providerId="ADAL" clId="{BECD4A7F-C1AF-4585-8C31-FE7D4FE3ED16}"/>
+    <pc:docChg chg="undo redo custSel addSld delSld modSld sldOrd">
+      <pc:chgData name="Mohammed Fasha" userId="cc64f42d-a1a6-4f08-b97b-0c37f877119f" providerId="ADAL" clId="{BECD4A7F-C1AF-4585-8C31-FE7D4FE3ED16}" dt="2025-01-05T16:36:16.605" v="1945" actId="1076"/>
       <pc:docMkLst>
         <pc:docMk/>
       </pc:docMkLst>
-      <pc:sldChg chg="delSp mod">
-        <pc:chgData name="Mohammed Fasha" userId="cc64f42d-a1a6-4f08-b97b-0c37f877119f" providerId="ADAL" clId="{5980B3BB-4EB6-4E37-92BF-3A2A8F4B2C7A}" dt="2024-10-15T02:28:13.535" v="0" actId="478"/>
-        <pc:sldMkLst>
-          <pc:docMk/>
-          <pc:sldMk cId="2297456757" sldId="483"/>
+      <pc:sldChg chg="modSp mod">
+        <pc:chgData name="Mohammed Fasha" userId="cc64f42d-a1a6-4f08-b97b-0c37f877119f" providerId="ADAL" clId="{BECD4A7F-C1AF-4585-8C31-FE7D4FE3ED16}" dt="2024-12-30T18:47:27.683" v="988" actId="20577"/>
+        <pc:sldMkLst>
+          <pc:docMk/>
+          <pc:sldMk cId="2281221656" sldId="527"/>
+        </pc:sldMkLst>
+      </pc:sldChg>
+      <pc:sldChg chg="modSp mod">
+        <pc:chgData name="Mohammed Fasha" userId="cc64f42d-a1a6-4f08-b97b-0c37f877119f" providerId="ADAL" clId="{BECD4A7F-C1AF-4585-8C31-FE7D4FE3ED16}" dt="2024-12-27T13:59:26.893" v="366" actId="20577"/>
+        <pc:sldMkLst>
+          <pc:docMk/>
+          <pc:sldMk cId="3474268344" sldId="596"/>
+        </pc:sldMkLst>
+      </pc:sldChg>
+      <pc:sldChg chg="modSp mod">
+        <pc:chgData name="Mohammed Fasha" userId="cc64f42d-a1a6-4f08-b97b-0c37f877119f" providerId="ADAL" clId="{BECD4A7F-C1AF-4585-8C31-FE7D4FE3ED16}" dt="2024-12-30T18:44:34.649" v="884" actId="20577"/>
+        <pc:sldMkLst>
+          <pc:docMk/>
+          <pc:sldMk cId="916802035" sldId="651"/>
+        </pc:sldMkLst>
+      </pc:sldChg>
+      <pc:sldChg chg="del">
+        <pc:chgData name="Mohammed Fasha" userId="cc64f42d-a1a6-4f08-b97b-0c37f877119f" providerId="ADAL" clId="{BECD4A7F-C1AF-4585-8C31-FE7D4FE3ED16}" dt="2025-01-05T14:42:38.675" v="989" actId="2696"/>
+        <pc:sldMkLst>
+          <pc:docMk/>
+          <pc:sldMk cId="426516858" sldId="662"/>
+        </pc:sldMkLst>
+      </pc:sldChg>
+      <pc:sldChg chg="modSp add del mod">
+        <pc:chgData name="Mohammed Fasha" userId="cc64f42d-a1a6-4f08-b97b-0c37f877119f" providerId="ADAL" clId="{BECD4A7F-C1AF-4585-8C31-FE7D4FE3ED16}" dt="2025-01-05T16:34:59.233" v="1926" actId="20577"/>
+        <pc:sldMkLst>
+          <pc:docMk/>
+          <pc:sldMk cId="691538069" sldId="662"/>
+        </pc:sldMkLst>
+      </pc:sldChg>
+      <pc:sldChg chg="del">
+        <pc:chgData name="Mohammed Fasha" userId="cc64f42d-a1a6-4f08-b97b-0c37f877119f" providerId="ADAL" clId="{BECD4A7F-C1AF-4585-8C31-FE7D4FE3ED16}" dt="2025-01-05T14:42:38.675" v="989" actId="2696"/>
+        <pc:sldMkLst>
+          <pc:docMk/>
+          <pc:sldMk cId="895445062" sldId="663"/>
+        </pc:sldMkLst>
+      </pc:sldChg>
+      <pc:sldChg chg="add del">
+        <pc:chgData name="Mohammed Fasha" userId="cc64f42d-a1a6-4f08-b97b-0c37f877119f" providerId="ADAL" clId="{BECD4A7F-C1AF-4585-8C31-FE7D4FE3ED16}" dt="2025-01-05T14:43:16.100" v="993" actId="2696"/>
+        <pc:sldMkLst>
+          <pc:docMk/>
+          <pc:sldMk cId="3980180774" sldId="663"/>
+        </pc:sldMkLst>
+      </pc:sldChg>
+      <pc:sldChg chg="add del">
+        <pc:chgData name="Mohammed Fasha" userId="cc64f42d-a1a6-4f08-b97b-0c37f877119f" providerId="ADAL" clId="{BECD4A7F-C1AF-4585-8C31-FE7D4FE3ED16}" dt="2025-01-05T14:43:16.100" v="993" actId="2696"/>
+        <pc:sldMkLst>
+          <pc:docMk/>
+          <pc:sldMk cId="1728680596" sldId="664"/>
+        </pc:sldMkLst>
+      </pc:sldChg>
+      <pc:sldChg chg="del">
+        <pc:chgData name="Mohammed Fasha" userId="cc64f42d-a1a6-4f08-b97b-0c37f877119f" providerId="ADAL" clId="{BECD4A7F-C1AF-4585-8C31-FE7D4FE3ED16}" dt="2025-01-05T14:42:38.675" v="989" actId="2696"/>
+        <pc:sldMkLst>
+          <pc:docMk/>
+          <pc:sldMk cId="3900588277" sldId="664"/>
+        </pc:sldMkLst>
+      </pc:sldChg>
+      <pc:sldChg chg="del">
+        <pc:chgData name="Mohammed Fasha" userId="cc64f42d-a1a6-4f08-b97b-0c37f877119f" providerId="ADAL" clId="{BECD4A7F-C1AF-4585-8C31-FE7D4FE3ED16}" dt="2025-01-05T14:42:38.675" v="989" actId="2696"/>
+        <pc:sldMkLst>
+          <pc:docMk/>
+          <pc:sldMk cId="123002105" sldId="665"/>
+        </pc:sldMkLst>
+      </pc:sldChg>
+      <pc:sldChg chg="modSp add del mod">
+        <pc:chgData name="Mohammed Fasha" userId="cc64f42d-a1a6-4f08-b97b-0c37f877119f" providerId="ADAL" clId="{BECD4A7F-C1AF-4585-8C31-FE7D4FE3ED16}" dt="2025-01-05T15:05:12.729" v="1226" actId="21"/>
+        <pc:sldMkLst>
+          <pc:docMk/>
+          <pc:sldMk cId="148099094" sldId="665"/>
+        </pc:sldMkLst>
+      </pc:sldChg>
+      <pc:sldChg chg="del">
+        <pc:chgData name="Mohammed Fasha" userId="cc64f42d-a1a6-4f08-b97b-0c37f877119f" providerId="ADAL" clId="{BECD4A7F-C1AF-4585-8C31-FE7D4FE3ED16}" dt="2025-01-05T14:42:38.675" v="989" actId="2696"/>
+        <pc:sldMkLst>
+          <pc:docMk/>
+          <pc:sldMk cId="659863378" sldId="676"/>
+        </pc:sldMkLst>
+      </pc:sldChg>
+      <pc:sldChg chg="modSp add del mod">
+        <pc:chgData name="Mohammed Fasha" userId="cc64f42d-a1a6-4f08-b97b-0c37f877119f" providerId="ADAL" clId="{BECD4A7F-C1AF-4585-8C31-FE7D4FE3ED16}" dt="2025-01-05T14:55:27.595" v="1130" actId="255"/>
+        <pc:sldMkLst>
+          <pc:docMk/>
+          <pc:sldMk cId="1577854815" sldId="676"/>
+        </pc:sldMkLst>
+      </pc:sldChg>
+      <pc:sldChg chg="modSp add del mod">
+        <pc:chgData name="Mohammed Fasha" userId="cc64f42d-a1a6-4f08-b97b-0c37f877119f" providerId="ADAL" clId="{BECD4A7F-C1AF-4585-8C31-FE7D4FE3ED16}" dt="2025-01-05T14:55:43.754" v="1132" actId="1076"/>
+        <pc:sldMkLst>
+          <pc:docMk/>
+          <pc:sldMk cId="139882925" sldId="677"/>
+        </pc:sldMkLst>
+      </pc:sldChg>
+      <pc:sldChg chg="del">
+        <pc:chgData name="Mohammed Fasha" userId="cc64f42d-a1a6-4f08-b97b-0c37f877119f" providerId="ADAL" clId="{BECD4A7F-C1AF-4585-8C31-FE7D4FE3ED16}" dt="2025-01-05T14:42:38.675" v="989" actId="2696"/>
+        <pc:sldMkLst>
+          <pc:docMk/>
+          <pc:sldMk cId="2736863534" sldId="677"/>
+        </pc:sldMkLst>
+      </pc:sldChg>
+      <pc:sldChg chg="add del">
+        <pc:chgData name="Mohammed Fasha" userId="cc64f42d-a1a6-4f08-b97b-0c37f877119f" providerId="ADAL" clId="{BECD4A7F-C1AF-4585-8C31-FE7D4FE3ED16}" dt="2025-01-05T14:43:16.100" v="993" actId="2696"/>
+        <pc:sldMkLst>
+          <pc:docMk/>
+          <pc:sldMk cId="4146654093" sldId="678"/>
+        </pc:sldMkLst>
+      </pc:sldChg>
+      <pc:sldChg chg="del">
+        <pc:chgData name="Mohammed Fasha" userId="cc64f42d-a1a6-4f08-b97b-0c37f877119f" providerId="ADAL" clId="{BECD4A7F-C1AF-4585-8C31-FE7D4FE3ED16}" dt="2025-01-05T14:42:38.675" v="989" actId="2696"/>
+        <pc:sldMkLst>
+          <pc:docMk/>
+          <pc:sldMk cId="4228312762" sldId="678"/>
+        </pc:sldMkLst>
+      </pc:sldChg>
+      <pc:sldChg chg="del">
+        <pc:chgData name="Mohammed Fasha" userId="cc64f42d-a1a6-4f08-b97b-0c37f877119f" providerId="ADAL" clId="{BECD4A7F-C1AF-4585-8C31-FE7D4FE3ED16}" dt="2025-01-05T14:42:38.675" v="989" actId="2696"/>
+        <pc:sldMkLst>
+          <pc:docMk/>
+          <pc:sldMk cId="581717462" sldId="679"/>
+        </pc:sldMkLst>
+      </pc:sldChg>
+      <pc:sldChg chg="addSp delSp modSp add del mod chgLayout">
+        <pc:chgData name="Mohammed Fasha" userId="cc64f42d-a1a6-4f08-b97b-0c37f877119f" providerId="ADAL" clId="{BECD4A7F-C1AF-4585-8C31-FE7D4FE3ED16}" dt="2025-01-05T16:36:16.605" v="1945" actId="1076"/>
+        <pc:sldMkLst>
+          <pc:docMk/>
+          <pc:sldMk cId="3454522070" sldId="679"/>
+        </pc:sldMkLst>
+      </pc:sldChg>
+      <pc:sldChg chg="add del">
+        <pc:chgData name="Mohammed Fasha" userId="cc64f42d-a1a6-4f08-b97b-0c37f877119f" providerId="ADAL" clId="{BECD4A7F-C1AF-4585-8C31-FE7D4FE3ED16}" dt="2025-01-05T14:43:16.100" v="993" actId="2696"/>
+        <pc:sldMkLst>
+          <pc:docMk/>
+          <pc:sldMk cId="2856814121" sldId="681"/>
+        </pc:sldMkLst>
+      </pc:sldChg>
+      <pc:sldChg chg="del">
+        <pc:chgData name="Mohammed Fasha" userId="cc64f42d-a1a6-4f08-b97b-0c37f877119f" providerId="ADAL" clId="{BECD4A7F-C1AF-4585-8C31-FE7D4FE3ED16}" dt="2025-01-05T14:42:38.675" v="989" actId="2696"/>
+        <pc:sldMkLst>
+          <pc:docMk/>
+          <pc:sldMk cId="3083966018" sldId="681"/>
+        </pc:sldMkLst>
+      </pc:sldChg>
+      <pc:sldChg chg="modSp mod">
+        <pc:chgData name="Mohammed Fasha" userId="cc64f42d-a1a6-4f08-b97b-0c37f877119f" providerId="ADAL" clId="{BECD4A7F-C1AF-4585-8C31-FE7D4FE3ED16}" dt="2025-01-05T14:42:50.596" v="990" actId="14100"/>
+        <pc:sldMkLst>
+          <pc:docMk/>
+          <pc:sldMk cId="1697141369" sldId="695"/>
+        </pc:sldMkLst>
+      </pc:sldChg>
+      <pc:sldChg chg="addSp delSp modSp add del mod">
+        <pc:chgData name="Mohammed Fasha" userId="cc64f42d-a1a6-4f08-b97b-0c37f877119f" providerId="ADAL" clId="{BECD4A7F-C1AF-4585-8C31-FE7D4FE3ED16}" dt="2025-01-05T14:54:31.375" v="1125" actId="14100"/>
+        <pc:sldMkLst>
+          <pc:docMk/>
+          <pc:sldMk cId="265576630" sldId="698"/>
+        </pc:sldMkLst>
+      </pc:sldChg>
+      <pc:sldChg chg="del">
+        <pc:chgData name="Mohammed Fasha" userId="cc64f42d-a1a6-4f08-b97b-0c37f877119f" providerId="ADAL" clId="{BECD4A7F-C1AF-4585-8C31-FE7D4FE3ED16}" dt="2025-01-05T14:42:38.675" v="989" actId="2696"/>
+        <pc:sldMkLst>
+          <pc:docMk/>
+          <pc:sldMk cId="991725834" sldId="698"/>
+        </pc:sldMkLst>
+      </pc:sldChg>
+      <pc:sldChg chg="del">
+        <pc:chgData name="Mohammed Fasha" userId="cc64f42d-a1a6-4f08-b97b-0c37f877119f" providerId="ADAL" clId="{BECD4A7F-C1AF-4585-8C31-FE7D4FE3ED16}" dt="2025-01-05T14:42:38.675" v="989" actId="2696"/>
+        <pc:sldMkLst>
+          <pc:docMk/>
+          <pc:sldMk cId="3109561867" sldId="700"/>
+        </pc:sldMkLst>
+      </pc:sldChg>
+      <pc:sldChg chg="addSp delSp modSp add del mod">
+        <pc:chgData name="Mohammed Fasha" userId="cc64f42d-a1a6-4f08-b97b-0c37f877119f" providerId="ADAL" clId="{BECD4A7F-C1AF-4585-8C31-FE7D4FE3ED16}" dt="2025-01-05T16:00:05.564" v="1529" actId="20577"/>
+        <pc:sldMkLst>
+          <pc:docMk/>
+          <pc:sldMk cId="4247717824" sldId="700"/>
+        </pc:sldMkLst>
+      </pc:sldChg>
+      <pc:sldChg chg="addSp delSp modSp add mod">
+        <pc:chgData name="Mohammed Fasha" userId="cc64f42d-a1a6-4f08-b97b-0c37f877119f" providerId="ADAL" clId="{BECD4A7F-C1AF-4585-8C31-FE7D4FE3ED16}" dt="2025-01-05T14:53:29.185" v="1101" actId="21"/>
+        <pc:sldMkLst>
+          <pc:docMk/>
+          <pc:sldMk cId="67871309" sldId="709"/>
+        </pc:sldMkLst>
+      </pc:sldChg>
+      <pc:sldChg chg="modSp add mod">
+        <pc:chgData name="Mohammed Fasha" userId="cc64f42d-a1a6-4f08-b97b-0c37f877119f" providerId="ADAL" clId="{BECD4A7F-C1AF-4585-8C31-FE7D4FE3ED16}" dt="2025-01-05T15:31:09.113" v="1385" actId="6549"/>
+        <pc:sldMkLst>
+          <pc:docMk/>
+          <pc:sldMk cId="4114896152" sldId="710"/>
+        </pc:sldMkLst>
+      </pc:sldChg>
+      <pc:sldChg chg="addSp modSp add mod">
+        <pc:chgData name="Mohammed Fasha" userId="cc64f42d-a1a6-4f08-b97b-0c37f877119f" providerId="ADAL" clId="{BECD4A7F-C1AF-4585-8C31-FE7D4FE3ED16}" dt="2025-01-05T15:27:36.027" v="1348" actId="20577"/>
+        <pc:sldMkLst>
+          <pc:docMk/>
+          <pc:sldMk cId="3794385322" sldId="711"/>
+        </pc:sldMkLst>
+      </pc:sldChg>
+      <pc:sldChg chg="add del">
+        <pc:chgData name="Mohammed Fasha" userId="cc64f42d-a1a6-4f08-b97b-0c37f877119f" providerId="ADAL" clId="{BECD4A7F-C1AF-4585-8C31-FE7D4FE3ED16}" dt="2025-01-05T14:57:43.613" v="1146" actId="2696"/>
+        <pc:sldMkLst>
+          <pc:docMk/>
+          <pc:sldMk cId="501127302" sldId="712"/>
+        </pc:sldMkLst>
+      </pc:sldChg>
+      <pc:sldChg chg="modSp add mod">
+        <pc:chgData name="Mohammed Fasha" userId="cc64f42d-a1a6-4f08-b97b-0c37f877119f" providerId="ADAL" clId="{BECD4A7F-C1AF-4585-8C31-FE7D4FE3ED16}" dt="2025-01-05T15:32:23.870" v="1388"/>
+        <pc:sldMkLst>
+          <pc:docMk/>
+          <pc:sldMk cId="3701206727" sldId="712"/>
+        </pc:sldMkLst>
+      </pc:sldChg>
+      <pc:sldChg chg="addSp modSp add mod">
+        <pc:chgData name="Mohammed Fasha" userId="cc64f42d-a1a6-4f08-b97b-0c37f877119f" providerId="ADAL" clId="{BECD4A7F-C1AF-4585-8C31-FE7D4FE3ED16}" dt="2025-01-05T16:06:36.028" v="1538" actId="1076"/>
+        <pc:sldMkLst>
+          <pc:docMk/>
+          <pc:sldMk cId="1499972066" sldId="713"/>
+        </pc:sldMkLst>
+      </pc:sldChg>
+      <pc:sldChg chg="addSp delSp modSp add mod">
+        <pc:chgData name="Mohammed Fasha" userId="cc64f42d-a1a6-4f08-b97b-0c37f877119f" providerId="ADAL" clId="{BECD4A7F-C1AF-4585-8C31-FE7D4FE3ED16}" dt="2025-01-05T16:19:08.436" v="1705" actId="1036"/>
+        <pc:sldMkLst>
+          <pc:docMk/>
+          <pc:sldMk cId="1270641495" sldId="714"/>
+        </pc:sldMkLst>
+      </pc:sldChg>
+      <pc:sldChg chg="addSp modSp new mod">
+        <pc:chgData name="Mohammed Fasha" userId="cc64f42d-a1a6-4f08-b97b-0c37f877119f" providerId="ADAL" clId="{BECD4A7F-C1AF-4585-8C31-FE7D4FE3ED16}" dt="2025-01-05T16:23:44.632" v="1736" actId="12"/>
+        <pc:sldMkLst>
+          <pc:docMk/>
+          <pc:sldMk cId="1096386322" sldId="715"/>
+        </pc:sldMkLst>
+      </pc:sldChg>
+      <pc:sldChg chg="modSp new mod">
+        <pc:chgData name="Mohammed Fasha" userId="cc64f42d-a1a6-4f08-b97b-0c37f877119f" providerId="ADAL" clId="{BECD4A7F-C1AF-4585-8C31-FE7D4FE3ED16}" dt="2025-01-05T16:34:02.360" v="1902" actId="27636"/>
+        <pc:sldMkLst>
+          <pc:docMk/>
+          <pc:sldMk cId="1784058309" sldId="716"/>
+        </pc:sldMkLst>
+      </pc:sldChg>
+      <pc:sldChg chg="modSp add mod ord">
+        <pc:chgData name="Mohammed Fasha" userId="cc64f42d-a1a6-4f08-b97b-0c37f877119f" providerId="ADAL" clId="{BECD4A7F-C1AF-4585-8C31-FE7D4FE3ED16}" dt="2025-01-05T16:27:20.520" v="1803"/>
+        <pc:sldMkLst>
+          <pc:docMk/>
+          <pc:sldMk cId="3139017106" sldId="717"/>
+        </pc:sldMkLst>
+      </pc:sldChg>
+      <pc:sldChg chg="addSp delSp modSp new mod">
+        <pc:chgData name="Mohammed Fasha" userId="cc64f42d-a1a6-4f08-b97b-0c37f877119f" providerId="ADAL" clId="{BECD4A7F-C1AF-4585-8C31-FE7D4FE3ED16}" dt="2025-01-05T16:32:45.446" v="1897" actId="20577"/>
+        <pc:sldMkLst>
+          <pc:docMk/>
+          <pc:sldMk cId="3043812923" sldId="718"/>
         </pc:sldMkLst>
       </pc:sldChg>
     </pc:docChg>
@@ -1057,14 +624,6 @@
           <pc:docMk/>
           <pc:sldMk cId="3339445507" sldId="430"/>
         </pc:sldMkLst>
-        <pc:spChg chg="mod">
-          <ac:chgData name="Mohammed Fasha" userId="cc64f42d-a1a6-4f08-b97b-0c37f877119f" providerId="ADAL" clId="{2E5FBF59-3168-4932-9518-582502FE1AD5}" dt="2024-12-03T07:43:58.007" v="456" actId="1076"/>
-          <ac:spMkLst>
-            <pc:docMk/>
-            <pc:sldMk cId="3339445507" sldId="430"/>
-            <ac:spMk id="6" creationId="{750183CC-E7FD-FCCB-B3F0-4ED143848459}"/>
-          </ac:spMkLst>
-        </pc:spChg>
       </pc:sldChg>
       <pc:sldChg chg="modSp">
         <pc:chgData name="Mohammed Fasha" userId="cc64f42d-a1a6-4f08-b97b-0c37f877119f" providerId="ADAL" clId="{2E5FBF59-3168-4932-9518-582502FE1AD5}" dt="2024-12-03T07:45:08.136" v="474" actId="20577"/>
@@ -1072,14 +631,6 @@
           <pc:docMk/>
           <pc:sldMk cId="3389046835" sldId="431"/>
         </pc:sldMkLst>
-        <pc:spChg chg="mod">
-          <ac:chgData name="Mohammed Fasha" userId="cc64f42d-a1a6-4f08-b97b-0c37f877119f" providerId="ADAL" clId="{2E5FBF59-3168-4932-9518-582502FE1AD5}" dt="2024-12-03T07:45:08.136" v="474" actId="20577"/>
-          <ac:spMkLst>
-            <pc:docMk/>
-            <pc:sldMk cId="3389046835" sldId="431"/>
-            <ac:spMk id="3" creationId="{7306AF92-2E41-6AA0-B630-E98522877DBA}"/>
-          </ac:spMkLst>
-        </pc:spChg>
       </pc:sldChg>
       <pc:sldChg chg="modSp">
         <pc:chgData name="Mohammed Fasha" userId="cc64f42d-a1a6-4f08-b97b-0c37f877119f" providerId="ADAL" clId="{2E5FBF59-3168-4932-9518-582502FE1AD5}" dt="2024-11-10T06:33:09.727" v="37" actId="207"/>
@@ -1087,22 +638,6 @@
           <pc:docMk/>
           <pc:sldMk cId="2726994946" sldId="479"/>
         </pc:sldMkLst>
-        <pc:spChg chg="mod">
-          <ac:chgData name="Mohammed Fasha" userId="cc64f42d-a1a6-4f08-b97b-0c37f877119f" providerId="ADAL" clId="{2E5FBF59-3168-4932-9518-582502FE1AD5}" dt="2024-11-10T06:32:42.366" v="35" actId="14100"/>
-          <ac:spMkLst>
-            <pc:docMk/>
-            <pc:sldMk cId="2726994946" sldId="479"/>
-            <ac:spMk id="3" creationId="{0A1BB95E-7496-B5F9-A25D-4BD7DF1EAEBB}"/>
-          </ac:spMkLst>
-        </pc:spChg>
-        <pc:spChg chg="mod">
-          <ac:chgData name="Mohammed Fasha" userId="cc64f42d-a1a6-4f08-b97b-0c37f877119f" providerId="ADAL" clId="{2E5FBF59-3168-4932-9518-582502FE1AD5}" dt="2024-11-10T06:33:09.727" v="37" actId="207"/>
-          <ac:spMkLst>
-            <pc:docMk/>
-            <pc:sldMk cId="2726994946" sldId="479"/>
-            <ac:spMk id="4" creationId="{36F156FD-6D69-7074-DF87-ED201B09AF96}"/>
-          </ac:spMkLst>
-        </pc:spChg>
       </pc:sldChg>
       <pc:sldChg chg="modSp">
         <pc:chgData name="Mohammed Fasha" userId="cc64f42d-a1a6-4f08-b97b-0c37f877119f" providerId="ADAL" clId="{2E5FBF59-3168-4932-9518-582502FE1AD5}" dt="2024-11-19T07:44:28.766" v="211" actId="20577"/>
@@ -1110,14 +645,6 @@
           <pc:docMk/>
           <pc:sldMk cId="2297456757" sldId="483"/>
         </pc:sldMkLst>
-        <pc:spChg chg="mod">
-          <ac:chgData name="Mohammed Fasha" userId="cc64f42d-a1a6-4f08-b97b-0c37f877119f" providerId="ADAL" clId="{2E5FBF59-3168-4932-9518-582502FE1AD5}" dt="2024-11-19T07:44:28.766" v="211" actId="20577"/>
-          <ac:spMkLst>
-            <pc:docMk/>
-            <pc:sldMk cId="2297456757" sldId="483"/>
-            <ac:spMk id="5" creationId="{89403830-E271-DAA0-8838-E295A84A8B5B}"/>
-          </ac:spMkLst>
-        </pc:spChg>
       </pc:sldChg>
       <pc:sldChg chg="modSp">
         <pc:chgData name="Mohammed Fasha" userId="cc64f42d-a1a6-4f08-b97b-0c37f877119f" providerId="ADAL" clId="{2E5FBF59-3168-4932-9518-582502FE1AD5}" dt="2024-11-10T06:45:09.392" v="40" actId="20577"/>
@@ -1125,14 +652,6 @@
           <pc:docMk/>
           <pc:sldMk cId="3474268344" sldId="596"/>
         </pc:sldMkLst>
-        <pc:spChg chg="mod">
-          <ac:chgData name="Mohammed Fasha" userId="cc64f42d-a1a6-4f08-b97b-0c37f877119f" providerId="ADAL" clId="{2E5FBF59-3168-4932-9518-582502FE1AD5}" dt="2024-11-10T06:45:09.392" v="40" actId="20577"/>
-          <ac:spMkLst>
-            <pc:docMk/>
-            <pc:sldMk cId="3474268344" sldId="596"/>
-            <ac:spMk id="3" creationId="{835E72A7-391A-F018-EF29-2D19FF7F7EA9}"/>
-          </ac:spMkLst>
-        </pc:spChg>
       </pc:sldChg>
       <pc:sldChg chg="modSp">
         <pc:chgData name="Mohammed Fasha" userId="cc64f42d-a1a6-4f08-b97b-0c37f877119f" providerId="ADAL" clId="{2E5FBF59-3168-4932-9518-582502FE1AD5}" dt="2024-12-03T07:47:21.561" v="476" actId="6549"/>
@@ -1140,14 +659,6 @@
           <pc:docMk/>
           <pc:sldMk cId="399592497" sldId="613"/>
         </pc:sldMkLst>
-        <pc:spChg chg="mod">
-          <ac:chgData name="Mohammed Fasha" userId="cc64f42d-a1a6-4f08-b97b-0c37f877119f" providerId="ADAL" clId="{2E5FBF59-3168-4932-9518-582502FE1AD5}" dt="2024-12-03T07:47:21.561" v="476" actId="6549"/>
-          <ac:spMkLst>
-            <pc:docMk/>
-            <pc:sldMk cId="399592497" sldId="613"/>
-            <ac:spMk id="3" creationId="{C1943909-B67F-2AFB-1222-ADB4F344CF2F}"/>
-          </ac:spMkLst>
-        </pc:spChg>
       </pc:sldChg>
       <pc:sldChg chg="modSp">
         <pc:chgData name="Mohammed Fasha" userId="cc64f42d-a1a6-4f08-b97b-0c37f877119f" providerId="ADAL" clId="{2E5FBF59-3168-4932-9518-582502FE1AD5}" dt="2024-12-03T07:49:02.980" v="478" actId="207"/>
@@ -1155,14 +666,6 @@
           <pc:docMk/>
           <pc:sldMk cId="3329135496" sldId="617"/>
         </pc:sldMkLst>
-        <pc:spChg chg="mod">
-          <ac:chgData name="Mohammed Fasha" userId="cc64f42d-a1a6-4f08-b97b-0c37f877119f" providerId="ADAL" clId="{2E5FBF59-3168-4932-9518-582502FE1AD5}" dt="2024-12-03T07:49:02.980" v="478" actId="207"/>
-          <ac:spMkLst>
-            <pc:docMk/>
-            <pc:sldMk cId="3329135496" sldId="617"/>
-            <ac:spMk id="6" creationId="{6CA8942A-EF4D-5560-122D-DA3EDEA30CF7}"/>
-          </ac:spMkLst>
-        </pc:spChg>
       </pc:sldChg>
       <pc:sldChg chg="modSp">
         <pc:chgData name="Mohammed Fasha" userId="cc64f42d-a1a6-4f08-b97b-0c37f877119f" providerId="ADAL" clId="{2E5FBF59-3168-4932-9518-582502FE1AD5}" dt="2024-12-24T08:05:16.608" v="482" actId="403"/>
@@ -1170,14 +673,6 @@
           <pc:docMk/>
           <pc:sldMk cId="2990045589" sldId="659"/>
         </pc:sldMkLst>
-        <pc:spChg chg="mod">
-          <ac:chgData name="Mohammed Fasha" userId="cc64f42d-a1a6-4f08-b97b-0c37f877119f" providerId="ADAL" clId="{2E5FBF59-3168-4932-9518-582502FE1AD5}" dt="2024-12-24T08:05:16.608" v="482" actId="403"/>
-          <ac:spMkLst>
-            <pc:docMk/>
-            <pc:sldMk cId="2990045589" sldId="659"/>
-            <ac:spMk id="3" creationId="{DDB8F6FE-FF12-0BA5-D224-71F068E4DF88}"/>
-          </ac:spMkLst>
-        </pc:spChg>
       </pc:sldChg>
       <pc:sldChg chg="modSp">
         <pc:chgData name="Mohammed Fasha" userId="cc64f42d-a1a6-4f08-b97b-0c37f877119f" providerId="ADAL" clId="{2E5FBF59-3168-4932-9518-582502FE1AD5}" dt="2024-12-24T08:08:19.987" v="550" actId="20577"/>
@@ -1185,14 +680,6 @@
           <pc:docMk/>
           <pc:sldMk cId="2680231355" sldId="669"/>
         </pc:sldMkLst>
-        <pc:spChg chg="mod">
-          <ac:chgData name="Mohammed Fasha" userId="cc64f42d-a1a6-4f08-b97b-0c37f877119f" providerId="ADAL" clId="{2E5FBF59-3168-4932-9518-582502FE1AD5}" dt="2024-12-24T08:08:19.987" v="550" actId="20577"/>
-          <ac:spMkLst>
-            <pc:docMk/>
-            <pc:sldMk cId="2680231355" sldId="669"/>
-            <ac:spMk id="9" creationId="{33559B29-4771-A9F7-E7CA-D37CB72E62CF}"/>
-          </ac:spMkLst>
-        </pc:spChg>
       </pc:sldChg>
       <pc:sldChg chg="addSp modSp">
         <pc:chgData name="Mohammed Fasha" userId="cc64f42d-a1a6-4f08-b97b-0c37f877119f" providerId="ADAL" clId="{2E5FBF59-3168-4932-9518-582502FE1AD5}" dt="2024-12-24T08:05:52.910" v="488" actId="1076"/>
@@ -1200,14 +687,6 @@
           <pc:docMk/>
           <pc:sldMk cId="916102856" sldId="685"/>
         </pc:sldMkLst>
-        <pc:picChg chg="add mod">
-          <ac:chgData name="Mohammed Fasha" userId="cc64f42d-a1a6-4f08-b97b-0c37f877119f" providerId="ADAL" clId="{2E5FBF59-3168-4932-9518-582502FE1AD5}" dt="2024-12-24T08:05:52.910" v="488" actId="1076"/>
-          <ac:picMkLst>
-            <pc:docMk/>
-            <pc:sldMk cId="916102856" sldId="685"/>
-            <ac:picMk id="1026" creationId="{4777CF26-0F99-41D1-84BC-BEB619F5AAA3}"/>
-          </ac:picMkLst>
-        </pc:picChg>
       </pc:sldChg>
       <pc:sldChg chg="modSp">
         <pc:chgData name="Mohammed Fasha" userId="cc64f42d-a1a6-4f08-b97b-0c37f877119f" providerId="ADAL" clId="{2E5FBF59-3168-4932-9518-582502FE1AD5}" dt="2024-11-19T07:03:29.557" v="206" actId="207"/>
@@ -1215,22 +694,6 @@
           <pc:docMk/>
           <pc:sldMk cId="32004852" sldId="708"/>
         </pc:sldMkLst>
-        <pc:spChg chg="mod">
-          <ac:chgData name="Mohammed Fasha" userId="cc64f42d-a1a6-4f08-b97b-0c37f877119f" providerId="ADAL" clId="{2E5FBF59-3168-4932-9518-582502FE1AD5}" dt="2024-11-19T07:03:29.557" v="206" actId="207"/>
-          <ac:spMkLst>
-            <pc:docMk/>
-            <pc:sldMk cId="32004852" sldId="708"/>
-            <ac:spMk id="4" creationId="{5C57822E-9052-4E30-99C6-E3BB69F76727}"/>
-          </ac:spMkLst>
-        </pc:spChg>
-        <pc:picChg chg="mod">
-          <ac:chgData name="Mohammed Fasha" userId="cc64f42d-a1a6-4f08-b97b-0c37f877119f" providerId="ADAL" clId="{2E5FBF59-3168-4932-9518-582502FE1AD5}" dt="2024-11-19T06:57:59.649" v="103" actId="1076"/>
-          <ac:picMkLst>
-            <pc:docMk/>
-            <pc:sldMk cId="32004852" sldId="708"/>
-            <ac:picMk id="5" creationId="{A6BFBA45-17BB-4116-9DA7-D90F19156FD1}"/>
-          </ac:picMkLst>
-        </pc:picChg>
       </pc:sldChg>
     </pc:docChg>
   </pc:docChgLst>
@@ -1254,15 +717,6 @@
             <pc:sldMasterMk cId="742811419" sldId="2147483648"/>
             <pc:sldLayoutMk cId="4063788262" sldId="2147483649"/>
           </pc:sldLayoutMkLst>
-          <pc:picChg chg="add mod">
-            <ac:chgData name="Mohammed Fasha" userId="cc64f42d-a1a6-4f08-b97b-0c37f877119f" providerId="ADAL" clId="{6804A8E6-8D7F-46E3-B091-66A8F6B926BF}" dt="2024-11-09T05:15:35.019" v="2" actId="1076"/>
-            <ac:picMkLst>
-              <pc:docMk/>
-              <pc:sldMasterMk cId="742811419" sldId="2147483648"/>
-              <pc:sldLayoutMk cId="4063788262" sldId="2147483649"/>
-              <ac:picMk id="7" creationId="{F5615635-BBAD-7E56-C59A-73312B1693C8}"/>
-            </ac:picMkLst>
-          </pc:picChg>
         </pc:sldLayoutChg>
       </pc:sldMasterChg>
     </pc:docChg>
@@ -1684,14 +1138,6 @@
             <ac:spMk id="3" creationId="{B7528FB2-87E2-1D21-8D90-2EFD9759E534}"/>
           </ac:spMkLst>
         </pc:spChg>
-        <pc:picChg chg="add del mod">
-          <ac:chgData name="Mohammed Fasha" userId="S::mohammed.fasha@uop.edu.jo::cc64f42d-a1a6-4f08-b97b-0c37f877119f" providerId="AD" clId="Web-{66E75AB1-FCE8-0FCD-8995-E220AF9681CC}" dt="2025-03-15T06:57:27.238" v="152"/>
-          <ac:picMkLst>
-            <pc:docMk/>
-            <pc:sldMk cId="1674895679" sldId="457"/>
-            <ac:picMk id="4" creationId="{A3858177-300E-7078-A3BC-8E4C7D8BA9AF}"/>
-          </ac:picMkLst>
-        </pc:picChg>
         <pc:picChg chg="add mod">
           <ac:chgData name="Mohammed Fasha" userId="S::mohammed.fasha@uop.edu.jo::cc64f42d-a1a6-4f08-b97b-0c37f877119f" providerId="AD" clId="Web-{66E75AB1-FCE8-0FCD-8995-E220AF9681CC}" dt="2025-03-15T06:57:53.787" v="154" actId="1076"/>
           <ac:picMkLst>
@@ -1875,14 +1321,6 @@
             <ac:spMk id="7" creationId="{35A5277C-1397-7A8F-6AC4-A6499E15E61D}"/>
           </ac:spMkLst>
         </pc:spChg>
-        <pc:picChg chg="add del mod">
-          <ac:chgData name="Mohammed Fasha" userId="S::mohammed.fasha@uop.edu.jo::cc64f42d-a1a6-4f08-b97b-0c37f877119f" providerId="AD" clId="Web-{66E75AB1-FCE8-0FCD-8995-E220AF9681CC}" dt="2025-03-15T07:05:59.457" v="282"/>
-          <ac:picMkLst>
-            <pc:docMk/>
-            <pc:sldMk cId="1157240725" sldId="462"/>
-            <ac:picMk id="4" creationId="{51D19A64-1161-EC4F-4689-31E54D8932DA}"/>
-          </ac:picMkLst>
-        </pc:picChg>
         <pc:picChg chg="add mod">
           <ac:chgData name="Mohammed Fasha" userId="S::mohammed.fasha@uop.edu.jo::cc64f42d-a1a6-4f08-b97b-0c37f877119f" providerId="AD" clId="Web-{66E75AB1-FCE8-0FCD-8995-E220AF9681CC}" dt="2025-03-15T07:09:35.299" v="331" actId="1076"/>
           <ac:picMkLst>
@@ -2234,7 +1672,7 @@
           <a:p>
             <a:fld id="{13BA03A4-B9F1-404C-8A74-B1AFD6480953}" type="datetimeFigureOut">
               <a:rPr lang="en-US" smtClean="0"/>
-              <a:t>3/15/2025</a:t>
+              <a:t>3/18/2025</a:t>
             </a:fld>
             <a:endParaRPr lang="en-US"/>
           </a:p>
@@ -2648,7 +2086,7 @@
           <a:p>
             <a:fld id="{0DB78E95-DE77-44D3-BDB9-E242948FB112}" type="datetimeFigureOut">
               <a:rPr lang="en-US" smtClean="0"/>
-              <a:t>3/15/2025</a:t>
+              <a:t>3/18/2025</a:t>
             </a:fld>
             <a:endParaRPr lang="en-US"/>
           </a:p>
@@ -2876,7 +2314,7 @@
           <a:p>
             <a:fld id="{0DB78E95-DE77-44D3-BDB9-E242948FB112}" type="datetimeFigureOut">
               <a:rPr lang="en-US" smtClean="0"/>
-              <a:t>3/15/2025</a:t>
+              <a:t>3/18/2025</a:t>
             </a:fld>
             <a:endParaRPr lang="en-US"/>
           </a:p>
@@ -3084,7 +2522,7 @@
           <a:p>
             <a:fld id="{0DB78E95-DE77-44D3-BDB9-E242948FB112}" type="datetimeFigureOut">
               <a:rPr lang="en-US" smtClean="0"/>
-              <a:t>3/15/2025</a:t>
+              <a:t>3/18/2025</a:t>
             </a:fld>
             <a:endParaRPr lang="en-US"/>
           </a:p>
@@ -3515,7 +2953,7 @@
           <a:p>
             <a:fld id="{0DB78E95-DE77-44D3-BDB9-E242948FB112}" type="datetimeFigureOut">
               <a:rPr lang="en-US" smtClean="0"/>
-              <a:t>3/15/2025</a:t>
+              <a:t>3/18/2025</a:t>
             </a:fld>
             <a:endParaRPr lang="en-US"/>
           </a:p>
@@ -3894,7 +3332,7 @@
           <a:p>
             <a:fld id="{0DB78E95-DE77-44D3-BDB9-E242948FB112}" type="datetimeFigureOut">
               <a:rPr lang="en-US" smtClean="0"/>
-              <a:t>3/15/2025</a:t>
+              <a:t>3/18/2025</a:t>
             </a:fld>
             <a:endParaRPr lang="en-US"/>
           </a:p>
@@ -4306,7 +3744,7 @@
           <a:p>
             <a:fld id="{0DB78E95-DE77-44D3-BDB9-E242948FB112}" type="datetimeFigureOut">
               <a:rPr lang="en-US" smtClean="0"/>
-              <a:t>3/15/2025</a:t>
+              <a:t>3/18/2025</a:t>
             </a:fld>
             <a:endParaRPr lang="en-US"/>
           </a:p>
@@ -4447,7 +3885,7 @@
           <a:p>
             <a:fld id="{0DB78E95-DE77-44D3-BDB9-E242948FB112}" type="datetimeFigureOut">
               <a:rPr lang="en-US" smtClean="0"/>
-              <a:t>3/15/2025</a:t>
+              <a:t>3/18/2025</a:t>
             </a:fld>
             <a:endParaRPr lang="en-US"/>
           </a:p>
@@ -4560,7 +3998,7 @@
           <a:p>
             <a:fld id="{0DB78E95-DE77-44D3-BDB9-E242948FB112}" type="datetimeFigureOut">
               <a:rPr lang="en-US" smtClean="0"/>
-              <a:t>3/15/2025</a:t>
+              <a:t>3/18/2025</a:t>
             </a:fld>
             <a:endParaRPr lang="en-US"/>
           </a:p>
@@ -4871,7 +4309,7 @@
           <a:p>
             <a:fld id="{0DB78E95-DE77-44D3-BDB9-E242948FB112}" type="datetimeFigureOut">
               <a:rPr lang="en-US" smtClean="0"/>
-              <a:t>3/15/2025</a:t>
+              <a:t>3/18/2025</a:t>
             </a:fld>
             <a:endParaRPr lang="en-US"/>
           </a:p>
@@ -5159,7 +4597,7 @@
           <a:p>
             <a:fld id="{0DB78E95-DE77-44D3-BDB9-E242948FB112}" type="datetimeFigureOut">
               <a:rPr lang="en-US" smtClean="0"/>
-              <a:t>3/15/2025</a:t>
+              <a:t>3/18/2025</a:t>
             </a:fld>
             <a:endParaRPr lang="en-US"/>
           </a:p>
@@ -5400,7 +4838,7 @@
           <a:p>
             <a:fld id="{0DB78E95-DE77-44D3-BDB9-E242948FB112}" type="datetimeFigureOut">
               <a:rPr lang="en-US" smtClean="0"/>
-              <a:t>3/15/2025</a:t>
+              <a:t>3/18/2025</a:t>
             </a:fld>
             <a:endParaRPr lang="en-US"/>
           </a:p>
@@ -6035,6 +5473,430 @@
         <p:cNvPr id="1" name="">
           <a:extLst>
             <a:ext uri="{FF2B5EF4-FFF2-40B4-BE49-F238E27FC236}">
+              <a16:creationId xmlns:a16="http://schemas.microsoft.com/office/drawing/2014/main" id="{F9B0DD7F-7DC3-8CC9-C0F0-1647D96B8866}"/>
+            </a:ext>
+          </a:extLst>
+        </p:cNvPr>
+        <p:cNvGrpSpPr/>
+        <p:nvPr/>
+      </p:nvGrpSpPr>
+      <p:grpSpPr>
+        <a:xfrm>
+          <a:off x="0" y="0"/>
+          <a:ext cx="0" cy="0"/>
+          <a:chOff x="0" y="0"/>
+          <a:chExt cx="0" cy="0"/>
+        </a:xfrm>
+      </p:grpSpPr>
+      <p:sp>
+        <p:nvSpPr>
+          <p:cNvPr id="2" name="Title 1">
+            <a:extLst>
+              <a:ext uri="{FF2B5EF4-FFF2-40B4-BE49-F238E27FC236}">
+                <a16:creationId xmlns:a16="http://schemas.microsoft.com/office/drawing/2014/main" id="{51944489-C96E-64DA-01C7-8148E0CFAA33}"/>
+              </a:ext>
+            </a:extLst>
+          </p:cNvPr>
+          <p:cNvSpPr>
+            <a:spLocks noGrp="1"/>
+          </p:cNvSpPr>
+          <p:nvPr>
+            <p:ph type="title"/>
+          </p:nvPr>
+        </p:nvSpPr>
+        <p:spPr/>
+        <p:txBody>
+          <a:bodyPr/>
+          <a:lstStyle/>
+          <a:p>
+            <a:endParaRPr lang="en-US"/>
+          </a:p>
+        </p:txBody>
+      </p:sp>
+      <p:sp>
+        <p:nvSpPr>
+          <p:cNvPr id="3" name="Content Placeholder 2">
+            <a:extLst>
+              <a:ext uri="{FF2B5EF4-FFF2-40B4-BE49-F238E27FC236}">
+                <a16:creationId xmlns:a16="http://schemas.microsoft.com/office/drawing/2014/main" id="{891DCAA0-5A3F-EEBE-021E-8D9D6B92B64A}"/>
+              </a:ext>
+            </a:extLst>
+          </p:cNvPr>
+          <p:cNvSpPr>
+            <a:spLocks noGrp="1"/>
+          </p:cNvSpPr>
+          <p:nvPr>
+            <p:ph idx="1"/>
+          </p:nvPr>
+        </p:nvSpPr>
+        <p:spPr/>
+        <p:txBody>
+          <a:bodyPr vert="horz" lIns="91440" tIns="45720" rIns="91440" bIns="45720" rtlCol="0" anchor="t">
+            <a:normAutofit/>
+          </a:bodyPr>
+          <a:lstStyle/>
+          <a:p>
+            <a:r>
+              <a:rPr lang="en-US" sz="1400" dirty="0">
+                <a:solidFill>
+                  <a:srgbClr val="222222"/>
+                </a:solidFill>
+                <a:latin typeface="Helvetica"/>
+                <a:cs typeface="Helvetica"/>
+              </a:rPr>
+              <a:t>By design, a RNN takes two inputs at each time step: an input (in the case of the encoder, one word from the input sentence), and a hidden state. </a:t>
+            </a:r>
+            <a:endParaRPr lang="en-US" dirty="0">
+              <a:solidFill>
+                <a:srgbClr val="000000"/>
+              </a:solidFill>
+              <a:latin typeface="Calibri" panose="020F0502020204030204"/>
+              <a:ea typeface="Calibri" panose="020F0502020204030204"/>
+              <a:cs typeface="Calibri" panose="020F0502020204030204"/>
+            </a:endParaRPr>
+          </a:p>
+          <a:p>
+            <a:r>
+              <a:rPr lang="en-US" sz="1400" dirty="0">
+                <a:solidFill>
+                  <a:srgbClr val="222222"/>
+                </a:solidFill>
+                <a:latin typeface="Helvetica"/>
+                <a:cs typeface="Helvetica"/>
+              </a:rPr>
+              <a:t>The word, however, needs to be represented by a vector. </a:t>
+            </a:r>
+            <a:endParaRPr lang="en-US" dirty="0">
+              <a:solidFill>
+                <a:srgbClr val="000000"/>
+              </a:solidFill>
+              <a:latin typeface="Calibri" panose="020F0502020204030204"/>
+              <a:ea typeface="Calibri"/>
+              <a:cs typeface="Calibri"/>
+            </a:endParaRPr>
+          </a:p>
+          <a:p>
+            <a:r>
+              <a:rPr lang="en-US" sz="1400" dirty="0">
+                <a:solidFill>
+                  <a:srgbClr val="222222"/>
+                </a:solidFill>
+                <a:latin typeface="Helvetica"/>
+                <a:cs typeface="Helvetica"/>
+              </a:rPr>
+              <a:t>To transform a word into a vector, we turn to the class of methods called “</a:t>
+            </a:r>
+            <a:r>
+              <a:rPr lang="en-US" sz="1400" dirty="0">
+                <a:solidFill>
+                  <a:srgbClr val="4183C4"/>
+                </a:solidFill>
+                <a:latin typeface="Helvetica"/>
+                <a:cs typeface="Helvetica"/>
+                <a:hlinkClick r:id="rId2"/>
+              </a:rPr>
+              <a:t>word embedding</a:t>
+            </a:r>
+            <a:r>
+              <a:rPr lang="en-US" sz="1400" dirty="0">
+                <a:solidFill>
+                  <a:srgbClr val="222222"/>
+                </a:solidFill>
+                <a:latin typeface="Helvetica"/>
+                <a:cs typeface="Helvetica"/>
+              </a:rPr>
+              <a:t>” algorithms. </a:t>
+            </a:r>
+            <a:endParaRPr lang="en-US">
+              <a:solidFill>
+                <a:srgbClr val="000000"/>
+              </a:solidFill>
+              <a:latin typeface="Calibri" panose="020F0502020204030204"/>
+              <a:ea typeface="Calibri"/>
+              <a:cs typeface="Calibri"/>
+            </a:endParaRPr>
+          </a:p>
+          <a:p>
+            <a:r>
+              <a:rPr lang="en-US" sz="1400" dirty="0">
+                <a:solidFill>
+                  <a:srgbClr val="222222"/>
+                </a:solidFill>
+                <a:latin typeface="Helvetica"/>
+                <a:cs typeface="Helvetica"/>
+              </a:rPr>
+              <a:t>These turn words into vector spaces that capture a lot of the meaning/semantic information of the words (e.g. </a:t>
+            </a:r>
+            <a:r>
+              <a:rPr lang="en-US" sz="1400" dirty="0">
+                <a:solidFill>
+                  <a:srgbClr val="4183C4"/>
+                </a:solidFill>
+                <a:latin typeface="Helvetica"/>
+                <a:cs typeface="Helvetica"/>
+                <a:hlinkClick r:id="rId3"/>
+              </a:rPr>
+              <a:t>king - man + woman = queen</a:t>
+            </a:r>
+            <a:r>
+              <a:rPr lang="en-US" sz="1400" dirty="0">
+                <a:solidFill>
+                  <a:srgbClr val="222222"/>
+                </a:solidFill>
+                <a:latin typeface="Helvetica"/>
+                <a:cs typeface="Helvetica"/>
+              </a:rPr>
+              <a:t>).</a:t>
+            </a:r>
+            <a:endParaRPr lang="en-US">
+              <a:ea typeface="Calibri"/>
+              <a:cs typeface="Calibri"/>
+            </a:endParaRPr>
+          </a:p>
+        </p:txBody>
+      </p:sp>
+      <p:pic>
+        <p:nvPicPr>
+          <p:cNvPr id="4" name="Picture 3" descr="A group of numbers in green squares&#10;&#10;AI-generated content may be incorrect.">
+            <a:extLst>
+              <a:ext uri="{FF2B5EF4-FFF2-40B4-BE49-F238E27FC236}">
+                <a16:creationId xmlns:a16="http://schemas.microsoft.com/office/drawing/2014/main" id="{76C95208-81C7-5CF3-E454-2C18A3F25FC0}"/>
+              </a:ext>
+            </a:extLst>
+          </p:cNvPr>
+          <p:cNvPicPr>
+            <a:picLocks noChangeAspect="1"/>
+          </p:cNvPicPr>
+          <p:nvPr/>
+        </p:nvPicPr>
+        <p:blipFill>
+          <a:blip r:embed="rId4"/>
+          <a:stretch>
+            <a:fillRect/>
+          </a:stretch>
+        </p:blipFill>
+        <p:spPr>
+          <a:xfrm>
+            <a:off x="3227374" y="3332201"/>
+            <a:ext cx="5750737" cy="1879438"/>
+          </a:xfrm>
+          <a:prstGeom prst="rect">
+            <a:avLst/>
+          </a:prstGeom>
+        </p:spPr>
+      </p:pic>
+      <p:sp>
+        <p:nvSpPr>
+          <p:cNvPr id="5" name="TextBox 4">
+            <a:extLst>
+              <a:ext uri="{FF2B5EF4-FFF2-40B4-BE49-F238E27FC236}">
+                <a16:creationId xmlns:a16="http://schemas.microsoft.com/office/drawing/2014/main" id="{0EE62ADA-E312-FE03-63AA-32558CEA7F2B}"/>
+              </a:ext>
+            </a:extLst>
+          </p:cNvPr>
+          <p:cNvSpPr txBox="1"/>
+          <p:nvPr/>
+        </p:nvSpPr>
+        <p:spPr>
+          <a:xfrm>
+            <a:off x="2687904" y="5837055"/>
+            <a:ext cx="7679341" cy="646331"/>
+          </a:xfrm>
+          <a:prstGeom prst="rect">
+            <a:avLst/>
+          </a:prstGeom>
+          <a:noFill/>
+        </p:spPr>
+        <p:txBody>
+          <a:bodyPr rot="0" spcFirstLastPara="0" vertOverflow="overflow" horzOverflow="overflow" vert="horz" wrap="square" lIns="91440" tIns="45720" rIns="91440" bIns="45720" numCol="1" spcCol="0" rtlCol="0" fromWordArt="0" anchor="t" anchorCtr="0" forceAA="0" compatLnSpc="1">
+            <a:prstTxWarp prst="textNoShape">
+              <a:avLst/>
+            </a:prstTxWarp>
+            <a:spAutoFit/>
+          </a:bodyPr>
+          <a:lstStyle/>
+          <a:p>
+            <a:r>
+              <a:rPr lang="en-US" sz="1200" dirty="0">
+                <a:solidFill>
+                  <a:srgbClr val="999999"/>
+                </a:solidFill>
+                <a:highlight>
+                  <a:srgbClr val="FFFFFF"/>
+                </a:highlight>
+                <a:latin typeface="Helvetica"/>
+                <a:cs typeface="Helvetica"/>
+              </a:rPr>
+              <a:t>We need to turn the input words into vectors before processing them. That transformation is done using a </a:t>
+            </a:r>
+            <a:r>
+              <a:rPr lang="en-US" sz="1200" dirty="0">
+                <a:solidFill>
+                  <a:srgbClr val="4183C4"/>
+                </a:solidFill>
+                <a:highlight>
+                  <a:srgbClr val="FFFFFF"/>
+                </a:highlight>
+                <a:latin typeface="Helvetica"/>
+                <a:cs typeface="Helvetica"/>
+                <a:hlinkClick r:id="rId5"/>
+              </a:rPr>
+              <a:t>word embedding</a:t>
+            </a:r>
+            <a:r>
+              <a:rPr lang="en-US" sz="1200" dirty="0">
+                <a:solidFill>
+                  <a:srgbClr val="999999"/>
+                </a:solidFill>
+                <a:highlight>
+                  <a:srgbClr val="FFFFFF"/>
+                </a:highlight>
+                <a:latin typeface="Helvetica"/>
+                <a:cs typeface="Helvetica"/>
+              </a:rPr>
+              <a:t> algorithm. We can use </a:t>
+            </a:r>
+            <a:r>
+              <a:rPr lang="en-US" sz="1200" dirty="0">
+                <a:solidFill>
+                  <a:srgbClr val="4183C4"/>
+                </a:solidFill>
+                <a:highlight>
+                  <a:srgbClr val="FFFFFF"/>
+                </a:highlight>
+                <a:latin typeface="Helvetica"/>
+                <a:cs typeface="Helvetica"/>
+                <a:hlinkClick r:id="rId6"/>
+              </a:rPr>
+              <a:t>pre-trained embeddings</a:t>
+            </a:r>
+            <a:r>
+              <a:rPr lang="en-US" sz="1200" dirty="0">
+                <a:solidFill>
+                  <a:srgbClr val="999999"/>
+                </a:solidFill>
+                <a:highlight>
+                  <a:srgbClr val="FFFFFF"/>
+                </a:highlight>
+                <a:latin typeface="Helvetica"/>
+                <a:cs typeface="Helvetica"/>
+              </a:rPr>
+              <a:t> or train our own embedding on our dataset. Embedding vectors of size 200 or 300 are typical, we're showing a vector of size four for simplicity.</a:t>
+            </a:r>
+            <a:endParaRPr lang="en-US" sz="1200" dirty="0">
+              <a:ea typeface="Calibri"/>
+              <a:cs typeface="Calibri"/>
+            </a:endParaRPr>
+          </a:p>
+        </p:txBody>
+      </p:sp>
+    </p:spTree>
+    <p:extLst>
+      <p:ext uri="{BB962C8B-B14F-4D97-AF65-F5344CB8AC3E}">
+        <p14:creationId xmlns:p14="http://schemas.microsoft.com/office/powerpoint/2010/main" val="2617340595"/>
+      </p:ext>
+    </p:extLst>
+  </p:cSld>
+  <p:clrMapOvr>
+    <a:masterClrMapping/>
+  </p:clrMapOvr>
+</p:sld>
+</file>
+
+<file path=ppt/slides/slide11.xml><?xml version="1.0" encoding="utf-8"?>
+<p:sld xmlns:a="http://schemas.openxmlformats.org/drawingml/2006/main" xmlns:r="http://schemas.openxmlformats.org/officeDocument/2006/relationships" xmlns:p="http://schemas.openxmlformats.org/presentationml/2006/main">
+  <p:cSld>
+    <p:spTree>
+      <p:nvGrpSpPr>
+        <p:cNvPr id="1" name="">
+          <a:extLst>
+            <a:ext uri="{FF2B5EF4-FFF2-40B4-BE49-F238E27FC236}">
+              <a16:creationId xmlns:a16="http://schemas.microsoft.com/office/drawing/2014/main" id="{EE106451-7A3A-9597-7660-A77AE45B0304}"/>
+            </a:ext>
+          </a:extLst>
+        </p:cNvPr>
+        <p:cNvGrpSpPr/>
+        <p:nvPr/>
+      </p:nvGrpSpPr>
+      <p:grpSpPr>
+        <a:xfrm>
+          <a:off x="0" y="0"/>
+          <a:ext cx="0" cy="0"/>
+          <a:chOff x="0" y="0"/>
+          <a:chExt cx="0" cy="0"/>
+        </a:xfrm>
+      </p:grpSpPr>
+      <p:sp>
+        <p:nvSpPr>
+          <p:cNvPr id="2" name="Title 1">
+            <a:extLst>
+              <a:ext uri="{FF2B5EF4-FFF2-40B4-BE49-F238E27FC236}">
+                <a16:creationId xmlns:a16="http://schemas.microsoft.com/office/drawing/2014/main" id="{652E3FBD-A8EC-A535-0F43-B16F175A37BE}"/>
+              </a:ext>
+            </a:extLst>
+          </p:cNvPr>
+          <p:cNvSpPr>
+            <a:spLocks noGrp="1"/>
+          </p:cNvSpPr>
+          <p:nvPr>
+            <p:ph type="title"/>
+          </p:nvPr>
+        </p:nvSpPr>
+        <p:spPr/>
+        <p:txBody>
+          <a:bodyPr/>
+          <a:lstStyle/>
+          <a:p>
+            <a:endParaRPr lang="en-US"/>
+          </a:p>
+        </p:txBody>
+      </p:sp>
+      <p:sp>
+        <p:nvSpPr>
+          <p:cNvPr id="3" name="Content Placeholder 2">
+            <a:extLst>
+              <a:ext uri="{FF2B5EF4-FFF2-40B4-BE49-F238E27FC236}">
+                <a16:creationId xmlns:a16="http://schemas.microsoft.com/office/drawing/2014/main" id="{ADF9EE4F-F63A-9666-F6DF-B1E9BFF482B4}"/>
+              </a:ext>
+            </a:extLst>
+          </p:cNvPr>
+          <p:cNvSpPr>
+            <a:spLocks noGrp="1"/>
+          </p:cNvSpPr>
+          <p:nvPr>
+            <p:ph idx="1"/>
+          </p:nvPr>
+        </p:nvSpPr>
+        <p:spPr/>
+        <p:txBody>
+          <a:bodyPr/>
+          <a:lstStyle/>
+          <a:p>
+            <a:endParaRPr lang="en-US"/>
+          </a:p>
+        </p:txBody>
+      </p:sp>
+    </p:spTree>
+    <p:extLst>
+      <p:ext uri="{BB962C8B-B14F-4D97-AF65-F5344CB8AC3E}">
+        <p14:creationId xmlns:p14="http://schemas.microsoft.com/office/powerpoint/2010/main" val="2675381745"/>
+      </p:ext>
+    </p:extLst>
+  </p:cSld>
+  <p:clrMapOvr>
+    <a:masterClrMapping/>
+  </p:clrMapOvr>
+</p:sld>
+</file>
+
+<file path=ppt/slides/slide12.xml><?xml version="1.0" encoding="utf-8"?>
+<p:sld xmlns:a="http://schemas.openxmlformats.org/drawingml/2006/main" xmlns:r="http://schemas.openxmlformats.org/officeDocument/2006/relationships" xmlns:p="http://schemas.openxmlformats.org/presentationml/2006/main">
+  <p:cSld>
+    <p:spTree>
+      <p:nvGrpSpPr>
+        <p:cNvPr id="1" name="">
+          <a:extLst>
+            <a:ext uri="{FF2B5EF4-FFF2-40B4-BE49-F238E27FC236}">
               <a16:creationId xmlns:a16="http://schemas.microsoft.com/office/drawing/2014/main" id="{73FEC29F-8B32-2D99-5511-B01BC15C2646}"/>
             </a:ext>
           </a:extLst>
@@ -6113,7 +5975,7 @@
 </p:sld>
 </file>
 
-<file path=ppt/slides/slide11.xml><?xml version="1.0" encoding="utf-8"?>
+<file path=ppt/slides/slide13.xml><?xml version="1.0" encoding="utf-8"?>
 <p:sld xmlns:a="http://schemas.openxmlformats.org/drawingml/2006/main" xmlns:r="http://schemas.openxmlformats.org/officeDocument/2006/relationships" xmlns:p="http://schemas.openxmlformats.org/presentationml/2006/main">
   <p:cSld>
     <p:spTree>
@@ -6199,7 +6061,7 @@
 </p:sld>
 </file>
 
-<file path=ppt/slides/slide12.xml><?xml version="1.0" encoding="utf-8"?>
+<file path=ppt/slides/slide14.xml><?xml version="1.0" encoding="utf-8"?>
 <p:sld xmlns:a="http://schemas.openxmlformats.org/drawingml/2006/main" xmlns:r="http://schemas.openxmlformats.org/officeDocument/2006/relationships" xmlns:p="http://schemas.openxmlformats.org/presentationml/2006/main">
   <p:cSld>
     <p:spTree>
@@ -6285,7 +6147,7 @@
 </p:sld>
 </file>
 
-<file path=ppt/slides/slide13.xml><?xml version="1.0" encoding="utf-8"?>
+<file path=ppt/slides/slide15.xml><?xml version="1.0" encoding="utf-8"?>
 <p:sld xmlns:a="http://schemas.openxmlformats.org/drawingml/2006/main" xmlns:r="http://schemas.openxmlformats.org/officeDocument/2006/relationships" xmlns:p="http://schemas.openxmlformats.org/presentationml/2006/main">
   <p:cSld>
     <p:spTree>
@@ -6371,7 +6233,7 @@
 </p:sld>
 </file>
 
-<file path=ppt/slides/slide14.xml><?xml version="1.0" encoding="utf-8"?>
+<file path=ppt/slides/slide16.xml><?xml version="1.0" encoding="utf-8"?>
 <p:sld xmlns:a="http://schemas.openxmlformats.org/drawingml/2006/main" xmlns:r="http://schemas.openxmlformats.org/officeDocument/2006/relationships" xmlns:p="http://schemas.openxmlformats.org/presentationml/2006/main">
   <p:cSld>
     <p:spTree>
@@ -6457,7 +6319,7 @@
 </p:sld>
 </file>
 
-<file path=ppt/slides/slide15.xml><?xml version="1.0" encoding="utf-8"?>
+<file path=ppt/slides/slide17.xml><?xml version="1.0" encoding="utf-8"?>
 <p:sld xmlns:a="http://schemas.openxmlformats.org/drawingml/2006/main" xmlns:r="http://schemas.openxmlformats.org/officeDocument/2006/relationships" xmlns:p="http://schemas.openxmlformats.org/presentationml/2006/main">
   <p:cSld>
     <p:spTree>
@@ -6543,7 +6405,7 @@
 </p:sld>
 </file>
 
-<file path=ppt/slides/slide16.xml><?xml version="1.0" encoding="utf-8"?>
+<file path=ppt/slides/slide18.xml><?xml version="1.0" encoding="utf-8"?>
 <p:sld xmlns:a="http://schemas.openxmlformats.org/drawingml/2006/main" xmlns:r="http://schemas.openxmlformats.org/officeDocument/2006/relationships" xmlns:p="http://schemas.openxmlformats.org/presentationml/2006/main">
   <p:cSld>
     <p:spTree>
@@ -6629,7 +6491,7 @@
 </p:sld>
 </file>
 
-<file path=ppt/slides/slide17.xml><?xml version="1.0" encoding="utf-8"?>
+<file path=ppt/slides/slide19.xml><?xml version="1.0" encoding="utf-8"?>
 <p:sld xmlns:a="http://schemas.openxmlformats.org/drawingml/2006/main" xmlns:r="http://schemas.openxmlformats.org/officeDocument/2006/relationships" xmlns:p="http://schemas.openxmlformats.org/presentationml/2006/main">
   <p:cSld>
     <p:spTree>
@@ -6757,6 +6619,784 @@
           <p:cNvPr id="2" name="Title 1">
             <a:extLst>
               <a:ext uri="{FF2B5EF4-FFF2-40B4-BE49-F238E27FC236}">
+                <a16:creationId xmlns:a16="http://schemas.microsoft.com/office/drawing/2014/main" id="{43A12493-75ED-FFA9-A1BD-A09AEC623815}"/>
+              </a:ext>
+            </a:extLst>
+          </p:cNvPr>
+          <p:cNvSpPr>
+            <a:spLocks noGrp="1"/>
+          </p:cNvSpPr>
+          <p:nvPr>
+            <p:ph type="title"/>
+          </p:nvPr>
+        </p:nvSpPr>
+        <p:spPr/>
+        <p:txBody>
+          <a:bodyPr/>
+          <a:lstStyle/>
+          <a:p>
+            <a:r>
+              <a:rPr lang="en-US" dirty="0"/>
+              <a:t>What is a Large Language Model?</a:t>
+            </a:r>
+          </a:p>
+        </p:txBody>
+      </p:sp>
+      <p:sp>
+        <p:nvSpPr>
+          <p:cNvPr id="3" name="Content Placeholder 2">
+            <a:extLst>
+              <a:ext uri="{FF2B5EF4-FFF2-40B4-BE49-F238E27FC236}">
+                <a16:creationId xmlns:a16="http://schemas.microsoft.com/office/drawing/2014/main" id="{4C7102F1-33CC-09ED-19D1-63AD5315FDDF}"/>
+              </a:ext>
+            </a:extLst>
+          </p:cNvPr>
+          <p:cNvSpPr>
+            <a:spLocks noGrp="1"/>
+          </p:cNvSpPr>
+          <p:nvPr>
+            <p:ph idx="1"/>
+          </p:nvPr>
+        </p:nvSpPr>
+        <p:spPr/>
+        <p:txBody>
+          <a:bodyPr/>
+          <a:lstStyle/>
+          <a:p>
+            <a:pPr>
+              <a:buNone/>
+            </a:pPr>
+            <a:r>
+              <a:rPr lang="en-US" dirty="0"/>
+              <a:t>A </a:t>
+            </a:r>
+            <a:r>
+              <a:rPr lang="en-US" b="1" dirty="0"/>
+              <a:t>Large Language Model (LLM)</a:t>
+            </a:r>
+            <a:r>
+              <a:rPr lang="en-US" dirty="0"/>
+              <a:t> is an advanced artificial intelligence system trained on vast amounts of text data to understand, generate, and manipulate human language. These models use </a:t>
+            </a:r>
+            <a:r>
+              <a:rPr lang="en-US" b="1" dirty="0"/>
+              <a:t>deep learning</a:t>
+            </a:r>
+            <a:r>
+              <a:rPr lang="en-US" dirty="0"/>
+              <a:t>, particularly </a:t>
+            </a:r>
+            <a:r>
+              <a:rPr lang="en-US" b="1" dirty="0"/>
+              <a:t>transformers</a:t>
+            </a:r>
+            <a:r>
+              <a:rPr lang="en-US" dirty="0"/>
+              <a:t>, to predict and generate text in a coherent and context-aware manner.</a:t>
+            </a:r>
+          </a:p>
+          <a:p>
+            <a:pPr>
+              <a:buNone/>
+            </a:pPr>
+            <a:r>
+              <a:rPr lang="en-US" dirty="0"/>
+              <a:t>Key features:</a:t>
+            </a:r>
+          </a:p>
+          <a:p>
+            <a:pPr>
+              <a:buFont typeface="Arial" panose="020B0604020202020204" pitchFamily="34" charset="0"/>
+              <a:buChar char="•"/>
+            </a:pPr>
+            <a:r>
+              <a:rPr lang="en-US" dirty="0"/>
+              <a:t>Trained on billions of words from books, articles, and the internet.</a:t>
+            </a:r>
+          </a:p>
+          <a:p>
+            <a:pPr>
+              <a:buFont typeface="Arial" panose="020B0604020202020204" pitchFamily="34" charset="0"/>
+              <a:buChar char="•"/>
+            </a:pPr>
+            <a:r>
+              <a:rPr lang="en-US" dirty="0"/>
+              <a:t>Can perform tasks like translation, summarization, code generation, and answering questions.</a:t>
+            </a:r>
+          </a:p>
+          <a:p>
+            <a:pPr>
+              <a:buFont typeface="Arial" panose="020B0604020202020204" pitchFamily="34" charset="0"/>
+              <a:buChar char="•"/>
+            </a:pPr>
+            <a:r>
+              <a:rPr lang="en-US" dirty="0"/>
+              <a:t>Examples include </a:t>
+            </a:r>
+            <a:r>
+              <a:rPr lang="en-US" b="1" dirty="0"/>
+              <a:t>GPT-4, ChatGPT, BERT, </a:t>
+            </a:r>
+            <a:r>
+              <a:rPr lang="en-US" b="1" dirty="0" err="1"/>
+              <a:t>PaLM</a:t>
+            </a:r>
+            <a:r>
+              <a:rPr lang="en-US" b="1" dirty="0"/>
+              <a:t>, </a:t>
+            </a:r>
+            <a:r>
+              <a:rPr lang="en-US" b="1" dirty="0" err="1"/>
+              <a:t>LLaMA</a:t>
+            </a:r>
+            <a:r>
+              <a:rPr lang="en-US" b="1" dirty="0"/>
+              <a:t>, and Claude</a:t>
+            </a:r>
+            <a:r>
+              <a:rPr lang="en-US" dirty="0"/>
+              <a:t>.</a:t>
+            </a:r>
+          </a:p>
+          <a:p>
+            <a:r>
+              <a:rPr lang="en-US" dirty="0"/>
+              <a:t>LLMs power modern AI applications, including chatbots, virtual assistants, and content creation tools.</a:t>
+            </a:r>
+          </a:p>
+          <a:p>
+            <a:endParaRPr lang="en-US" dirty="0"/>
+          </a:p>
+          <a:p>
+            <a:endParaRPr lang="en-US" dirty="0"/>
+          </a:p>
+        </p:txBody>
+      </p:sp>
+    </p:spTree>
+    <p:extLst>
+      <p:ext uri="{BB962C8B-B14F-4D97-AF65-F5344CB8AC3E}">
+        <p14:creationId xmlns:p14="http://schemas.microsoft.com/office/powerpoint/2010/main" val="1939766790"/>
+      </p:ext>
+    </p:extLst>
+  </p:cSld>
+  <p:clrMapOvr>
+    <a:masterClrMapping/>
+  </p:clrMapOvr>
+</p:sld>
+</file>
+
+<file path=ppt/slides/slide3.xml><?xml version="1.0" encoding="utf-8"?>
+<p:sld xmlns:a="http://schemas.openxmlformats.org/drawingml/2006/main" xmlns:r="http://schemas.openxmlformats.org/officeDocument/2006/relationships" xmlns:p="http://schemas.openxmlformats.org/presentationml/2006/main">
+  <p:cSld>
+    <p:spTree>
+      <p:nvGrpSpPr>
+        <p:cNvPr id="1" name=""/>
+        <p:cNvGrpSpPr/>
+        <p:nvPr/>
+      </p:nvGrpSpPr>
+      <p:grpSpPr>
+        <a:xfrm>
+          <a:off x="0" y="0"/>
+          <a:ext cx="0" cy="0"/>
+          <a:chOff x="0" y="0"/>
+          <a:chExt cx="0" cy="0"/>
+        </a:xfrm>
+      </p:grpSpPr>
+      <p:sp>
+        <p:nvSpPr>
+          <p:cNvPr id="4" name="Title 3">
+            <a:extLst>
+              <a:ext uri="{FF2B5EF4-FFF2-40B4-BE49-F238E27FC236}">
+                <a16:creationId xmlns:a16="http://schemas.microsoft.com/office/drawing/2014/main" id="{0B0DDC81-A74C-861A-3FF8-DEFF3BE23C27}"/>
+              </a:ext>
+            </a:extLst>
+          </p:cNvPr>
+          <p:cNvSpPr>
+            <a:spLocks noGrp="1"/>
+          </p:cNvSpPr>
+          <p:nvPr>
+            <p:ph type="title"/>
+          </p:nvPr>
+        </p:nvSpPr>
+        <p:spPr/>
+        <p:txBody>
+          <a:bodyPr/>
+          <a:lstStyle/>
+          <a:p>
+            <a:r>
+              <a:rPr lang="en-US" dirty="0"/>
+              <a:t>Evolution of </a:t>
+            </a:r>
+            <a:r>
+              <a:rPr lang="en-US"/>
+              <a:t>Large Language Models</a:t>
+            </a:r>
+          </a:p>
+        </p:txBody>
+      </p:sp>
+      <p:sp>
+        <p:nvSpPr>
+          <p:cNvPr id="3" name="Content Placeholder 2">
+            <a:extLst>
+              <a:ext uri="{FF2B5EF4-FFF2-40B4-BE49-F238E27FC236}">
+                <a16:creationId xmlns:a16="http://schemas.microsoft.com/office/drawing/2014/main" id="{A41D86F4-2CDE-CB20-3664-2556C0F84D47}"/>
+              </a:ext>
+            </a:extLst>
+          </p:cNvPr>
+          <p:cNvSpPr>
+            <a:spLocks noGrp="1"/>
+          </p:cNvSpPr>
+          <p:nvPr>
+            <p:ph idx="1"/>
+          </p:nvPr>
+        </p:nvSpPr>
+        <p:spPr>
+          <a:xfrm>
+            <a:off x="838200" y="1706007"/>
+            <a:ext cx="4919133" cy="4991039"/>
+          </a:xfrm>
+        </p:spPr>
+        <p:txBody>
+          <a:bodyPr>
+            <a:normAutofit lnSpcReduction="10000"/>
+          </a:bodyPr>
+          <a:lstStyle/>
+          <a:p>
+            <a:pPr marL="0" marR="0">
+              <a:lnSpc>
+                <a:spcPct val="115000"/>
+              </a:lnSpc>
+              <a:spcBef>
+                <a:spcPts val="0"/>
+              </a:spcBef>
+              <a:spcAft>
+                <a:spcPts val="800"/>
+              </a:spcAft>
+              <a:buNone/>
+            </a:pPr>
+            <a:r>
+              <a:rPr lang="en-US" sz="1400" kern="100" dirty="0">
+                <a:effectLst/>
+                <a:latin typeface="Aptos" panose="020B0004020202020204" pitchFamily="34" charset="0"/>
+                <a:ea typeface="Aptos" panose="020B0004020202020204" pitchFamily="34" charset="0"/>
+                <a:cs typeface="Arial" panose="020B0604020202020204" pitchFamily="34" charset="0"/>
+              </a:rPr>
+              <a:t>The image is an </a:t>
+            </a:r>
+            <a:r>
+              <a:rPr lang="en-US" sz="1400" b="1" kern="100" dirty="0">
+                <a:effectLst/>
+                <a:latin typeface="Aptos" panose="020B0004020202020204" pitchFamily="34" charset="0"/>
+                <a:ea typeface="Aptos" panose="020B0004020202020204" pitchFamily="34" charset="0"/>
+                <a:cs typeface="Arial" panose="020B0604020202020204" pitchFamily="34" charset="0"/>
+              </a:rPr>
+              <a:t>evolutionary tree of natural language processing (NLP) models</a:t>
+            </a:r>
+            <a:r>
+              <a:rPr lang="en-US" sz="1400" kern="100" dirty="0">
+                <a:effectLst/>
+                <a:latin typeface="Aptos" panose="020B0004020202020204" pitchFamily="34" charset="0"/>
+                <a:ea typeface="Aptos" panose="020B0004020202020204" pitchFamily="34" charset="0"/>
+                <a:cs typeface="Arial" panose="020B0604020202020204" pitchFamily="34" charset="0"/>
+              </a:rPr>
+              <a:t>, showing their development from 2018 to 2023. It categorizes models into </a:t>
+            </a:r>
+            <a:r>
+              <a:rPr lang="en-US" sz="1400" b="1" kern="100" dirty="0">
+                <a:effectLst/>
+                <a:latin typeface="Aptos" panose="020B0004020202020204" pitchFamily="34" charset="0"/>
+                <a:ea typeface="Aptos" panose="020B0004020202020204" pitchFamily="34" charset="0"/>
+                <a:cs typeface="Arial" panose="020B0604020202020204" pitchFamily="34" charset="0"/>
+              </a:rPr>
+              <a:t>open-source (light color) and closed-source (darker color)</a:t>
+            </a:r>
+            <a:r>
+              <a:rPr lang="en-US" sz="1400" kern="100" dirty="0">
+                <a:effectLst/>
+                <a:latin typeface="Aptos" panose="020B0004020202020204" pitchFamily="34" charset="0"/>
+                <a:ea typeface="Aptos" panose="020B0004020202020204" pitchFamily="34" charset="0"/>
+                <a:cs typeface="Arial" panose="020B0604020202020204" pitchFamily="34" charset="0"/>
+              </a:rPr>
+              <a:t>, tracking major advancements in transformer-based architectures.</a:t>
+            </a:r>
+          </a:p>
+          <a:p>
+            <a:pPr marL="0" marR="0">
+              <a:lnSpc>
+                <a:spcPct val="115000"/>
+              </a:lnSpc>
+              <a:spcBef>
+                <a:spcPts val="0"/>
+              </a:spcBef>
+              <a:spcAft>
+                <a:spcPts val="800"/>
+              </a:spcAft>
+              <a:buNone/>
+            </a:pPr>
+            <a:r>
+              <a:rPr lang="en-US" sz="1400" kern="100" dirty="0">
+                <a:effectLst/>
+                <a:latin typeface="Aptos" panose="020B0004020202020204" pitchFamily="34" charset="0"/>
+                <a:ea typeface="Aptos" panose="020B0004020202020204" pitchFamily="34" charset="0"/>
+                <a:cs typeface="Arial" panose="020B0604020202020204" pitchFamily="34" charset="0"/>
+              </a:rPr>
+              <a:t>Key highlights:</a:t>
+            </a:r>
+          </a:p>
+          <a:p>
+            <a:pPr>
+              <a:lnSpc>
+                <a:spcPct val="115000"/>
+              </a:lnSpc>
+              <a:spcBef>
+                <a:spcPts val="0"/>
+              </a:spcBef>
+              <a:spcAft>
+                <a:spcPts val="800"/>
+              </a:spcAft>
+              <a:buSzPts val="1000"/>
+              <a:tabLst>
+                <a:tab pos="173038" algn="l"/>
+              </a:tabLst>
+            </a:pPr>
+            <a:r>
+              <a:rPr lang="en-US" sz="1400" b="1" kern="100" dirty="0">
+                <a:effectLst/>
+                <a:latin typeface="Aptos" panose="020B0004020202020204" pitchFamily="34" charset="0"/>
+                <a:ea typeface="Aptos" panose="020B0004020202020204" pitchFamily="34" charset="0"/>
+                <a:cs typeface="Arial" panose="020B0604020202020204" pitchFamily="34" charset="0"/>
+              </a:rPr>
+              <a:t>Early models (2018-2019):</a:t>
+            </a:r>
+            <a:r>
+              <a:rPr lang="en-US" sz="1400" kern="100" dirty="0">
+                <a:effectLst/>
+                <a:latin typeface="Aptos" panose="020B0004020202020204" pitchFamily="34" charset="0"/>
+                <a:ea typeface="Aptos" panose="020B0004020202020204" pitchFamily="34" charset="0"/>
+                <a:cs typeface="Arial" panose="020B0604020202020204" pitchFamily="34" charset="0"/>
+              </a:rPr>
+              <a:t> Word embeddings like </a:t>
+            </a:r>
+            <a:r>
+              <a:rPr lang="en-US" sz="1400" b="1" kern="100" dirty="0">
+                <a:effectLst/>
+                <a:latin typeface="Aptos" panose="020B0004020202020204" pitchFamily="34" charset="0"/>
+                <a:ea typeface="Aptos" panose="020B0004020202020204" pitchFamily="34" charset="0"/>
+                <a:cs typeface="Arial" panose="020B0604020202020204" pitchFamily="34" charset="0"/>
+              </a:rPr>
+              <a:t>Word2Vec, </a:t>
+            </a:r>
+            <a:r>
+              <a:rPr lang="en-US" sz="1400" b="1" kern="100" dirty="0" err="1">
+                <a:effectLst/>
+                <a:latin typeface="Aptos" panose="020B0004020202020204" pitchFamily="34" charset="0"/>
+                <a:ea typeface="Aptos" panose="020B0004020202020204" pitchFamily="34" charset="0"/>
+                <a:cs typeface="Arial" panose="020B0604020202020204" pitchFamily="34" charset="0"/>
+              </a:rPr>
+              <a:t>FastText</a:t>
+            </a:r>
+            <a:r>
+              <a:rPr lang="en-US" sz="1400" b="1" kern="100" dirty="0">
+                <a:effectLst/>
+                <a:latin typeface="Aptos" panose="020B0004020202020204" pitchFamily="34" charset="0"/>
+                <a:ea typeface="Aptos" panose="020B0004020202020204" pitchFamily="34" charset="0"/>
+                <a:cs typeface="Arial" panose="020B0604020202020204" pitchFamily="34" charset="0"/>
+              </a:rPr>
+              <a:t>, </a:t>
+            </a:r>
+            <a:r>
+              <a:rPr lang="en-US" sz="1400" b="1" kern="100" dirty="0" err="1">
+                <a:effectLst/>
+                <a:latin typeface="Aptos" panose="020B0004020202020204" pitchFamily="34" charset="0"/>
+                <a:ea typeface="Aptos" panose="020B0004020202020204" pitchFamily="34" charset="0"/>
+                <a:cs typeface="Arial" panose="020B0604020202020204" pitchFamily="34" charset="0"/>
+              </a:rPr>
+              <a:t>GloVe</a:t>
+            </a:r>
+            <a:r>
+              <a:rPr lang="en-US" sz="1400" kern="100" dirty="0">
+                <a:effectLst/>
+                <a:latin typeface="Aptos" panose="020B0004020202020204" pitchFamily="34" charset="0"/>
+                <a:ea typeface="Aptos" panose="020B0004020202020204" pitchFamily="34" charset="0"/>
+                <a:cs typeface="Arial" panose="020B0604020202020204" pitchFamily="34" charset="0"/>
+              </a:rPr>
+              <a:t>, evolving into transformer-based models like </a:t>
+            </a:r>
+            <a:r>
+              <a:rPr lang="en-US" sz="1400" b="1" kern="100" dirty="0">
+                <a:effectLst/>
+                <a:latin typeface="Aptos" panose="020B0004020202020204" pitchFamily="34" charset="0"/>
+                <a:ea typeface="Aptos" panose="020B0004020202020204" pitchFamily="34" charset="0"/>
+                <a:cs typeface="Arial" panose="020B0604020202020204" pitchFamily="34" charset="0"/>
+              </a:rPr>
+              <a:t>BERT, </a:t>
+            </a:r>
+            <a:r>
+              <a:rPr lang="en-US" sz="1400" b="1" kern="100" dirty="0" err="1">
+                <a:effectLst/>
+                <a:latin typeface="Aptos" panose="020B0004020202020204" pitchFamily="34" charset="0"/>
+                <a:ea typeface="Aptos" panose="020B0004020202020204" pitchFamily="34" charset="0"/>
+                <a:cs typeface="Arial" panose="020B0604020202020204" pitchFamily="34" charset="0"/>
+              </a:rPr>
+              <a:t>RoBERTa</a:t>
+            </a:r>
+            <a:r>
+              <a:rPr lang="en-US" sz="1400" b="1" kern="100" dirty="0">
+                <a:effectLst/>
+                <a:latin typeface="Aptos" panose="020B0004020202020204" pitchFamily="34" charset="0"/>
+                <a:ea typeface="Aptos" panose="020B0004020202020204" pitchFamily="34" charset="0"/>
+                <a:cs typeface="Arial" panose="020B0604020202020204" pitchFamily="34" charset="0"/>
+              </a:rPr>
+              <a:t>, and </a:t>
+            </a:r>
+            <a:r>
+              <a:rPr lang="en-US" sz="1400" b="1" kern="100" dirty="0" err="1">
+                <a:effectLst/>
+                <a:latin typeface="Aptos" panose="020B0004020202020204" pitchFamily="34" charset="0"/>
+                <a:ea typeface="Aptos" panose="020B0004020202020204" pitchFamily="34" charset="0"/>
+                <a:cs typeface="Arial" panose="020B0604020202020204" pitchFamily="34" charset="0"/>
+              </a:rPr>
+              <a:t>XLNet</a:t>
+            </a:r>
+            <a:r>
+              <a:rPr lang="en-US" sz="1400" kern="100" dirty="0">
+                <a:effectLst/>
+                <a:latin typeface="Aptos" panose="020B0004020202020204" pitchFamily="34" charset="0"/>
+                <a:ea typeface="Aptos" panose="020B0004020202020204" pitchFamily="34" charset="0"/>
+                <a:cs typeface="Arial" panose="020B0604020202020204" pitchFamily="34" charset="0"/>
+              </a:rPr>
+              <a:t>.</a:t>
+            </a:r>
+          </a:p>
+          <a:p>
+            <a:pPr>
+              <a:lnSpc>
+                <a:spcPct val="115000"/>
+              </a:lnSpc>
+              <a:spcBef>
+                <a:spcPts val="0"/>
+              </a:spcBef>
+              <a:spcAft>
+                <a:spcPts val="800"/>
+              </a:spcAft>
+              <a:buSzPts val="1000"/>
+              <a:tabLst>
+                <a:tab pos="173038" algn="l"/>
+              </a:tabLst>
+            </a:pPr>
+            <a:r>
+              <a:rPr lang="en-US" sz="1400" b="1" kern="100" dirty="0">
+                <a:effectLst/>
+                <a:latin typeface="Aptos" panose="020B0004020202020204" pitchFamily="34" charset="0"/>
+                <a:ea typeface="Aptos" panose="020B0004020202020204" pitchFamily="34" charset="0"/>
+                <a:cs typeface="Arial" panose="020B0604020202020204" pitchFamily="34" charset="0"/>
+              </a:rPr>
+              <a:t>Growth in 2020-2021:</a:t>
+            </a:r>
+            <a:r>
+              <a:rPr lang="en-US" sz="1400" kern="100" dirty="0">
+                <a:effectLst/>
+                <a:latin typeface="Aptos" panose="020B0004020202020204" pitchFamily="34" charset="0"/>
+                <a:ea typeface="Aptos" panose="020B0004020202020204" pitchFamily="34" charset="0"/>
+                <a:cs typeface="Arial" panose="020B0604020202020204" pitchFamily="34" charset="0"/>
+              </a:rPr>
+              <a:t> Expansion into encoder-only (e.g., </a:t>
+            </a:r>
+            <a:r>
+              <a:rPr lang="en-US" sz="1400" b="1" kern="100" dirty="0">
+                <a:effectLst/>
+                <a:latin typeface="Aptos" panose="020B0004020202020204" pitchFamily="34" charset="0"/>
+                <a:ea typeface="Aptos" panose="020B0004020202020204" pitchFamily="34" charset="0"/>
+                <a:cs typeface="Arial" panose="020B0604020202020204" pitchFamily="34" charset="0"/>
+              </a:rPr>
+              <a:t>ELECTRA, ALBERT</a:t>
+            </a:r>
+            <a:r>
+              <a:rPr lang="en-US" sz="1400" kern="100" dirty="0">
+                <a:effectLst/>
+                <a:latin typeface="Aptos" panose="020B0004020202020204" pitchFamily="34" charset="0"/>
+                <a:ea typeface="Aptos" panose="020B0004020202020204" pitchFamily="34" charset="0"/>
+                <a:cs typeface="Arial" panose="020B0604020202020204" pitchFamily="34" charset="0"/>
+              </a:rPr>
+              <a:t>), encoder-decoder (e.g., </a:t>
+            </a:r>
+            <a:r>
+              <a:rPr lang="en-US" sz="1400" b="1" kern="100" dirty="0">
+                <a:effectLst/>
+                <a:latin typeface="Aptos" panose="020B0004020202020204" pitchFamily="34" charset="0"/>
+                <a:ea typeface="Aptos" panose="020B0004020202020204" pitchFamily="34" charset="0"/>
+                <a:cs typeface="Arial" panose="020B0604020202020204" pitchFamily="34" charset="0"/>
+              </a:rPr>
+              <a:t>T5, BART</a:t>
+            </a:r>
+            <a:r>
+              <a:rPr lang="en-US" sz="1400" kern="100" dirty="0">
+                <a:effectLst/>
+                <a:latin typeface="Aptos" panose="020B0004020202020204" pitchFamily="34" charset="0"/>
+                <a:ea typeface="Aptos" panose="020B0004020202020204" pitchFamily="34" charset="0"/>
+                <a:cs typeface="Arial" panose="020B0604020202020204" pitchFamily="34" charset="0"/>
+              </a:rPr>
+              <a:t>), and decoder-only models (</a:t>
+            </a:r>
+            <a:r>
+              <a:rPr lang="en-US" sz="1400" b="1" kern="100" dirty="0">
+                <a:effectLst/>
+                <a:latin typeface="Aptos" panose="020B0004020202020204" pitchFamily="34" charset="0"/>
+                <a:ea typeface="Aptos" panose="020B0004020202020204" pitchFamily="34" charset="0"/>
+                <a:cs typeface="Arial" panose="020B0604020202020204" pitchFamily="34" charset="0"/>
+              </a:rPr>
+              <a:t>GPT-2, GPT-3</a:t>
+            </a:r>
+            <a:r>
+              <a:rPr lang="en-US" sz="1400" kern="100" dirty="0">
+                <a:effectLst/>
+                <a:latin typeface="Aptos" panose="020B0004020202020204" pitchFamily="34" charset="0"/>
+                <a:ea typeface="Aptos" panose="020B0004020202020204" pitchFamily="34" charset="0"/>
+                <a:cs typeface="Arial" panose="020B0604020202020204" pitchFamily="34" charset="0"/>
+              </a:rPr>
+              <a:t>).</a:t>
+            </a:r>
+          </a:p>
+          <a:p>
+            <a:pPr>
+              <a:lnSpc>
+                <a:spcPct val="115000"/>
+              </a:lnSpc>
+              <a:spcBef>
+                <a:spcPts val="0"/>
+              </a:spcBef>
+              <a:spcAft>
+                <a:spcPts val="800"/>
+              </a:spcAft>
+              <a:buSzPts val="1000"/>
+              <a:tabLst>
+                <a:tab pos="173038" algn="l"/>
+              </a:tabLst>
+            </a:pPr>
+            <a:r>
+              <a:rPr lang="en-US" sz="1400" b="1" kern="100" dirty="0">
+                <a:effectLst/>
+                <a:latin typeface="Aptos" panose="020B0004020202020204" pitchFamily="34" charset="0"/>
+                <a:ea typeface="Aptos" panose="020B0004020202020204" pitchFamily="34" charset="0"/>
+                <a:cs typeface="Arial" panose="020B0604020202020204" pitchFamily="34" charset="0"/>
+              </a:rPr>
+              <a:t>2022-2023 advancements:</a:t>
+            </a:r>
+            <a:r>
+              <a:rPr lang="en-US" sz="1400" kern="100" dirty="0">
+                <a:effectLst/>
+                <a:latin typeface="Aptos" panose="020B0004020202020204" pitchFamily="34" charset="0"/>
+                <a:ea typeface="Aptos" panose="020B0004020202020204" pitchFamily="34" charset="0"/>
+                <a:cs typeface="Arial" panose="020B0604020202020204" pitchFamily="34" charset="0"/>
+              </a:rPr>
+              <a:t> Introduction of </a:t>
+            </a:r>
+            <a:r>
+              <a:rPr lang="en-US" sz="1400" b="1" kern="100" dirty="0">
+                <a:effectLst/>
+                <a:latin typeface="Aptos" panose="020B0004020202020204" pitchFamily="34" charset="0"/>
+                <a:ea typeface="Aptos" panose="020B0004020202020204" pitchFamily="34" charset="0"/>
+                <a:cs typeface="Arial" panose="020B0604020202020204" pitchFamily="34" charset="0"/>
+              </a:rPr>
+              <a:t>ChatGPT, GPT-4, Claude, </a:t>
+            </a:r>
+            <a:r>
+              <a:rPr lang="en-US" sz="1400" b="1" kern="100" dirty="0" err="1">
+                <a:effectLst/>
+                <a:latin typeface="Aptos" panose="020B0004020202020204" pitchFamily="34" charset="0"/>
+                <a:ea typeface="Aptos" panose="020B0004020202020204" pitchFamily="34" charset="0"/>
+                <a:cs typeface="Arial" panose="020B0604020202020204" pitchFamily="34" charset="0"/>
+              </a:rPr>
+              <a:t>PaLM</a:t>
+            </a:r>
+            <a:r>
+              <a:rPr lang="en-US" sz="1400" b="1" kern="100" dirty="0">
+                <a:effectLst/>
+                <a:latin typeface="Aptos" panose="020B0004020202020204" pitchFamily="34" charset="0"/>
+                <a:ea typeface="Aptos" panose="020B0004020202020204" pitchFamily="34" charset="0"/>
+                <a:cs typeface="Arial" panose="020B0604020202020204" pitchFamily="34" charset="0"/>
+              </a:rPr>
+              <a:t>, </a:t>
+            </a:r>
+            <a:r>
+              <a:rPr lang="en-US" sz="1400" b="1" kern="100" dirty="0" err="1">
+                <a:effectLst/>
+                <a:latin typeface="Aptos" panose="020B0004020202020204" pitchFamily="34" charset="0"/>
+                <a:ea typeface="Aptos" panose="020B0004020202020204" pitchFamily="34" charset="0"/>
+                <a:cs typeface="Arial" panose="020B0604020202020204" pitchFamily="34" charset="0"/>
+              </a:rPr>
+              <a:t>LLaMA</a:t>
+            </a:r>
+            <a:r>
+              <a:rPr lang="en-US" sz="1400" b="1" kern="100" dirty="0">
+                <a:effectLst/>
+                <a:latin typeface="Aptos" panose="020B0004020202020204" pitchFamily="34" charset="0"/>
+                <a:ea typeface="Aptos" panose="020B0004020202020204" pitchFamily="34" charset="0"/>
+                <a:cs typeface="Arial" panose="020B0604020202020204" pitchFamily="34" charset="0"/>
+              </a:rPr>
+              <a:t>, Bard, BLOOM, and more</a:t>
+            </a:r>
+            <a:r>
+              <a:rPr lang="en-US" sz="1400" kern="100" dirty="0">
+                <a:effectLst/>
+                <a:latin typeface="Aptos" panose="020B0004020202020204" pitchFamily="34" charset="0"/>
+                <a:ea typeface="Aptos" panose="020B0004020202020204" pitchFamily="34" charset="0"/>
+                <a:cs typeface="Arial" panose="020B0604020202020204" pitchFamily="34" charset="0"/>
+              </a:rPr>
+              <a:t>, reflecting both </a:t>
+            </a:r>
+            <a:r>
+              <a:rPr lang="en-US" sz="1400" b="1" kern="100" dirty="0">
+                <a:effectLst/>
+                <a:latin typeface="Aptos" panose="020B0004020202020204" pitchFamily="34" charset="0"/>
+                <a:ea typeface="Aptos" panose="020B0004020202020204" pitchFamily="34" charset="0"/>
+                <a:cs typeface="Arial" panose="020B0604020202020204" pitchFamily="34" charset="0"/>
+              </a:rPr>
+              <a:t>research-driven (open-source) and commercial (closed-source) efforts</a:t>
+            </a:r>
+            <a:r>
+              <a:rPr lang="en-US" sz="1400" kern="100" dirty="0">
+                <a:effectLst/>
+                <a:latin typeface="Aptos" panose="020B0004020202020204" pitchFamily="34" charset="0"/>
+                <a:ea typeface="Aptos" panose="020B0004020202020204" pitchFamily="34" charset="0"/>
+                <a:cs typeface="Arial" panose="020B0604020202020204" pitchFamily="34" charset="0"/>
+              </a:rPr>
+              <a:t>.</a:t>
+            </a:r>
+          </a:p>
+          <a:p>
+            <a:pPr marL="0" marR="0">
+              <a:lnSpc>
+                <a:spcPct val="115000"/>
+              </a:lnSpc>
+              <a:spcBef>
+                <a:spcPts val="0"/>
+              </a:spcBef>
+              <a:spcAft>
+                <a:spcPts val="800"/>
+              </a:spcAft>
+              <a:buNone/>
+            </a:pPr>
+            <a:r>
+              <a:rPr lang="en-US" sz="1400" kern="100" dirty="0">
+                <a:effectLst/>
+                <a:latin typeface="Aptos" panose="020B0004020202020204" pitchFamily="34" charset="0"/>
+                <a:ea typeface="Aptos" panose="020B0004020202020204" pitchFamily="34" charset="0"/>
+                <a:cs typeface="Arial" panose="020B0604020202020204" pitchFamily="34" charset="0"/>
+              </a:rPr>
+              <a:t>The diagram illustrates the competition and innovation between </a:t>
+            </a:r>
+            <a:r>
+              <a:rPr lang="en-US" sz="1400" b="1" kern="100" dirty="0">
+                <a:effectLst/>
+                <a:latin typeface="Aptos" panose="020B0004020202020204" pitchFamily="34" charset="0"/>
+                <a:ea typeface="Aptos" panose="020B0004020202020204" pitchFamily="34" charset="0"/>
+                <a:cs typeface="Arial" panose="020B0604020202020204" pitchFamily="34" charset="0"/>
+              </a:rPr>
+              <a:t>Google, OpenAI, Meta, AI21 Labs, and Anthropic</a:t>
+            </a:r>
+            <a:r>
+              <a:rPr lang="en-US" sz="1400" kern="100" dirty="0">
+                <a:effectLst/>
+                <a:latin typeface="Aptos" panose="020B0004020202020204" pitchFamily="34" charset="0"/>
+                <a:ea typeface="Aptos" panose="020B0004020202020204" pitchFamily="34" charset="0"/>
+                <a:cs typeface="Arial" panose="020B0604020202020204" pitchFamily="34" charset="0"/>
+              </a:rPr>
+              <a:t>, among others.</a:t>
+            </a:r>
+          </a:p>
+          <a:p>
+            <a:pPr>
+              <a:spcBef>
+                <a:spcPts val="0"/>
+              </a:spcBef>
+            </a:pPr>
+            <a:endParaRPr lang="en-US" sz="1400" dirty="0"/>
+          </a:p>
+        </p:txBody>
+      </p:sp>
+      <p:pic>
+        <p:nvPicPr>
+          <p:cNvPr id="2050" name="Picture 2">
+            <a:extLst>
+              <a:ext uri="{FF2B5EF4-FFF2-40B4-BE49-F238E27FC236}">
+                <a16:creationId xmlns:a16="http://schemas.microsoft.com/office/drawing/2014/main" id="{804C5AFC-2370-82B7-38A0-7C05C6C3769B}"/>
+              </a:ext>
+            </a:extLst>
+          </p:cNvPr>
+          <p:cNvPicPr>
+            <a:picLocks noChangeAspect="1" noChangeArrowheads="1"/>
+          </p:cNvPicPr>
+          <p:nvPr/>
+        </p:nvPicPr>
+        <p:blipFill>
+          <a:blip r:embed="rId2">
+            <a:extLst>
+              <a:ext uri="{28A0092B-C50C-407E-A947-70E740481C1C}">
+                <a14:useLocalDpi xmlns:a14="http://schemas.microsoft.com/office/drawing/2010/main" val="0"/>
+              </a:ext>
+            </a:extLst>
+          </a:blip>
+          <a:srcRect/>
+          <a:stretch>
+            <a:fillRect/>
+          </a:stretch>
+        </p:blipFill>
+        <p:spPr bwMode="auto">
+          <a:xfrm>
+            <a:off x="6096000" y="1706007"/>
+            <a:ext cx="5987627" cy="4710986"/>
+          </a:xfrm>
+          <a:prstGeom prst="rect">
+            <a:avLst/>
+          </a:prstGeom>
+          <a:noFill/>
+          <a:extLst>
+            <a:ext uri="{909E8E84-426E-40DD-AFC4-6F175D3DCCD1}">
+              <a14:hiddenFill xmlns:a14="http://schemas.microsoft.com/office/drawing/2010/main">
+                <a:solidFill>
+                  <a:srgbClr val="FFFFFF"/>
+                </a:solidFill>
+              </a14:hiddenFill>
+            </a:ext>
+          </a:extLst>
+        </p:spPr>
+      </p:pic>
+    </p:spTree>
+    <p:extLst>
+      <p:ext uri="{BB962C8B-B14F-4D97-AF65-F5344CB8AC3E}">
+        <p14:creationId xmlns:p14="http://schemas.microsoft.com/office/powerpoint/2010/main" val="3385747305"/>
+      </p:ext>
+    </p:extLst>
+  </p:cSld>
+  <p:clrMapOvr>
+    <a:masterClrMapping/>
+  </p:clrMapOvr>
+</p:sld>
+</file>
+
+<file path=ppt/slides/slide4.xml><?xml version="1.0" encoding="utf-8"?>
+<p:sld xmlns:a="http://schemas.openxmlformats.org/drawingml/2006/main" xmlns:r="http://schemas.openxmlformats.org/officeDocument/2006/relationships" xmlns:p="http://schemas.openxmlformats.org/presentationml/2006/main">
+  <p:cSld>
+    <p:spTree>
+      <p:nvGrpSpPr>
+        <p:cNvPr id="1" name=""/>
+        <p:cNvGrpSpPr/>
+        <p:nvPr/>
+      </p:nvGrpSpPr>
+      <p:grpSpPr>
+        <a:xfrm>
+          <a:off x="0" y="0"/>
+          <a:ext cx="0" cy="0"/>
+          <a:chOff x="0" y="0"/>
+          <a:chExt cx="0" cy="0"/>
+        </a:xfrm>
+      </p:grpSpPr>
+      <p:sp>
+        <p:nvSpPr>
+          <p:cNvPr id="2" name="Title 1">
+            <a:extLst>
+              <a:ext uri="{FF2B5EF4-FFF2-40B4-BE49-F238E27FC236}">
                 <a16:creationId xmlns:a16="http://schemas.microsoft.com/office/drawing/2014/main" id="{B641E847-78EB-D12D-1289-076C03040899}"/>
               </a:ext>
             </a:extLst>
@@ -6849,7 +7489,7 @@
 </p:sld>
 </file>
 
-<file path=ppt/slides/slide3.xml><?xml version="1.0" encoding="utf-8"?>
+<file path=ppt/slides/slide5.xml><?xml version="1.0" encoding="utf-8"?>
 <p:sld xmlns:a="http://schemas.openxmlformats.org/drawingml/2006/main" xmlns:r="http://schemas.openxmlformats.org/officeDocument/2006/relationships" xmlns:p="http://schemas.openxmlformats.org/presentationml/2006/main">
   <p:cSld>
     <p:spTree>
@@ -7143,7 +7783,7 @@
 </p:sld>
 </file>
 
-<file path=ppt/slides/slide4.xml><?xml version="1.0" encoding="utf-8"?>
+<file path=ppt/slides/slide6.xml><?xml version="1.0" encoding="utf-8"?>
 <p:sld xmlns:a="http://schemas.openxmlformats.org/drawingml/2006/main" xmlns:r="http://schemas.openxmlformats.org/officeDocument/2006/relationships" xmlns:p="http://schemas.openxmlformats.org/presentationml/2006/main">
   <p:cSld>
     <p:spTree>
@@ -7423,7 +8063,7 @@
 </p:sld>
 </file>
 
-<file path=ppt/slides/slide5.xml><?xml version="1.0" encoding="utf-8"?>
+<file path=ppt/slides/slide7.xml><?xml version="1.0" encoding="utf-8"?>
 <p:sld xmlns:a="http://schemas.openxmlformats.org/drawingml/2006/main" xmlns:r="http://schemas.openxmlformats.org/officeDocument/2006/relationships" xmlns:p="http://schemas.openxmlformats.org/presentationml/2006/main">
   <p:cSld>
     <p:spTree>
@@ -7860,7 +8500,7 @@
 </p:sld>
 </file>
 
-<file path=ppt/slides/slide6.xml><?xml version="1.0" encoding="utf-8"?>
+<file path=ppt/slides/slide8.xml><?xml version="1.0" encoding="utf-8"?>
 <p:sld xmlns:a="http://schemas.openxmlformats.org/drawingml/2006/main" xmlns:r="http://schemas.openxmlformats.org/officeDocument/2006/relationships" xmlns:p="http://schemas.openxmlformats.org/presentationml/2006/main">
   <p:cSld>
     <p:spTree>
@@ -8126,7 +8766,7 @@
 </p:sld>
 </file>
 
-<file path=ppt/slides/slide7.xml><?xml version="1.0" encoding="utf-8"?>
+<file path=ppt/slides/slide9.xml><?xml version="1.0" encoding="utf-8"?>
 <p:sld xmlns:a="http://schemas.openxmlformats.org/drawingml/2006/main" xmlns:r="http://schemas.openxmlformats.org/officeDocument/2006/relationships" xmlns:p="http://schemas.openxmlformats.org/presentationml/2006/main">
   <p:cSld>
     <p:spTree>
@@ -8523,430 +9163,6 @@
     <p:extLst>
       <p:ext uri="{BB962C8B-B14F-4D97-AF65-F5344CB8AC3E}">
         <p14:creationId xmlns:p14="http://schemas.microsoft.com/office/powerpoint/2010/main" val="1157240725"/>
-      </p:ext>
-    </p:extLst>
-  </p:cSld>
-  <p:clrMapOvr>
-    <a:masterClrMapping/>
-  </p:clrMapOvr>
-</p:sld>
-</file>
-
-<file path=ppt/slides/slide8.xml><?xml version="1.0" encoding="utf-8"?>
-<p:sld xmlns:a="http://schemas.openxmlformats.org/drawingml/2006/main" xmlns:r="http://schemas.openxmlformats.org/officeDocument/2006/relationships" xmlns:p="http://schemas.openxmlformats.org/presentationml/2006/main">
-  <p:cSld>
-    <p:spTree>
-      <p:nvGrpSpPr>
-        <p:cNvPr id="1" name="">
-          <a:extLst>
-            <a:ext uri="{FF2B5EF4-FFF2-40B4-BE49-F238E27FC236}">
-              <a16:creationId xmlns:a16="http://schemas.microsoft.com/office/drawing/2014/main" id="{F9B0DD7F-7DC3-8CC9-C0F0-1647D96B8866}"/>
-            </a:ext>
-          </a:extLst>
-        </p:cNvPr>
-        <p:cNvGrpSpPr/>
-        <p:nvPr/>
-      </p:nvGrpSpPr>
-      <p:grpSpPr>
-        <a:xfrm>
-          <a:off x="0" y="0"/>
-          <a:ext cx="0" cy="0"/>
-          <a:chOff x="0" y="0"/>
-          <a:chExt cx="0" cy="0"/>
-        </a:xfrm>
-      </p:grpSpPr>
-      <p:sp>
-        <p:nvSpPr>
-          <p:cNvPr id="2" name="Title 1">
-            <a:extLst>
-              <a:ext uri="{FF2B5EF4-FFF2-40B4-BE49-F238E27FC236}">
-                <a16:creationId xmlns:a16="http://schemas.microsoft.com/office/drawing/2014/main" id="{51944489-C96E-64DA-01C7-8148E0CFAA33}"/>
-              </a:ext>
-            </a:extLst>
-          </p:cNvPr>
-          <p:cNvSpPr>
-            <a:spLocks noGrp="1"/>
-          </p:cNvSpPr>
-          <p:nvPr>
-            <p:ph type="title"/>
-          </p:nvPr>
-        </p:nvSpPr>
-        <p:spPr/>
-        <p:txBody>
-          <a:bodyPr/>
-          <a:lstStyle/>
-          <a:p>
-            <a:endParaRPr lang="en-US"/>
-          </a:p>
-        </p:txBody>
-      </p:sp>
-      <p:sp>
-        <p:nvSpPr>
-          <p:cNvPr id="3" name="Content Placeholder 2">
-            <a:extLst>
-              <a:ext uri="{FF2B5EF4-FFF2-40B4-BE49-F238E27FC236}">
-                <a16:creationId xmlns:a16="http://schemas.microsoft.com/office/drawing/2014/main" id="{891DCAA0-5A3F-EEBE-021E-8D9D6B92B64A}"/>
-              </a:ext>
-            </a:extLst>
-          </p:cNvPr>
-          <p:cNvSpPr>
-            <a:spLocks noGrp="1"/>
-          </p:cNvSpPr>
-          <p:nvPr>
-            <p:ph idx="1"/>
-          </p:nvPr>
-        </p:nvSpPr>
-        <p:spPr/>
-        <p:txBody>
-          <a:bodyPr vert="horz" lIns="91440" tIns="45720" rIns="91440" bIns="45720" rtlCol="0" anchor="t">
-            <a:normAutofit/>
-          </a:bodyPr>
-          <a:lstStyle/>
-          <a:p>
-            <a:r>
-              <a:rPr lang="en-US" sz="1400" dirty="0">
-                <a:solidFill>
-                  <a:srgbClr val="222222"/>
-                </a:solidFill>
-                <a:latin typeface="Helvetica"/>
-                <a:cs typeface="Helvetica"/>
-              </a:rPr>
-              <a:t>By design, a RNN takes two inputs at each time step: an input (in the case of the encoder, one word from the input sentence), and a hidden state. </a:t>
-            </a:r>
-            <a:endParaRPr lang="en-US" dirty="0">
-              <a:solidFill>
-                <a:srgbClr val="000000"/>
-              </a:solidFill>
-              <a:latin typeface="Calibri" panose="020F0502020204030204"/>
-              <a:ea typeface="Calibri" panose="020F0502020204030204"/>
-              <a:cs typeface="Calibri" panose="020F0502020204030204"/>
-            </a:endParaRPr>
-          </a:p>
-          <a:p>
-            <a:r>
-              <a:rPr lang="en-US" sz="1400" dirty="0">
-                <a:solidFill>
-                  <a:srgbClr val="222222"/>
-                </a:solidFill>
-                <a:latin typeface="Helvetica"/>
-                <a:cs typeface="Helvetica"/>
-              </a:rPr>
-              <a:t>The word, however, needs to be represented by a vector. </a:t>
-            </a:r>
-            <a:endParaRPr lang="en-US" dirty="0">
-              <a:solidFill>
-                <a:srgbClr val="000000"/>
-              </a:solidFill>
-              <a:latin typeface="Calibri" panose="020F0502020204030204"/>
-              <a:ea typeface="Calibri"/>
-              <a:cs typeface="Calibri"/>
-            </a:endParaRPr>
-          </a:p>
-          <a:p>
-            <a:r>
-              <a:rPr lang="en-US" sz="1400" dirty="0">
-                <a:solidFill>
-                  <a:srgbClr val="222222"/>
-                </a:solidFill>
-                <a:latin typeface="Helvetica"/>
-                <a:cs typeface="Helvetica"/>
-              </a:rPr>
-              <a:t>To transform a word into a vector, we turn to the class of methods called “</a:t>
-            </a:r>
-            <a:r>
-              <a:rPr lang="en-US" sz="1400" dirty="0">
-                <a:solidFill>
-                  <a:srgbClr val="4183C4"/>
-                </a:solidFill>
-                <a:latin typeface="Helvetica"/>
-                <a:cs typeface="Helvetica"/>
-                <a:hlinkClick r:id="rId2"/>
-              </a:rPr>
-              <a:t>word embedding</a:t>
-            </a:r>
-            <a:r>
-              <a:rPr lang="en-US" sz="1400" dirty="0">
-                <a:solidFill>
-                  <a:srgbClr val="222222"/>
-                </a:solidFill>
-                <a:latin typeface="Helvetica"/>
-                <a:cs typeface="Helvetica"/>
-              </a:rPr>
-              <a:t>” algorithms. </a:t>
-            </a:r>
-            <a:endParaRPr lang="en-US">
-              <a:solidFill>
-                <a:srgbClr val="000000"/>
-              </a:solidFill>
-              <a:latin typeface="Calibri" panose="020F0502020204030204"/>
-              <a:ea typeface="Calibri"/>
-              <a:cs typeface="Calibri"/>
-            </a:endParaRPr>
-          </a:p>
-          <a:p>
-            <a:r>
-              <a:rPr lang="en-US" sz="1400" dirty="0">
-                <a:solidFill>
-                  <a:srgbClr val="222222"/>
-                </a:solidFill>
-                <a:latin typeface="Helvetica"/>
-                <a:cs typeface="Helvetica"/>
-              </a:rPr>
-              <a:t>These turn words into vector spaces that capture a lot of the meaning/semantic information of the words (e.g. </a:t>
-            </a:r>
-            <a:r>
-              <a:rPr lang="en-US" sz="1400" dirty="0">
-                <a:solidFill>
-                  <a:srgbClr val="4183C4"/>
-                </a:solidFill>
-                <a:latin typeface="Helvetica"/>
-                <a:cs typeface="Helvetica"/>
-                <a:hlinkClick r:id="rId3"/>
-              </a:rPr>
-              <a:t>king - man + woman = queen</a:t>
-            </a:r>
-            <a:r>
-              <a:rPr lang="en-US" sz="1400" dirty="0">
-                <a:solidFill>
-                  <a:srgbClr val="222222"/>
-                </a:solidFill>
-                <a:latin typeface="Helvetica"/>
-                <a:cs typeface="Helvetica"/>
-              </a:rPr>
-              <a:t>).</a:t>
-            </a:r>
-            <a:endParaRPr lang="en-US">
-              <a:ea typeface="Calibri"/>
-              <a:cs typeface="Calibri"/>
-            </a:endParaRPr>
-          </a:p>
-        </p:txBody>
-      </p:sp>
-      <p:pic>
-        <p:nvPicPr>
-          <p:cNvPr id="4" name="Picture 3" descr="A group of numbers in green squares&#10;&#10;AI-generated content may be incorrect.">
-            <a:extLst>
-              <a:ext uri="{FF2B5EF4-FFF2-40B4-BE49-F238E27FC236}">
-                <a16:creationId xmlns:a16="http://schemas.microsoft.com/office/drawing/2014/main" id="{76C95208-81C7-5CF3-E454-2C18A3F25FC0}"/>
-              </a:ext>
-            </a:extLst>
-          </p:cNvPr>
-          <p:cNvPicPr>
-            <a:picLocks noChangeAspect="1"/>
-          </p:cNvPicPr>
-          <p:nvPr/>
-        </p:nvPicPr>
-        <p:blipFill>
-          <a:blip r:embed="rId4"/>
-          <a:stretch>
-            <a:fillRect/>
-          </a:stretch>
-        </p:blipFill>
-        <p:spPr>
-          <a:xfrm>
-            <a:off x="3227374" y="3332201"/>
-            <a:ext cx="5750737" cy="1879438"/>
-          </a:xfrm>
-          <a:prstGeom prst="rect">
-            <a:avLst/>
-          </a:prstGeom>
-        </p:spPr>
-      </p:pic>
-      <p:sp>
-        <p:nvSpPr>
-          <p:cNvPr id="5" name="TextBox 4">
-            <a:extLst>
-              <a:ext uri="{FF2B5EF4-FFF2-40B4-BE49-F238E27FC236}">
-                <a16:creationId xmlns:a16="http://schemas.microsoft.com/office/drawing/2014/main" id="{0EE62ADA-E312-FE03-63AA-32558CEA7F2B}"/>
-              </a:ext>
-            </a:extLst>
-          </p:cNvPr>
-          <p:cNvSpPr txBox="1"/>
-          <p:nvPr/>
-        </p:nvSpPr>
-        <p:spPr>
-          <a:xfrm>
-            <a:off x="2687904" y="5837055"/>
-            <a:ext cx="7679341" cy="646331"/>
-          </a:xfrm>
-          <a:prstGeom prst="rect">
-            <a:avLst/>
-          </a:prstGeom>
-          <a:noFill/>
-        </p:spPr>
-        <p:txBody>
-          <a:bodyPr rot="0" spcFirstLastPara="0" vertOverflow="overflow" horzOverflow="overflow" vert="horz" wrap="square" lIns="91440" tIns="45720" rIns="91440" bIns="45720" numCol="1" spcCol="0" rtlCol="0" fromWordArt="0" anchor="t" anchorCtr="0" forceAA="0" compatLnSpc="1">
-            <a:prstTxWarp prst="textNoShape">
-              <a:avLst/>
-            </a:prstTxWarp>
-            <a:spAutoFit/>
-          </a:bodyPr>
-          <a:lstStyle/>
-          <a:p>
-            <a:r>
-              <a:rPr lang="en-US" sz="1200" dirty="0">
-                <a:solidFill>
-                  <a:srgbClr val="999999"/>
-                </a:solidFill>
-                <a:highlight>
-                  <a:srgbClr val="FFFFFF"/>
-                </a:highlight>
-                <a:latin typeface="Helvetica"/>
-                <a:cs typeface="Helvetica"/>
-              </a:rPr>
-              <a:t>We need to turn the input words into vectors before processing them. That transformation is done using a </a:t>
-            </a:r>
-            <a:r>
-              <a:rPr lang="en-US" sz="1200" dirty="0">
-                <a:solidFill>
-                  <a:srgbClr val="4183C4"/>
-                </a:solidFill>
-                <a:highlight>
-                  <a:srgbClr val="FFFFFF"/>
-                </a:highlight>
-                <a:latin typeface="Helvetica"/>
-                <a:cs typeface="Helvetica"/>
-                <a:hlinkClick r:id="rId5"/>
-              </a:rPr>
-              <a:t>word embedding</a:t>
-            </a:r>
-            <a:r>
-              <a:rPr lang="en-US" sz="1200" dirty="0">
-                <a:solidFill>
-                  <a:srgbClr val="999999"/>
-                </a:solidFill>
-                <a:highlight>
-                  <a:srgbClr val="FFFFFF"/>
-                </a:highlight>
-                <a:latin typeface="Helvetica"/>
-                <a:cs typeface="Helvetica"/>
-              </a:rPr>
-              <a:t> algorithm. We can use </a:t>
-            </a:r>
-            <a:r>
-              <a:rPr lang="en-US" sz="1200" dirty="0">
-                <a:solidFill>
-                  <a:srgbClr val="4183C4"/>
-                </a:solidFill>
-                <a:highlight>
-                  <a:srgbClr val="FFFFFF"/>
-                </a:highlight>
-                <a:latin typeface="Helvetica"/>
-                <a:cs typeface="Helvetica"/>
-                <a:hlinkClick r:id="rId6"/>
-              </a:rPr>
-              <a:t>pre-trained embeddings</a:t>
-            </a:r>
-            <a:r>
-              <a:rPr lang="en-US" sz="1200" dirty="0">
-                <a:solidFill>
-                  <a:srgbClr val="999999"/>
-                </a:solidFill>
-                <a:highlight>
-                  <a:srgbClr val="FFFFFF"/>
-                </a:highlight>
-                <a:latin typeface="Helvetica"/>
-                <a:cs typeface="Helvetica"/>
-              </a:rPr>
-              <a:t> or train our own embedding on our dataset. Embedding vectors of size 200 or 300 are typical, we're showing a vector of size four for simplicity.</a:t>
-            </a:r>
-            <a:endParaRPr lang="en-US" sz="1200" dirty="0">
-              <a:ea typeface="Calibri"/>
-              <a:cs typeface="Calibri"/>
-            </a:endParaRPr>
-          </a:p>
-        </p:txBody>
-      </p:sp>
-    </p:spTree>
-    <p:extLst>
-      <p:ext uri="{BB962C8B-B14F-4D97-AF65-F5344CB8AC3E}">
-        <p14:creationId xmlns:p14="http://schemas.microsoft.com/office/powerpoint/2010/main" val="2617340595"/>
-      </p:ext>
-    </p:extLst>
-  </p:cSld>
-  <p:clrMapOvr>
-    <a:masterClrMapping/>
-  </p:clrMapOvr>
-</p:sld>
-</file>
-
-<file path=ppt/slides/slide9.xml><?xml version="1.0" encoding="utf-8"?>
-<p:sld xmlns:a="http://schemas.openxmlformats.org/drawingml/2006/main" xmlns:r="http://schemas.openxmlformats.org/officeDocument/2006/relationships" xmlns:p="http://schemas.openxmlformats.org/presentationml/2006/main">
-  <p:cSld>
-    <p:spTree>
-      <p:nvGrpSpPr>
-        <p:cNvPr id="1" name="">
-          <a:extLst>
-            <a:ext uri="{FF2B5EF4-FFF2-40B4-BE49-F238E27FC236}">
-              <a16:creationId xmlns:a16="http://schemas.microsoft.com/office/drawing/2014/main" id="{EE106451-7A3A-9597-7660-A77AE45B0304}"/>
-            </a:ext>
-          </a:extLst>
-        </p:cNvPr>
-        <p:cNvGrpSpPr/>
-        <p:nvPr/>
-      </p:nvGrpSpPr>
-      <p:grpSpPr>
-        <a:xfrm>
-          <a:off x="0" y="0"/>
-          <a:ext cx="0" cy="0"/>
-          <a:chOff x="0" y="0"/>
-          <a:chExt cx="0" cy="0"/>
-        </a:xfrm>
-      </p:grpSpPr>
-      <p:sp>
-        <p:nvSpPr>
-          <p:cNvPr id="2" name="Title 1">
-            <a:extLst>
-              <a:ext uri="{FF2B5EF4-FFF2-40B4-BE49-F238E27FC236}">
-                <a16:creationId xmlns:a16="http://schemas.microsoft.com/office/drawing/2014/main" id="{652E3FBD-A8EC-A535-0F43-B16F175A37BE}"/>
-              </a:ext>
-            </a:extLst>
-          </p:cNvPr>
-          <p:cNvSpPr>
-            <a:spLocks noGrp="1"/>
-          </p:cNvSpPr>
-          <p:nvPr>
-            <p:ph type="title"/>
-          </p:nvPr>
-        </p:nvSpPr>
-        <p:spPr/>
-        <p:txBody>
-          <a:bodyPr/>
-          <a:lstStyle/>
-          <a:p>
-            <a:endParaRPr lang="en-US"/>
-          </a:p>
-        </p:txBody>
-      </p:sp>
-      <p:sp>
-        <p:nvSpPr>
-          <p:cNvPr id="3" name="Content Placeholder 2">
-            <a:extLst>
-              <a:ext uri="{FF2B5EF4-FFF2-40B4-BE49-F238E27FC236}">
-                <a16:creationId xmlns:a16="http://schemas.microsoft.com/office/drawing/2014/main" id="{ADF9EE4F-F63A-9666-F6DF-B1E9BFF482B4}"/>
-              </a:ext>
-            </a:extLst>
-          </p:cNvPr>
-          <p:cNvSpPr>
-            <a:spLocks noGrp="1"/>
-          </p:cNvSpPr>
-          <p:nvPr>
-            <p:ph idx="1"/>
-          </p:nvPr>
-        </p:nvSpPr>
-        <p:spPr/>
-        <p:txBody>
-          <a:bodyPr/>
-          <a:lstStyle/>
-          <a:p>
-            <a:endParaRPr lang="en-US"/>
-          </a:p>
-        </p:txBody>
-      </p:sp>
-    </p:spTree>
-    <p:extLst>
-      <p:ext uri="{BB962C8B-B14F-4D97-AF65-F5344CB8AC3E}">
-        <p14:creationId xmlns:p14="http://schemas.microsoft.com/office/powerpoint/2010/main" val="2675381745"/>
       </p:ext>
     </p:extLst>
   </p:cSld>

</xml_diff>